<commit_message>
Slide bảo vệ bản rút gọn: cập nhật deck và script dựng
Co-Authored-By: Claude Opus 5.5 <noreply@anthropic.com>
</commit_message>
<xml_diff>
--- a/slides/LUAN_VAN_SLIDE_BAO_VE_CONCISE.pptx
+++ b/slides/LUAN_VAN_SLIDE_BAO_VE_CONCISE.pptx
@@ -15504,8 +15504,8 @@
         </p:nvSpPr>
         <p:spPr>
           <a:xfrm>
-            <a:off x="502920" y="932688"/>
-            <a:ext cx="8138160" cy="566928"/>
+            <a:off x="502920" y="841248"/>
+            <a:ext cx="8138160" cy="438912"/>
           </a:xfrm>
           <a:prstGeom prst="rect">
             <a:avLst/>
@@ -15523,7 +15523,7 @@
               <a:buNone/>
             </a:pPr>
             <a:r>
-              <a:rPr lang="en-US" sz="1650" b="1" dirty="0">
+              <a:rPr lang="en-US" sz="1550" b="1" dirty="0">
                 <a:solidFill>
                   <a:srgbClr val="25194B"/>
                 </a:solidFill>
@@ -15531,50 +15531,38 @@
                 <a:ea typeface="Cambria" pitchFamily="34" charset="-122"/>
                 <a:cs typeface="Cambria" pitchFamily="34" charset="-120"/>
               </a:rPr>
-              <a:t>So với GRPO + SPICE, sau ACE điểm quan sát của cả 7 thước đo dựa trên câu tham chiếu đều tăng.</a:t>
-            </a:r>
-            <a:endParaRPr lang="en-US" sz="1650" dirty="0"/>
-          </a:p>
-        </p:txBody>
-      </p:sp>
-      <p:sp>
-        <p:nvSpPr>
-          <p:cNvPr id="5" name="Text 3"/>
-          <p:cNvSpPr/>
-          <p:nvPr/>
-        </p:nvSpPr>
-        <p:spPr>
-          <a:xfrm>
-            <a:off x="777240" y="1874520"/>
-            <a:ext cx="2057400" cy="502920"/>
-          </a:xfrm>
-          <a:prstGeom prst="rect">
-            <a:avLst/>
-          </a:prstGeom>
-          <a:noFill/>
-          <a:ln/>
-        </p:spPr>
-        <p:txBody>
-          <a:bodyPr wrap="square" lIns="0" tIns="0" rIns="0" bIns="0" rtlCol="0" anchor="ctr"/>
-          <a:lstStyle/>
-          <a:p>
-            <a:pPr algn="ctr" indent="0" marL="0">
-              <a:buNone/>
-            </a:pPr>
-            <a:r>
-              <a:rPr lang="en-US" sz="2400" b="1" dirty="0">
-                <a:solidFill>
-                  <a:srgbClr val="4F417A"/>
-                </a:solidFill>
-                <a:latin typeface="Cambria" pitchFamily="34" charset="0"/>
-                <a:ea typeface="Cambria" pitchFamily="34" charset="-122"/>
-                <a:cs typeface="Cambria" pitchFamily="34" charset="-120"/>
-              </a:rPr>
-              <a:t>+11,98</a:t>
-            </a:r>
-            <a:endParaRPr lang="en-US" sz="2400" dirty="0"/>
-          </a:p>
-        </p:txBody>
+              <a:t>Sau ACE, điểm quan sát của cả 7 thước đo dựa trên câu tham chiếu đều tăng so với GRPO + SPICE.</a:t>
+            </a:r>
+            <a:endParaRPr lang="en-US" sz="1550" dirty="0"/>
+          </a:p>
+        </p:txBody>
+      </p:sp>
+      <p:sp>
+        <p:nvSpPr>
+          <p:cNvPr id="5" name="Shape 3"/>
+          <p:cNvSpPr/>
+          <p:nvPr/>
+        </p:nvSpPr>
+        <p:spPr>
+          <a:xfrm>
+            <a:off x="502920" y="1389888"/>
+            <a:ext cx="7662672" cy="384048"/>
+          </a:xfrm>
+          <a:prstGeom prst="rect">
+            <a:avLst/>
+          </a:prstGeom>
+          <a:solidFill>
+            <a:srgbClr val="25194B"/>
+          </a:solidFill>
+          <a:ln w="12700">
+            <a:solidFill>
+              <a:srgbClr val="25194B">
+                <a:alpha val="0"/>
+              </a:srgbClr>
+            </a:solidFill>
+            <a:prstDash val="solid"/>
+          </a:ln>
+        </p:spPr>
       </p:sp>
       <p:sp>
         <p:nvSpPr>
@@ -15584,8 +15572,8 @@
         </p:nvSpPr>
         <p:spPr>
           <a:xfrm>
-            <a:off x="777240" y="2404872"/>
-            <a:ext cx="2057400" cy="475488"/>
+            <a:off x="502920" y="1389888"/>
+            <a:ext cx="1691640" cy="384048"/>
           </a:xfrm>
           <a:prstGeom prst="rect">
             <a:avLst/>
@@ -15599,21 +15587,21 @@
           </a:bodyPr>
           <a:lstStyle/>
           <a:p>
-            <a:pPr algn="ctr" indent="0" marL="0">
-              <a:buNone/>
-            </a:pPr>
-            <a:r>
-              <a:rPr lang="en-US" sz="1250" b="1" dirty="0">
-                <a:solidFill>
-                  <a:srgbClr val="1A1A1A"/>
-                </a:solidFill>
-                <a:latin typeface="Cambria" pitchFamily="34" charset="0"/>
-                <a:ea typeface="Cambria" pitchFamily="34" charset="-122"/>
-                <a:cs typeface="Cambria" pitchFamily="34" charset="-120"/>
-              </a:rPr>
-              <a:t>CIDEr-D</a:t>
-            </a:r>
-            <a:endParaRPr lang="en-US" sz="1250" dirty="0"/>
+            <a:pPr algn="l" indent="0" marL="0">
+              <a:buNone/>
+            </a:pPr>
+            <a:r>
+              <a:rPr lang="en-US" sz="1180" b="1" dirty="0">
+                <a:solidFill>
+                  <a:srgbClr val="FFFFFF"/>
+                </a:solidFill>
+                <a:latin typeface="Cambria" pitchFamily="34" charset="0"/>
+                <a:ea typeface="Cambria" pitchFamily="34" charset="-122"/>
+                <a:cs typeface="Cambria" pitchFamily="34" charset="-120"/>
+              </a:rPr>
+              <a:t>Thước đo</a:t>
+            </a:r>
+            <a:endParaRPr lang="en-US" sz="1180" dirty="0"/>
           </a:p>
         </p:txBody>
       </p:sp>
@@ -15625,47 +15613,8 @@
         </p:nvSpPr>
         <p:spPr>
           <a:xfrm>
-            <a:off x="3547872" y="1874520"/>
-            <a:ext cx="2057400" cy="502920"/>
-          </a:xfrm>
-          <a:prstGeom prst="rect">
-            <a:avLst/>
-          </a:prstGeom>
-          <a:noFill/>
-          <a:ln/>
-        </p:spPr>
-        <p:txBody>
-          <a:bodyPr wrap="square" lIns="0" tIns="0" rIns="0" bIns="0" rtlCol="0" anchor="ctr"/>
-          <a:lstStyle/>
-          <a:p>
-            <a:pPr algn="ctr" indent="0" marL="0">
-              <a:buNone/>
-            </a:pPr>
-            <a:r>
-              <a:rPr lang="en-US" sz="2400" b="1" dirty="0">
-                <a:solidFill>
-                  <a:srgbClr val="4F417A"/>
-                </a:solidFill>
-                <a:latin typeface="Cambria" pitchFamily="34" charset="0"/>
-                <a:ea typeface="Cambria" pitchFamily="34" charset="-122"/>
-                <a:cs typeface="Cambria" pitchFamily="34" charset="-120"/>
-              </a:rPr>
-              <a:t>+1,34</a:t>
-            </a:r>
-            <a:endParaRPr lang="en-US" sz="2400" dirty="0"/>
-          </a:p>
-        </p:txBody>
-      </p:sp>
-      <p:sp>
-        <p:nvSpPr>
-          <p:cNvPr id="8" name="Text 6"/>
-          <p:cNvSpPr/>
-          <p:nvPr/>
-        </p:nvSpPr>
-        <p:spPr>
-          <a:xfrm>
-            <a:off x="3547872" y="2404872"/>
-            <a:ext cx="2057400" cy="475488"/>
+            <a:off x="2194560" y="1389888"/>
+            <a:ext cx="1024128" cy="384048"/>
           </a:xfrm>
           <a:prstGeom prst="rect">
             <a:avLst/>
@@ -15683,69 +15632,30 @@
               <a:buNone/>
             </a:pPr>
             <a:r>
-              <a:rPr lang="en-US" sz="1250" b="1" dirty="0">
-                <a:solidFill>
-                  <a:srgbClr val="1A1A1A"/>
-                </a:solidFill>
-                <a:latin typeface="Cambria" pitchFamily="34" charset="0"/>
-                <a:ea typeface="Cambria" pitchFamily="34" charset="-122"/>
-                <a:cs typeface="Cambria" pitchFamily="34" charset="-120"/>
-              </a:rPr>
-              <a:t>SPICE</a:t>
-            </a:r>
-            <a:endParaRPr lang="en-US" sz="1250" dirty="0"/>
-          </a:p>
-        </p:txBody>
-      </p:sp>
-      <p:sp>
-        <p:nvSpPr>
-          <p:cNvPr id="9" name="Text 7"/>
-          <p:cNvSpPr/>
-          <p:nvPr/>
-        </p:nvSpPr>
-        <p:spPr>
-          <a:xfrm>
-            <a:off x="6309360" y="1874520"/>
-            <a:ext cx="2057400" cy="502920"/>
-          </a:xfrm>
-          <a:prstGeom prst="rect">
-            <a:avLst/>
-          </a:prstGeom>
-          <a:noFill/>
-          <a:ln/>
-        </p:spPr>
-        <p:txBody>
-          <a:bodyPr wrap="square" lIns="0" tIns="0" rIns="0" bIns="0" rtlCol="0" anchor="ctr"/>
-          <a:lstStyle/>
-          <a:p>
-            <a:pPr algn="ctr" indent="0" marL="0">
-              <a:buNone/>
-            </a:pPr>
-            <a:r>
-              <a:rPr lang="en-US" sz="2400" b="1" dirty="0">
-                <a:solidFill>
-                  <a:srgbClr val="4F417A"/>
-                </a:solidFill>
-                <a:latin typeface="Cambria" pitchFamily="34" charset="0"/>
-                <a:ea typeface="Cambria" pitchFamily="34" charset="-122"/>
-                <a:cs typeface="Cambria" pitchFamily="34" charset="-120"/>
-              </a:rPr>
-              <a:t>+0,66</a:t>
-            </a:r>
-            <a:endParaRPr lang="en-US" sz="2400" dirty="0"/>
-          </a:p>
-        </p:txBody>
-      </p:sp>
-      <p:sp>
-        <p:nvSpPr>
-          <p:cNvPr id="10" name="Text 8"/>
-          <p:cNvSpPr/>
-          <p:nvPr/>
-        </p:nvSpPr>
-        <p:spPr>
-          <a:xfrm>
-            <a:off x="6309360" y="2404872"/>
-            <a:ext cx="2057400" cy="475488"/>
+              <a:rPr lang="en-US" sz="1180" b="1" dirty="0">
+                <a:solidFill>
+                  <a:srgbClr val="FFFFFF"/>
+                </a:solidFill>
+                <a:latin typeface="Cambria" pitchFamily="34" charset="0"/>
+                <a:ea typeface="Cambria" pitchFamily="34" charset="-122"/>
+                <a:cs typeface="Cambria" pitchFamily="34" charset="-120"/>
+              </a:rPr>
+              <a:t>Base</a:t>
+            </a:r>
+            <a:endParaRPr lang="en-US" sz="1180" dirty="0"/>
+          </a:p>
+        </p:txBody>
+      </p:sp>
+      <p:sp>
+        <p:nvSpPr>
+          <p:cNvPr id="8" name="Text 6"/>
+          <p:cNvSpPr/>
+          <p:nvPr/>
+        </p:nvSpPr>
+        <p:spPr>
+          <a:xfrm>
+            <a:off x="3218688" y="1389888"/>
+            <a:ext cx="1024128" cy="384048"/>
           </a:xfrm>
           <a:prstGeom prst="rect">
             <a:avLst/>
@@ -15763,7 +15673,171 @@
               <a:buNone/>
             </a:pPr>
             <a:r>
-              <a:rPr lang="en-US" sz="1250" b="1" dirty="0">
+              <a:rPr lang="en-US" sz="1180" b="1" dirty="0">
+                <a:solidFill>
+                  <a:srgbClr val="FFFFFF"/>
+                </a:solidFill>
+                <a:latin typeface="Cambria" pitchFamily="34" charset="0"/>
+                <a:ea typeface="Cambria" pitchFamily="34" charset="-122"/>
+                <a:cs typeface="Cambria" pitchFamily="34" charset="-120"/>
+              </a:rPr>
+              <a:t>S1</a:t>
+            </a:r>
+            <a:endParaRPr lang="en-US" sz="1180" dirty="0"/>
+          </a:p>
+        </p:txBody>
+      </p:sp>
+      <p:sp>
+        <p:nvSpPr>
+          <p:cNvPr id="9" name="Text 7"/>
+          <p:cNvSpPr/>
+          <p:nvPr/>
+        </p:nvSpPr>
+        <p:spPr>
+          <a:xfrm>
+            <a:off x="4242816" y="1389888"/>
+            <a:ext cx="1298448" cy="384048"/>
+          </a:xfrm>
+          <a:prstGeom prst="rect">
+            <a:avLst/>
+          </a:prstGeom>
+          <a:noFill/>
+          <a:ln/>
+        </p:spPr>
+        <p:txBody>
+          <a:bodyPr wrap="square" lIns="0" tIns="0" rIns="0" bIns="0" rtlCol="0" anchor="ctr">
+            <a:normAutofit/>
+          </a:bodyPr>
+          <a:lstStyle/>
+          <a:p>
+            <a:pPr algn="ctr" indent="0" marL="0">
+              <a:buNone/>
+            </a:pPr>
+            <a:r>
+              <a:rPr lang="en-US" sz="1180" b="1" dirty="0">
+                <a:solidFill>
+                  <a:srgbClr val="FFFFFF"/>
+                </a:solidFill>
+                <a:latin typeface="Cambria" pitchFamily="34" charset="0"/>
+                <a:ea typeface="Cambria" pitchFamily="34" charset="-122"/>
+                <a:cs typeface="Cambria" pitchFamily="34" charset="-120"/>
+              </a:rPr>
+              <a:t>GRPO</a:t>
+            </a:r>
+            <a:endParaRPr lang="en-US" sz="1180" dirty="0"/>
+          </a:p>
+        </p:txBody>
+      </p:sp>
+      <p:sp>
+        <p:nvSpPr>
+          <p:cNvPr id="10" name="Text 8"/>
+          <p:cNvSpPr/>
+          <p:nvPr/>
+        </p:nvSpPr>
+        <p:spPr>
+          <a:xfrm>
+            <a:off x="5541264" y="1389888"/>
+            <a:ext cx="1389888" cy="384048"/>
+          </a:xfrm>
+          <a:prstGeom prst="rect">
+            <a:avLst/>
+          </a:prstGeom>
+          <a:noFill/>
+          <a:ln/>
+        </p:spPr>
+        <p:txBody>
+          <a:bodyPr wrap="square" lIns="0" tIns="0" rIns="0" bIns="0" rtlCol="0" anchor="ctr">
+            <a:normAutofit/>
+          </a:bodyPr>
+          <a:lstStyle/>
+          <a:p>
+            <a:pPr algn="ctr" indent="0" marL="0">
+              <a:buNone/>
+            </a:pPr>
+            <a:r>
+              <a:rPr lang="en-US" sz="1180" b="1" dirty="0">
+                <a:solidFill>
+                  <a:srgbClr val="FFFFFF"/>
+                </a:solidFill>
+                <a:latin typeface="Cambria" pitchFamily="34" charset="0"/>
+                <a:ea typeface="Cambria" pitchFamily="34" charset="-122"/>
+                <a:cs typeface="Cambria" pitchFamily="34" charset="-120"/>
+              </a:rPr>
+              <a:t>Đề xuất</a:t>
+            </a:r>
+            <a:endParaRPr lang="en-US" sz="1180" dirty="0"/>
+          </a:p>
+        </p:txBody>
+      </p:sp>
+      <p:sp>
+        <p:nvSpPr>
+          <p:cNvPr id="11" name="Text 9"/>
+          <p:cNvSpPr/>
+          <p:nvPr/>
+        </p:nvSpPr>
+        <p:spPr>
+          <a:xfrm>
+            <a:off x="6931152" y="1389888"/>
+            <a:ext cx="1234440" cy="384048"/>
+          </a:xfrm>
+          <a:prstGeom prst="rect">
+            <a:avLst/>
+          </a:prstGeom>
+          <a:noFill/>
+          <a:ln/>
+        </p:spPr>
+        <p:txBody>
+          <a:bodyPr wrap="square" lIns="0" tIns="0" rIns="0" bIns="0" rtlCol="0" anchor="ctr">
+            <a:normAutofit/>
+          </a:bodyPr>
+          <a:lstStyle/>
+          <a:p>
+            <a:pPr algn="ctr" indent="0" marL="0">
+              <a:buNone/>
+            </a:pPr>
+            <a:r>
+              <a:rPr lang="en-US" sz="1180" b="1" dirty="0">
+                <a:solidFill>
+                  <a:srgbClr val="FFFFFF"/>
+                </a:solidFill>
+                <a:latin typeface="Cambria" pitchFamily="34" charset="0"/>
+                <a:ea typeface="Cambria" pitchFamily="34" charset="-122"/>
+                <a:cs typeface="Cambria" pitchFamily="34" charset="-120"/>
+              </a:rPr>
+              <a:t>Δ ACE</a:t>
+            </a:r>
+            <a:endParaRPr lang="en-US" sz="1180" dirty="0"/>
+          </a:p>
+        </p:txBody>
+      </p:sp>
+      <p:sp>
+        <p:nvSpPr>
+          <p:cNvPr id="12" name="Text 10"/>
+          <p:cNvSpPr/>
+          <p:nvPr/>
+        </p:nvSpPr>
+        <p:spPr>
+          <a:xfrm>
+            <a:off x="502920" y="1773936"/>
+            <a:ext cx="1691640" cy="429768"/>
+          </a:xfrm>
+          <a:prstGeom prst="rect">
+            <a:avLst/>
+          </a:prstGeom>
+          <a:noFill/>
+          <a:ln/>
+        </p:spPr>
+        <p:txBody>
+          <a:bodyPr wrap="square" lIns="0" tIns="0" rIns="0" bIns="0" rtlCol="0" anchor="ctr">
+            <a:normAutofit/>
+          </a:bodyPr>
+          <a:lstStyle/>
+          <a:p>
+            <a:pPr algn="l" indent="0" marL="0">
+              <a:buNone/>
+            </a:pPr>
+            <a:r>
+              <a:rPr lang="en-US" sz="1190" dirty="0">
                 <a:solidFill>
                   <a:srgbClr val="1A1A1A"/>
                 </a:solidFill>
@@ -15771,22 +15845,1847 @@
                 <a:ea typeface="Cambria" pitchFamily="34" charset="-122"/>
                 <a:cs typeface="Cambria" pitchFamily="34" charset="-120"/>
               </a:rPr>
+              <a:t>BLEU-4</a:t>
+            </a:r>
+            <a:endParaRPr lang="en-US" sz="1190" dirty="0"/>
+          </a:p>
+        </p:txBody>
+      </p:sp>
+      <p:sp>
+        <p:nvSpPr>
+          <p:cNvPr id="13" name="Text 11"/>
+          <p:cNvSpPr/>
+          <p:nvPr/>
+        </p:nvSpPr>
+        <p:spPr>
+          <a:xfrm>
+            <a:off x="2194560" y="1773936"/>
+            <a:ext cx="1024128" cy="429768"/>
+          </a:xfrm>
+          <a:prstGeom prst="rect">
+            <a:avLst/>
+          </a:prstGeom>
+          <a:noFill/>
+          <a:ln/>
+        </p:spPr>
+        <p:txBody>
+          <a:bodyPr wrap="square" lIns="0" tIns="0" rIns="0" bIns="0" rtlCol="0" anchor="ctr">
+            <a:normAutofit/>
+          </a:bodyPr>
+          <a:lstStyle/>
+          <a:p>
+            <a:pPr algn="ctr" indent="0" marL="0">
+              <a:buNone/>
+            </a:pPr>
+            <a:r>
+              <a:rPr lang="en-US" sz="1190" dirty="0">
+                <a:solidFill>
+                  <a:srgbClr val="1A1A1A"/>
+                </a:solidFill>
+                <a:latin typeface="Cambria" pitchFamily="34" charset="0"/>
+                <a:ea typeface="Cambria" pitchFamily="34" charset="-122"/>
+                <a:cs typeface="Cambria" pitchFamily="34" charset="-120"/>
+              </a:rPr>
+              <a:t>15,30</a:t>
+            </a:r>
+            <a:endParaRPr lang="en-US" sz="1190" dirty="0"/>
+          </a:p>
+        </p:txBody>
+      </p:sp>
+      <p:sp>
+        <p:nvSpPr>
+          <p:cNvPr id="14" name="Text 12"/>
+          <p:cNvSpPr/>
+          <p:nvPr/>
+        </p:nvSpPr>
+        <p:spPr>
+          <a:xfrm>
+            <a:off x="3218688" y="1773936"/>
+            <a:ext cx="1024128" cy="429768"/>
+          </a:xfrm>
+          <a:prstGeom prst="rect">
+            <a:avLst/>
+          </a:prstGeom>
+          <a:noFill/>
+          <a:ln/>
+        </p:spPr>
+        <p:txBody>
+          <a:bodyPr wrap="square" lIns="0" tIns="0" rIns="0" bIns="0" rtlCol="0" anchor="ctr">
+            <a:normAutofit/>
+          </a:bodyPr>
+          <a:lstStyle/>
+          <a:p>
+            <a:pPr algn="ctr" indent="0" marL="0">
+              <a:buNone/>
+            </a:pPr>
+            <a:r>
+              <a:rPr lang="en-US" sz="1190" dirty="0">
+                <a:solidFill>
+                  <a:srgbClr val="1A1A1A"/>
+                </a:solidFill>
+                <a:latin typeface="Cambria" pitchFamily="34" charset="0"/>
+                <a:ea typeface="Cambria" pitchFamily="34" charset="-122"/>
+                <a:cs typeface="Cambria" pitchFamily="34" charset="-120"/>
+              </a:rPr>
+              <a:t>51,56</a:t>
+            </a:r>
+            <a:endParaRPr lang="en-US" sz="1190" dirty="0"/>
+          </a:p>
+        </p:txBody>
+      </p:sp>
+      <p:sp>
+        <p:nvSpPr>
+          <p:cNvPr id="15" name="Text 13"/>
+          <p:cNvSpPr/>
+          <p:nvPr/>
+        </p:nvSpPr>
+        <p:spPr>
+          <a:xfrm>
+            <a:off x="4242816" y="1773936"/>
+            <a:ext cx="1298448" cy="429768"/>
+          </a:xfrm>
+          <a:prstGeom prst="rect">
+            <a:avLst/>
+          </a:prstGeom>
+          <a:noFill/>
+          <a:ln/>
+        </p:spPr>
+        <p:txBody>
+          <a:bodyPr wrap="square" lIns="0" tIns="0" rIns="0" bIns="0" rtlCol="0" anchor="ctr">
+            <a:normAutofit/>
+          </a:bodyPr>
+          <a:lstStyle/>
+          <a:p>
+            <a:pPr algn="ctr" indent="0" marL="0">
+              <a:buNone/>
+            </a:pPr>
+            <a:r>
+              <a:rPr lang="en-US" sz="1190" dirty="0">
+                <a:solidFill>
+                  <a:srgbClr val="1A1A1A"/>
+                </a:solidFill>
+                <a:latin typeface="Cambria" pitchFamily="34" charset="0"/>
+                <a:ea typeface="Cambria" pitchFamily="34" charset="-122"/>
+                <a:cs typeface="Cambria" pitchFamily="34" charset="-120"/>
+              </a:rPr>
+              <a:t>52,36</a:t>
+            </a:r>
+            <a:endParaRPr lang="en-US" sz="1190" dirty="0"/>
+          </a:p>
+        </p:txBody>
+      </p:sp>
+      <p:sp>
+        <p:nvSpPr>
+          <p:cNvPr id="16" name="Text 14"/>
+          <p:cNvSpPr/>
+          <p:nvPr/>
+        </p:nvSpPr>
+        <p:spPr>
+          <a:xfrm>
+            <a:off x="5541264" y="1773936"/>
+            <a:ext cx="1389888" cy="429768"/>
+          </a:xfrm>
+          <a:prstGeom prst="rect">
+            <a:avLst/>
+          </a:prstGeom>
+          <a:noFill/>
+          <a:ln/>
+        </p:spPr>
+        <p:txBody>
+          <a:bodyPr wrap="square" lIns="0" tIns="0" rIns="0" bIns="0" rtlCol="0" anchor="ctr">
+            <a:normAutofit/>
+          </a:bodyPr>
+          <a:lstStyle/>
+          <a:p>
+            <a:pPr algn="ctr" indent="0" marL="0">
+              <a:buNone/>
+            </a:pPr>
+            <a:r>
+              <a:rPr lang="en-US" sz="1190" dirty="0">
+                <a:solidFill>
+                  <a:srgbClr val="1A1A1A"/>
+                </a:solidFill>
+                <a:latin typeface="Cambria" pitchFamily="34" charset="0"/>
+                <a:ea typeface="Cambria" pitchFamily="34" charset="-122"/>
+                <a:cs typeface="Cambria" pitchFamily="34" charset="-120"/>
+              </a:rPr>
+              <a:t>53,47</a:t>
+            </a:r>
+            <a:endParaRPr lang="en-US" sz="1190" dirty="0"/>
+          </a:p>
+        </p:txBody>
+      </p:sp>
+      <p:sp>
+        <p:nvSpPr>
+          <p:cNvPr id="17" name="Text 15"/>
+          <p:cNvSpPr/>
+          <p:nvPr/>
+        </p:nvSpPr>
+        <p:spPr>
+          <a:xfrm>
+            <a:off x="6931152" y="1773936"/>
+            <a:ext cx="1234440" cy="429768"/>
+          </a:xfrm>
+          <a:prstGeom prst="rect">
+            <a:avLst/>
+          </a:prstGeom>
+          <a:noFill/>
+          <a:ln/>
+        </p:spPr>
+        <p:txBody>
+          <a:bodyPr wrap="square" lIns="0" tIns="0" rIns="0" bIns="0" rtlCol="0" anchor="ctr">
+            <a:normAutofit/>
+          </a:bodyPr>
+          <a:lstStyle/>
+          <a:p>
+            <a:pPr algn="ctr" indent="0" marL="0">
+              <a:buNone/>
+            </a:pPr>
+            <a:r>
+              <a:rPr lang="en-US" sz="1190" dirty="0">
+                <a:solidFill>
+                  <a:srgbClr val="1A1A1A"/>
+                </a:solidFill>
+                <a:latin typeface="Cambria" pitchFamily="34" charset="0"/>
+                <a:ea typeface="Cambria" pitchFamily="34" charset="-122"/>
+                <a:cs typeface="Cambria" pitchFamily="34" charset="-120"/>
+              </a:rPr>
+              <a:t>+1,11</a:t>
+            </a:r>
+            <a:endParaRPr lang="en-US" sz="1190" dirty="0"/>
+          </a:p>
+        </p:txBody>
+      </p:sp>
+      <p:sp>
+        <p:nvSpPr>
+          <p:cNvPr id="18" name="Shape 16"/>
+          <p:cNvSpPr/>
+          <p:nvPr/>
+        </p:nvSpPr>
+        <p:spPr>
+          <a:xfrm>
+            <a:off x="502920" y="2203704"/>
+            <a:ext cx="7662672" cy="0"/>
+          </a:xfrm>
+          <a:prstGeom prst="line">
+            <a:avLst/>
+          </a:prstGeom>
+          <a:noFill/>
+          <a:ln w="12700">
+            <a:solidFill>
+              <a:srgbClr val="D9D6DF"/>
+            </a:solidFill>
+            <a:prstDash val="solid"/>
+            <a:tailEnd type="none"/>
+          </a:ln>
+        </p:spPr>
+      </p:sp>
+      <p:sp>
+        <p:nvSpPr>
+          <p:cNvPr id="19" name="Text 17"/>
+          <p:cNvSpPr/>
+          <p:nvPr/>
+        </p:nvSpPr>
+        <p:spPr>
+          <a:xfrm>
+            <a:off x="502920" y="2203704"/>
+            <a:ext cx="1691640" cy="429768"/>
+          </a:xfrm>
+          <a:prstGeom prst="rect">
+            <a:avLst/>
+          </a:prstGeom>
+          <a:noFill/>
+          <a:ln/>
+        </p:spPr>
+        <p:txBody>
+          <a:bodyPr wrap="square" lIns="0" tIns="0" rIns="0" bIns="0" rtlCol="0" anchor="ctr">
+            <a:normAutofit/>
+          </a:bodyPr>
+          <a:lstStyle/>
+          <a:p>
+            <a:pPr algn="l" indent="0" marL="0">
+              <a:buNone/>
+            </a:pPr>
+            <a:r>
+              <a:rPr lang="en-US" sz="1190" dirty="0">
+                <a:solidFill>
+                  <a:srgbClr val="1A1A1A"/>
+                </a:solidFill>
+                <a:latin typeface="Cambria" pitchFamily="34" charset="0"/>
+                <a:ea typeface="Cambria" pitchFamily="34" charset="-122"/>
+                <a:cs typeface="Cambria" pitchFamily="34" charset="-120"/>
+              </a:rPr>
+              <a:t>METEOR</a:t>
+            </a:r>
+            <a:endParaRPr lang="en-US" sz="1190" dirty="0"/>
+          </a:p>
+        </p:txBody>
+      </p:sp>
+      <p:sp>
+        <p:nvSpPr>
+          <p:cNvPr id="20" name="Text 18"/>
+          <p:cNvSpPr/>
+          <p:nvPr/>
+        </p:nvSpPr>
+        <p:spPr>
+          <a:xfrm>
+            <a:off x="2194560" y="2203704"/>
+            <a:ext cx="1024128" cy="429768"/>
+          </a:xfrm>
+          <a:prstGeom prst="rect">
+            <a:avLst/>
+          </a:prstGeom>
+          <a:noFill/>
+          <a:ln/>
+        </p:spPr>
+        <p:txBody>
+          <a:bodyPr wrap="square" lIns="0" tIns="0" rIns="0" bIns="0" rtlCol="0" anchor="ctr">
+            <a:normAutofit/>
+          </a:bodyPr>
+          <a:lstStyle/>
+          <a:p>
+            <a:pPr algn="ctr" indent="0" marL="0">
+              <a:buNone/>
+            </a:pPr>
+            <a:r>
+              <a:rPr lang="en-US" sz="1190" dirty="0">
+                <a:solidFill>
+                  <a:srgbClr val="1A1A1A"/>
+                </a:solidFill>
+                <a:latin typeface="Cambria" pitchFamily="34" charset="0"/>
+                <a:ea typeface="Cambria" pitchFamily="34" charset="-122"/>
+                <a:cs typeface="Cambria" pitchFamily="34" charset="-120"/>
+              </a:rPr>
+              <a:t>24,60</a:t>
+            </a:r>
+            <a:endParaRPr lang="en-US" sz="1190" dirty="0"/>
+          </a:p>
+        </p:txBody>
+      </p:sp>
+      <p:sp>
+        <p:nvSpPr>
+          <p:cNvPr id="21" name="Text 19"/>
+          <p:cNvSpPr/>
+          <p:nvPr/>
+        </p:nvSpPr>
+        <p:spPr>
+          <a:xfrm>
+            <a:off x="3218688" y="2203704"/>
+            <a:ext cx="1024128" cy="429768"/>
+          </a:xfrm>
+          <a:prstGeom prst="rect">
+            <a:avLst/>
+          </a:prstGeom>
+          <a:noFill/>
+          <a:ln/>
+        </p:spPr>
+        <p:txBody>
+          <a:bodyPr wrap="square" lIns="0" tIns="0" rIns="0" bIns="0" rtlCol="0" anchor="ctr">
+            <a:normAutofit/>
+          </a:bodyPr>
+          <a:lstStyle/>
+          <a:p>
+            <a:pPr algn="ctr" indent="0" marL="0">
+              <a:buNone/>
+            </a:pPr>
+            <a:r>
+              <a:rPr lang="en-US" sz="1190" dirty="0">
+                <a:solidFill>
+                  <a:srgbClr val="1A1A1A"/>
+                </a:solidFill>
+                <a:latin typeface="Cambria" pitchFamily="34" charset="0"/>
+                <a:ea typeface="Cambria" pitchFamily="34" charset="-122"/>
+                <a:cs typeface="Cambria" pitchFamily="34" charset="-120"/>
+              </a:rPr>
+              <a:t>36,79</a:t>
+            </a:r>
+            <a:endParaRPr lang="en-US" sz="1190" dirty="0"/>
+          </a:p>
+        </p:txBody>
+      </p:sp>
+      <p:sp>
+        <p:nvSpPr>
+          <p:cNvPr id="22" name="Text 20"/>
+          <p:cNvSpPr/>
+          <p:nvPr/>
+        </p:nvSpPr>
+        <p:spPr>
+          <a:xfrm>
+            <a:off x="4242816" y="2203704"/>
+            <a:ext cx="1298448" cy="429768"/>
+          </a:xfrm>
+          <a:prstGeom prst="rect">
+            <a:avLst/>
+          </a:prstGeom>
+          <a:noFill/>
+          <a:ln/>
+        </p:spPr>
+        <p:txBody>
+          <a:bodyPr wrap="square" lIns="0" tIns="0" rIns="0" bIns="0" rtlCol="0" anchor="ctr">
+            <a:normAutofit/>
+          </a:bodyPr>
+          <a:lstStyle/>
+          <a:p>
+            <a:pPr algn="ctr" indent="0" marL="0">
+              <a:buNone/>
+            </a:pPr>
+            <a:r>
+              <a:rPr lang="en-US" sz="1190" dirty="0">
+                <a:solidFill>
+                  <a:srgbClr val="1A1A1A"/>
+                </a:solidFill>
+                <a:latin typeface="Cambria" pitchFamily="34" charset="0"/>
+                <a:ea typeface="Cambria" pitchFamily="34" charset="-122"/>
+                <a:cs typeface="Cambria" pitchFamily="34" charset="-120"/>
+              </a:rPr>
+              <a:t>37,92</a:t>
+            </a:r>
+            <a:endParaRPr lang="en-US" sz="1190" dirty="0"/>
+          </a:p>
+        </p:txBody>
+      </p:sp>
+      <p:sp>
+        <p:nvSpPr>
+          <p:cNvPr id="23" name="Text 21"/>
+          <p:cNvSpPr/>
+          <p:nvPr/>
+        </p:nvSpPr>
+        <p:spPr>
+          <a:xfrm>
+            <a:off x="5541264" y="2203704"/>
+            <a:ext cx="1389888" cy="429768"/>
+          </a:xfrm>
+          <a:prstGeom prst="rect">
+            <a:avLst/>
+          </a:prstGeom>
+          <a:noFill/>
+          <a:ln/>
+        </p:spPr>
+        <p:txBody>
+          <a:bodyPr wrap="square" lIns="0" tIns="0" rIns="0" bIns="0" rtlCol="0" anchor="ctr">
+            <a:normAutofit/>
+          </a:bodyPr>
+          <a:lstStyle/>
+          <a:p>
+            <a:pPr algn="ctr" indent="0" marL="0">
+              <a:buNone/>
+            </a:pPr>
+            <a:r>
+              <a:rPr lang="en-US" sz="1190" dirty="0">
+                <a:solidFill>
+                  <a:srgbClr val="1A1A1A"/>
+                </a:solidFill>
+                <a:latin typeface="Cambria" pitchFamily="34" charset="0"/>
+                <a:ea typeface="Cambria" pitchFamily="34" charset="-122"/>
+                <a:cs typeface="Cambria" pitchFamily="34" charset="-120"/>
+              </a:rPr>
+              <a:t>38,37</a:t>
+            </a:r>
+            <a:endParaRPr lang="en-US" sz="1190" dirty="0"/>
+          </a:p>
+        </p:txBody>
+      </p:sp>
+      <p:sp>
+        <p:nvSpPr>
+          <p:cNvPr id="24" name="Text 22"/>
+          <p:cNvSpPr/>
+          <p:nvPr/>
+        </p:nvSpPr>
+        <p:spPr>
+          <a:xfrm>
+            <a:off x="6931152" y="2203704"/>
+            <a:ext cx="1234440" cy="429768"/>
+          </a:xfrm>
+          <a:prstGeom prst="rect">
+            <a:avLst/>
+          </a:prstGeom>
+          <a:noFill/>
+          <a:ln/>
+        </p:spPr>
+        <p:txBody>
+          <a:bodyPr wrap="square" lIns="0" tIns="0" rIns="0" bIns="0" rtlCol="0" anchor="ctr">
+            <a:normAutofit/>
+          </a:bodyPr>
+          <a:lstStyle/>
+          <a:p>
+            <a:pPr algn="ctr" indent="0" marL="0">
+              <a:buNone/>
+            </a:pPr>
+            <a:r>
+              <a:rPr lang="en-US" sz="1190" dirty="0">
+                <a:solidFill>
+                  <a:srgbClr val="1A1A1A"/>
+                </a:solidFill>
+                <a:latin typeface="Cambria" pitchFamily="34" charset="0"/>
+                <a:ea typeface="Cambria" pitchFamily="34" charset="-122"/>
+                <a:cs typeface="Cambria" pitchFamily="34" charset="-120"/>
+              </a:rPr>
+              <a:t>+0,46</a:t>
+            </a:r>
+            <a:endParaRPr lang="en-US" sz="1190" dirty="0"/>
+          </a:p>
+        </p:txBody>
+      </p:sp>
+      <p:sp>
+        <p:nvSpPr>
+          <p:cNvPr id="25" name="Shape 23"/>
+          <p:cNvSpPr/>
+          <p:nvPr/>
+        </p:nvSpPr>
+        <p:spPr>
+          <a:xfrm>
+            <a:off x="502920" y="2633472"/>
+            <a:ext cx="7662672" cy="0"/>
+          </a:xfrm>
+          <a:prstGeom prst="line">
+            <a:avLst/>
+          </a:prstGeom>
+          <a:noFill/>
+          <a:ln w="12700">
+            <a:solidFill>
+              <a:srgbClr val="D9D6DF"/>
+            </a:solidFill>
+            <a:prstDash val="solid"/>
+            <a:tailEnd type="none"/>
+          </a:ln>
+        </p:spPr>
+      </p:sp>
+      <p:sp>
+        <p:nvSpPr>
+          <p:cNvPr id="26" name="Text 24"/>
+          <p:cNvSpPr/>
+          <p:nvPr/>
+        </p:nvSpPr>
+        <p:spPr>
+          <a:xfrm>
+            <a:off x="502920" y="2633472"/>
+            <a:ext cx="1691640" cy="429768"/>
+          </a:xfrm>
+          <a:prstGeom prst="rect">
+            <a:avLst/>
+          </a:prstGeom>
+          <a:noFill/>
+          <a:ln/>
+        </p:spPr>
+        <p:txBody>
+          <a:bodyPr wrap="square" lIns="0" tIns="0" rIns="0" bIns="0" rtlCol="0" anchor="ctr">
+            <a:normAutofit/>
+          </a:bodyPr>
+          <a:lstStyle/>
+          <a:p>
+            <a:pPr algn="l" indent="0" marL="0">
+              <a:buNone/>
+            </a:pPr>
+            <a:r>
+              <a:rPr lang="en-US" sz="1190" dirty="0">
+                <a:solidFill>
+                  <a:srgbClr val="1A1A1A"/>
+                </a:solidFill>
+                <a:latin typeface="Cambria" pitchFamily="34" charset="0"/>
+                <a:ea typeface="Cambria" pitchFamily="34" charset="-122"/>
+                <a:cs typeface="Cambria" pitchFamily="34" charset="-120"/>
+              </a:rPr>
+              <a:t>ROUGE-L</a:t>
+            </a:r>
+            <a:endParaRPr lang="en-US" sz="1190" dirty="0"/>
+          </a:p>
+        </p:txBody>
+      </p:sp>
+      <p:sp>
+        <p:nvSpPr>
+          <p:cNvPr id="27" name="Text 25"/>
+          <p:cNvSpPr/>
+          <p:nvPr/>
+        </p:nvSpPr>
+        <p:spPr>
+          <a:xfrm>
+            <a:off x="2194560" y="2633472"/>
+            <a:ext cx="1024128" cy="429768"/>
+          </a:xfrm>
+          <a:prstGeom prst="rect">
+            <a:avLst/>
+          </a:prstGeom>
+          <a:noFill/>
+          <a:ln/>
+        </p:spPr>
+        <p:txBody>
+          <a:bodyPr wrap="square" lIns="0" tIns="0" rIns="0" bIns="0" rtlCol="0" anchor="ctr">
+            <a:normAutofit/>
+          </a:bodyPr>
+          <a:lstStyle/>
+          <a:p>
+            <a:pPr algn="ctr" indent="0" marL="0">
+              <a:buNone/>
+            </a:pPr>
+            <a:r>
+              <a:rPr lang="en-US" sz="1190" dirty="0">
+                <a:solidFill>
+                  <a:srgbClr val="1A1A1A"/>
+                </a:solidFill>
+                <a:latin typeface="Cambria" pitchFamily="34" charset="0"/>
+                <a:ea typeface="Cambria" pitchFamily="34" charset="-122"/>
+                <a:cs typeface="Cambria" pitchFamily="34" charset="-120"/>
+              </a:rPr>
+              <a:t>42,30</a:t>
+            </a:r>
+            <a:endParaRPr lang="en-US" sz="1190" dirty="0"/>
+          </a:p>
+        </p:txBody>
+      </p:sp>
+      <p:sp>
+        <p:nvSpPr>
+          <p:cNvPr id="28" name="Text 26"/>
+          <p:cNvSpPr/>
+          <p:nvPr/>
+        </p:nvSpPr>
+        <p:spPr>
+          <a:xfrm>
+            <a:off x="3218688" y="2633472"/>
+            <a:ext cx="1024128" cy="429768"/>
+          </a:xfrm>
+          <a:prstGeom prst="rect">
+            <a:avLst/>
+          </a:prstGeom>
+          <a:noFill/>
+          <a:ln/>
+        </p:spPr>
+        <p:txBody>
+          <a:bodyPr wrap="square" lIns="0" tIns="0" rIns="0" bIns="0" rtlCol="0" anchor="ctr">
+            <a:normAutofit/>
+          </a:bodyPr>
+          <a:lstStyle/>
+          <a:p>
+            <a:pPr algn="ctr" indent="0" marL="0">
+              <a:buNone/>
+            </a:pPr>
+            <a:r>
+              <a:rPr lang="en-US" sz="1190" dirty="0">
+                <a:solidFill>
+                  <a:srgbClr val="1A1A1A"/>
+                </a:solidFill>
+                <a:latin typeface="Cambria" pitchFamily="34" charset="0"/>
+                <a:ea typeface="Cambria" pitchFamily="34" charset="-122"/>
+                <a:cs typeface="Cambria" pitchFamily="34" charset="-120"/>
+              </a:rPr>
+              <a:t>67,35</a:t>
+            </a:r>
+            <a:endParaRPr lang="en-US" sz="1190" dirty="0"/>
+          </a:p>
+        </p:txBody>
+      </p:sp>
+      <p:sp>
+        <p:nvSpPr>
+          <p:cNvPr id="29" name="Text 27"/>
+          <p:cNvSpPr/>
+          <p:nvPr/>
+        </p:nvSpPr>
+        <p:spPr>
+          <a:xfrm>
+            <a:off x="4242816" y="2633472"/>
+            <a:ext cx="1298448" cy="429768"/>
+          </a:xfrm>
+          <a:prstGeom prst="rect">
+            <a:avLst/>
+          </a:prstGeom>
+          <a:noFill/>
+          <a:ln/>
+        </p:spPr>
+        <p:txBody>
+          <a:bodyPr wrap="square" lIns="0" tIns="0" rIns="0" bIns="0" rtlCol="0" anchor="ctr">
+            <a:normAutofit/>
+          </a:bodyPr>
+          <a:lstStyle/>
+          <a:p>
+            <a:pPr algn="ctr" indent="0" marL="0">
+              <a:buNone/>
+            </a:pPr>
+            <a:r>
+              <a:rPr lang="en-US" sz="1190" dirty="0">
+                <a:solidFill>
+                  <a:srgbClr val="1A1A1A"/>
+                </a:solidFill>
+                <a:latin typeface="Cambria" pitchFamily="34" charset="0"/>
+                <a:ea typeface="Cambria" pitchFamily="34" charset="-122"/>
+                <a:cs typeface="Cambria" pitchFamily="34" charset="-120"/>
+              </a:rPr>
+              <a:t>68,36</a:t>
+            </a:r>
+            <a:endParaRPr lang="en-US" sz="1190" dirty="0"/>
+          </a:p>
+        </p:txBody>
+      </p:sp>
+      <p:sp>
+        <p:nvSpPr>
+          <p:cNvPr id="30" name="Text 28"/>
+          <p:cNvSpPr/>
+          <p:nvPr/>
+        </p:nvSpPr>
+        <p:spPr>
+          <a:xfrm>
+            <a:off x="5541264" y="2633472"/>
+            <a:ext cx="1389888" cy="429768"/>
+          </a:xfrm>
+          <a:prstGeom prst="rect">
+            <a:avLst/>
+          </a:prstGeom>
+          <a:noFill/>
+          <a:ln/>
+        </p:spPr>
+        <p:txBody>
+          <a:bodyPr wrap="square" lIns="0" tIns="0" rIns="0" bIns="0" rtlCol="0" anchor="ctr">
+            <a:normAutofit/>
+          </a:bodyPr>
+          <a:lstStyle/>
+          <a:p>
+            <a:pPr algn="ctr" indent="0" marL="0">
+              <a:buNone/>
+            </a:pPr>
+            <a:r>
+              <a:rPr lang="en-US" sz="1190" dirty="0">
+                <a:solidFill>
+                  <a:srgbClr val="1A1A1A"/>
+                </a:solidFill>
+                <a:latin typeface="Cambria" pitchFamily="34" charset="0"/>
+                <a:ea typeface="Cambria" pitchFamily="34" charset="-122"/>
+                <a:cs typeface="Cambria" pitchFamily="34" charset="-120"/>
+              </a:rPr>
+              <a:t>69,08</a:t>
+            </a:r>
+            <a:endParaRPr lang="en-US" sz="1190" dirty="0"/>
+          </a:p>
+        </p:txBody>
+      </p:sp>
+      <p:sp>
+        <p:nvSpPr>
+          <p:cNvPr id="31" name="Text 29"/>
+          <p:cNvSpPr/>
+          <p:nvPr/>
+        </p:nvSpPr>
+        <p:spPr>
+          <a:xfrm>
+            <a:off x="6931152" y="2633472"/>
+            <a:ext cx="1234440" cy="429768"/>
+          </a:xfrm>
+          <a:prstGeom prst="rect">
+            <a:avLst/>
+          </a:prstGeom>
+          <a:noFill/>
+          <a:ln/>
+        </p:spPr>
+        <p:txBody>
+          <a:bodyPr wrap="square" lIns="0" tIns="0" rIns="0" bIns="0" rtlCol="0" anchor="ctr">
+            <a:normAutofit/>
+          </a:bodyPr>
+          <a:lstStyle/>
+          <a:p>
+            <a:pPr algn="ctr" indent="0" marL="0">
+              <a:buNone/>
+            </a:pPr>
+            <a:r>
+              <a:rPr lang="en-US" sz="1190" dirty="0">
+                <a:solidFill>
+                  <a:srgbClr val="1A1A1A"/>
+                </a:solidFill>
+                <a:latin typeface="Cambria" pitchFamily="34" charset="0"/>
+                <a:ea typeface="Cambria" pitchFamily="34" charset="-122"/>
+                <a:cs typeface="Cambria" pitchFamily="34" charset="-120"/>
+              </a:rPr>
+              <a:t>+0,74</a:t>
+            </a:r>
+            <a:endParaRPr lang="en-US" sz="1190" dirty="0"/>
+          </a:p>
+        </p:txBody>
+      </p:sp>
+      <p:sp>
+        <p:nvSpPr>
+          <p:cNvPr id="32" name="Shape 30"/>
+          <p:cNvSpPr/>
+          <p:nvPr/>
+        </p:nvSpPr>
+        <p:spPr>
+          <a:xfrm>
+            <a:off x="502920" y="3063240"/>
+            <a:ext cx="7662672" cy="0"/>
+          </a:xfrm>
+          <a:prstGeom prst="line">
+            <a:avLst/>
+          </a:prstGeom>
+          <a:noFill/>
+          <a:ln w="12700">
+            <a:solidFill>
+              <a:srgbClr val="D9D6DF"/>
+            </a:solidFill>
+            <a:prstDash val="solid"/>
+            <a:tailEnd type="none"/>
+          </a:ln>
+        </p:spPr>
+      </p:sp>
+      <p:sp>
+        <p:nvSpPr>
+          <p:cNvPr id="33" name="Text 31"/>
+          <p:cNvSpPr/>
+          <p:nvPr/>
+        </p:nvSpPr>
+        <p:spPr>
+          <a:xfrm>
+            <a:off x="502920" y="3063240"/>
+            <a:ext cx="1691640" cy="429768"/>
+          </a:xfrm>
+          <a:prstGeom prst="rect">
+            <a:avLst/>
+          </a:prstGeom>
+          <a:noFill/>
+          <a:ln/>
+        </p:spPr>
+        <p:txBody>
+          <a:bodyPr wrap="square" lIns="0" tIns="0" rIns="0" bIns="0" rtlCol="0" anchor="ctr">
+            <a:normAutofit/>
+          </a:bodyPr>
+          <a:lstStyle/>
+          <a:p>
+            <a:pPr algn="l" indent="0" marL="0">
+              <a:buNone/>
+            </a:pPr>
+            <a:r>
+              <a:rPr lang="en-US" sz="1190" dirty="0">
+                <a:solidFill>
+                  <a:srgbClr val="1A1A1A"/>
+                </a:solidFill>
+                <a:latin typeface="Cambria" pitchFamily="34" charset="0"/>
+                <a:ea typeface="Cambria" pitchFamily="34" charset="-122"/>
+                <a:cs typeface="Cambria" pitchFamily="34" charset="-120"/>
+              </a:rPr>
+              <a:t>CIDEr-D</a:t>
+            </a:r>
+            <a:endParaRPr lang="en-US" sz="1190" dirty="0"/>
+          </a:p>
+        </p:txBody>
+      </p:sp>
+      <p:sp>
+        <p:nvSpPr>
+          <p:cNvPr id="34" name="Text 32"/>
+          <p:cNvSpPr/>
+          <p:nvPr/>
+        </p:nvSpPr>
+        <p:spPr>
+          <a:xfrm>
+            <a:off x="2194560" y="3063240"/>
+            <a:ext cx="1024128" cy="429768"/>
+          </a:xfrm>
+          <a:prstGeom prst="rect">
+            <a:avLst/>
+          </a:prstGeom>
+          <a:noFill/>
+          <a:ln/>
+        </p:spPr>
+        <p:txBody>
+          <a:bodyPr wrap="square" lIns="0" tIns="0" rIns="0" bIns="0" rtlCol="0" anchor="ctr">
+            <a:normAutofit/>
+          </a:bodyPr>
+          <a:lstStyle/>
+          <a:p>
+            <a:pPr algn="ctr" indent="0" marL="0">
+              <a:buNone/>
+            </a:pPr>
+            <a:r>
+              <a:rPr lang="en-US" sz="1190" dirty="0">
+                <a:solidFill>
+                  <a:srgbClr val="1A1A1A"/>
+                </a:solidFill>
+                <a:latin typeface="Cambria" pitchFamily="34" charset="0"/>
+                <a:ea typeface="Cambria" pitchFamily="34" charset="-122"/>
+                <a:cs typeface="Cambria" pitchFamily="34" charset="-120"/>
+              </a:rPr>
+              <a:t>88,00</a:t>
+            </a:r>
+            <a:endParaRPr lang="en-US" sz="1190" dirty="0"/>
+          </a:p>
+        </p:txBody>
+      </p:sp>
+      <p:sp>
+        <p:nvSpPr>
+          <p:cNvPr id="35" name="Text 33"/>
+          <p:cNvSpPr/>
+          <p:nvPr/>
+        </p:nvSpPr>
+        <p:spPr>
+          <a:xfrm>
+            <a:off x="3218688" y="3063240"/>
+            <a:ext cx="1024128" cy="429768"/>
+          </a:xfrm>
+          <a:prstGeom prst="rect">
+            <a:avLst/>
+          </a:prstGeom>
+          <a:noFill/>
+          <a:ln/>
+        </p:spPr>
+        <p:txBody>
+          <a:bodyPr wrap="square" lIns="0" tIns="0" rIns="0" bIns="0" rtlCol="0" anchor="ctr">
+            <a:normAutofit/>
+          </a:bodyPr>
+          <a:lstStyle/>
+          <a:p>
+            <a:pPr algn="ctr" indent="0" marL="0">
+              <a:buNone/>
+            </a:pPr>
+            <a:r>
+              <a:rPr lang="en-US" sz="1190" dirty="0">
+                <a:solidFill>
+                  <a:srgbClr val="1A1A1A"/>
+                </a:solidFill>
+                <a:latin typeface="Cambria" pitchFamily="34" charset="0"/>
+                <a:ea typeface="Cambria" pitchFamily="34" charset="-122"/>
+                <a:cs typeface="Cambria" pitchFamily="34" charset="-120"/>
+              </a:rPr>
+              <a:t>416,12</a:t>
+            </a:r>
+            <a:endParaRPr lang="en-US" sz="1190" dirty="0"/>
+          </a:p>
+        </p:txBody>
+      </p:sp>
+      <p:sp>
+        <p:nvSpPr>
+          <p:cNvPr id="36" name="Text 34"/>
+          <p:cNvSpPr/>
+          <p:nvPr/>
+        </p:nvSpPr>
+        <p:spPr>
+          <a:xfrm>
+            <a:off x="4242816" y="3063240"/>
+            <a:ext cx="1298448" cy="429768"/>
+          </a:xfrm>
+          <a:prstGeom prst="rect">
+            <a:avLst/>
+          </a:prstGeom>
+          <a:noFill/>
+          <a:ln/>
+        </p:spPr>
+        <p:txBody>
+          <a:bodyPr wrap="square" lIns="0" tIns="0" rIns="0" bIns="0" rtlCol="0" anchor="ctr">
+            <a:normAutofit/>
+          </a:bodyPr>
+          <a:lstStyle/>
+          <a:p>
+            <a:pPr algn="ctr" indent="0" marL="0">
+              <a:buNone/>
+            </a:pPr>
+            <a:r>
+              <a:rPr lang="en-US" sz="1190" dirty="0">
+                <a:solidFill>
+                  <a:srgbClr val="1A1A1A"/>
+                </a:solidFill>
+                <a:latin typeface="Cambria" pitchFamily="34" charset="0"/>
+                <a:ea typeface="Cambria" pitchFamily="34" charset="-122"/>
+                <a:cs typeface="Cambria" pitchFamily="34" charset="-120"/>
+              </a:rPr>
+              <a:t>430,05</a:t>
+            </a:r>
+            <a:endParaRPr lang="en-US" sz="1190" dirty="0"/>
+          </a:p>
+        </p:txBody>
+      </p:sp>
+      <p:sp>
+        <p:nvSpPr>
+          <p:cNvPr id="37" name="Text 35"/>
+          <p:cNvSpPr/>
+          <p:nvPr/>
+        </p:nvSpPr>
+        <p:spPr>
+          <a:xfrm>
+            <a:off x="5541264" y="3063240"/>
+            <a:ext cx="1389888" cy="429768"/>
+          </a:xfrm>
+          <a:prstGeom prst="rect">
+            <a:avLst/>
+          </a:prstGeom>
+          <a:noFill/>
+          <a:ln/>
+        </p:spPr>
+        <p:txBody>
+          <a:bodyPr wrap="square" lIns="0" tIns="0" rIns="0" bIns="0" rtlCol="0" anchor="ctr">
+            <a:normAutofit/>
+          </a:bodyPr>
+          <a:lstStyle/>
+          <a:p>
+            <a:pPr algn="ctr" indent="0" marL="0">
+              <a:buNone/>
+            </a:pPr>
+            <a:r>
+              <a:rPr lang="en-US" sz="1190" dirty="0">
+                <a:solidFill>
+                  <a:srgbClr val="1A1A1A"/>
+                </a:solidFill>
+                <a:latin typeface="Cambria" pitchFamily="34" charset="0"/>
+                <a:ea typeface="Cambria" pitchFamily="34" charset="-122"/>
+                <a:cs typeface="Cambria" pitchFamily="34" charset="-120"/>
+              </a:rPr>
+              <a:t>442,02</a:t>
+            </a:r>
+            <a:endParaRPr lang="en-US" sz="1190" dirty="0"/>
+          </a:p>
+        </p:txBody>
+      </p:sp>
+      <p:sp>
+        <p:nvSpPr>
+          <p:cNvPr id="38" name="Text 36"/>
+          <p:cNvSpPr/>
+          <p:nvPr/>
+        </p:nvSpPr>
+        <p:spPr>
+          <a:xfrm>
+            <a:off x="6931152" y="3063240"/>
+            <a:ext cx="1234440" cy="429768"/>
+          </a:xfrm>
+          <a:prstGeom prst="rect">
+            <a:avLst/>
+          </a:prstGeom>
+          <a:noFill/>
+          <a:ln/>
+        </p:spPr>
+        <p:txBody>
+          <a:bodyPr wrap="square" lIns="0" tIns="0" rIns="0" bIns="0" rtlCol="0" anchor="ctr">
+            <a:normAutofit/>
+          </a:bodyPr>
+          <a:lstStyle/>
+          <a:p>
+            <a:pPr algn="ctr" indent="0" marL="0">
+              <a:buNone/>
+            </a:pPr>
+            <a:r>
+              <a:rPr lang="en-US" sz="1190" dirty="0">
+                <a:solidFill>
+                  <a:srgbClr val="1A1A1A"/>
+                </a:solidFill>
+                <a:latin typeface="Cambria" pitchFamily="34" charset="0"/>
+                <a:ea typeface="Cambria" pitchFamily="34" charset="-122"/>
+                <a:cs typeface="Cambria" pitchFamily="34" charset="-120"/>
+              </a:rPr>
+              <a:t>+11,98</a:t>
+            </a:r>
+            <a:endParaRPr lang="en-US" sz="1190" dirty="0"/>
+          </a:p>
+        </p:txBody>
+      </p:sp>
+      <p:sp>
+        <p:nvSpPr>
+          <p:cNvPr id="39" name="Shape 37"/>
+          <p:cNvSpPr/>
+          <p:nvPr/>
+        </p:nvSpPr>
+        <p:spPr>
+          <a:xfrm>
+            <a:off x="502920" y="3493008"/>
+            <a:ext cx="7662672" cy="0"/>
+          </a:xfrm>
+          <a:prstGeom prst="line">
+            <a:avLst/>
+          </a:prstGeom>
+          <a:noFill/>
+          <a:ln w="12700">
+            <a:solidFill>
+              <a:srgbClr val="D9D6DF"/>
+            </a:solidFill>
+            <a:prstDash val="solid"/>
+            <a:tailEnd type="none"/>
+          </a:ln>
+        </p:spPr>
+      </p:sp>
+      <p:sp>
+        <p:nvSpPr>
+          <p:cNvPr id="40" name="Text 38"/>
+          <p:cNvSpPr/>
+          <p:nvPr/>
+        </p:nvSpPr>
+        <p:spPr>
+          <a:xfrm>
+            <a:off x="502920" y="3493008"/>
+            <a:ext cx="1691640" cy="429768"/>
+          </a:xfrm>
+          <a:prstGeom prst="rect">
+            <a:avLst/>
+          </a:prstGeom>
+          <a:noFill/>
+          <a:ln/>
+        </p:spPr>
+        <p:txBody>
+          <a:bodyPr wrap="square" lIns="0" tIns="0" rIns="0" bIns="0" rtlCol="0" anchor="ctr">
+            <a:normAutofit/>
+          </a:bodyPr>
+          <a:lstStyle/>
+          <a:p>
+            <a:pPr algn="l" indent="0" marL="0">
+              <a:buNone/>
+            </a:pPr>
+            <a:r>
+              <a:rPr lang="en-US" sz="1190" dirty="0">
+                <a:solidFill>
+                  <a:srgbClr val="1A1A1A"/>
+                </a:solidFill>
+                <a:latin typeface="Cambria" pitchFamily="34" charset="0"/>
+                <a:ea typeface="Cambria" pitchFamily="34" charset="-122"/>
+                <a:cs typeface="Cambria" pitchFamily="34" charset="-120"/>
+              </a:rPr>
+              <a:t>SPICE</a:t>
+            </a:r>
+            <a:endParaRPr lang="en-US" sz="1190" dirty="0"/>
+          </a:p>
+        </p:txBody>
+      </p:sp>
+      <p:sp>
+        <p:nvSpPr>
+          <p:cNvPr id="41" name="Text 39"/>
+          <p:cNvSpPr/>
+          <p:nvPr/>
+        </p:nvSpPr>
+        <p:spPr>
+          <a:xfrm>
+            <a:off x="2194560" y="3493008"/>
+            <a:ext cx="1024128" cy="429768"/>
+          </a:xfrm>
+          <a:prstGeom prst="rect">
+            <a:avLst/>
+          </a:prstGeom>
+          <a:noFill/>
+          <a:ln/>
+        </p:spPr>
+        <p:txBody>
+          <a:bodyPr wrap="square" lIns="0" tIns="0" rIns="0" bIns="0" rtlCol="0" anchor="ctr">
+            <a:normAutofit/>
+          </a:bodyPr>
+          <a:lstStyle/>
+          <a:p>
+            <a:pPr algn="ctr" indent="0" marL="0">
+              <a:buNone/>
+            </a:pPr>
+            <a:r>
+              <a:rPr lang="en-US" sz="1190" dirty="0">
+                <a:solidFill>
+                  <a:srgbClr val="1A1A1A"/>
+                </a:solidFill>
+                <a:latin typeface="Cambria" pitchFamily="34" charset="0"/>
+                <a:ea typeface="Cambria" pitchFamily="34" charset="-122"/>
+                <a:cs typeface="Cambria" pitchFamily="34" charset="-120"/>
+              </a:rPr>
+              <a:t>18,50</a:t>
+            </a:r>
+            <a:endParaRPr lang="en-US" sz="1190" dirty="0"/>
+          </a:p>
+        </p:txBody>
+      </p:sp>
+      <p:sp>
+        <p:nvSpPr>
+          <p:cNvPr id="42" name="Text 40"/>
+          <p:cNvSpPr/>
+          <p:nvPr/>
+        </p:nvSpPr>
+        <p:spPr>
+          <a:xfrm>
+            <a:off x="3218688" y="3493008"/>
+            <a:ext cx="1024128" cy="429768"/>
+          </a:xfrm>
+          <a:prstGeom prst="rect">
+            <a:avLst/>
+          </a:prstGeom>
+          <a:noFill/>
+          <a:ln/>
+        </p:spPr>
+        <p:txBody>
+          <a:bodyPr wrap="square" lIns="0" tIns="0" rIns="0" bIns="0" rtlCol="0" anchor="ctr">
+            <a:normAutofit/>
+          </a:bodyPr>
+          <a:lstStyle/>
+          <a:p>
+            <a:pPr algn="ctr" indent="0" marL="0">
+              <a:buNone/>
+            </a:pPr>
+            <a:r>
+              <a:rPr lang="en-US" sz="1190" dirty="0">
+                <a:solidFill>
+                  <a:srgbClr val="1A1A1A"/>
+                </a:solidFill>
+                <a:latin typeface="Cambria" pitchFamily="34" charset="0"/>
+                <a:ea typeface="Cambria" pitchFamily="34" charset="-122"/>
+                <a:cs typeface="Cambria" pitchFamily="34" charset="-120"/>
+              </a:rPr>
+              <a:t>44,37</a:t>
+            </a:r>
+            <a:endParaRPr lang="en-US" sz="1190" dirty="0"/>
+          </a:p>
+        </p:txBody>
+      </p:sp>
+      <p:sp>
+        <p:nvSpPr>
+          <p:cNvPr id="43" name="Text 41"/>
+          <p:cNvSpPr/>
+          <p:nvPr/>
+        </p:nvSpPr>
+        <p:spPr>
+          <a:xfrm>
+            <a:off x="4242816" y="3493008"/>
+            <a:ext cx="1298448" cy="429768"/>
+          </a:xfrm>
+          <a:prstGeom prst="rect">
+            <a:avLst/>
+          </a:prstGeom>
+          <a:noFill/>
+          <a:ln/>
+        </p:spPr>
+        <p:txBody>
+          <a:bodyPr wrap="square" lIns="0" tIns="0" rIns="0" bIns="0" rtlCol="0" anchor="ctr">
+            <a:normAutofit/>
+          </a:bodyPr>
+          <a:lstStyle/>
+          <a:p>
+            <a:pPr algn="ctr" indent="0" marL="0">
+              <a:buNone/>
+            </a:pPr>
+            <a:r>
+              <a:rPr lang="en-US" sz="1190" dirty="0">
+                <a:solidFill>
+                  <a:srgbClr val="1A1A1A"/>
+                </a:solidFill>
+                <a:latin typeface="Cambria" pitchFamily="34" charset="0"/>
+                <a:ea typeface="Cambria" pitchFamily="34" charset="-122"/>
+                <a:cs typeface="Cambria" pitchFamily="34" charset="-120"/>
+              </a:rPr>
+              <a:t>45,79</a:t>
+            </a:r>
+            <a:endParaRPr lang="en-US" sz="1190" dirty="0"/>
+          </a:p>
+        </p:txBody>
+      </p:sp>
+      <p:sp>
+        <p:nvSpPr>
+          <p:cNvPr id="44" name="Text 42"/>
+          <p:cNvSpPr/>
+          <p:nvPr/>
+        </p:nvSpPr>
+        <p:spPr>
+          <a:xfrm>
+            <a:off x="5541264" y="3493008"/>
+            <a:ext cx="1389888" cy="429768"/>
+          </a:xfrm>
+          <a:prstGeom prst="rect">
+            <a:avLst/>
+          </a:prstGeom>
+          <a:noFill/>
+          <a:ln/>
+        </p:spPr>
+        <p:txBody>
+          <a:bodyPr wrap="square" lIns="0" tIns="0" rIns="0" bIns="0" rtlCol="0" anchor="ctr">
+            <a:normAutofit/>
+          </a:bodyPr>
+          <a:lstStyle/>
+          <a:p>
+            <a:pPr algn="ctr" indent="0" marL="0">
+              <a:buNone/>
+            </a:pPr>
+            <a:r>
+              <a:rPr lang="en-US" sz="1190" dirty="0">
+                <a:solidFill>
+                  <a:srgbClr val="1A1A1A"/>
+                </a:solidFill>
+                <a:latin typeface="Cambria" pitchFamily="34" charset="0"/>
+                <a:ea typeface="Cambria" pitchFamily="34" charset="-122"/>
+                <a:cs typeface="Cambria" pitchFamily="34" charset="-120"/>
+              </a:rPr>
+              <a:t>47,13</a:t>
+            </a:r>
+            <a:endParaRPr lang="en-US" sz="1190" dirty="0"/>
+          </a:p>
+        </p:txBody>
+      </p:sp>
+      <p:sp>
+        <p:nvSpPr>
+          <p:cNvPr id="45" name="Text 43"/>
+          <p:cNvSpPr/>
+          <p:nvPr/>
+        </p:nvSpPr>
+        <p:spPr>
+          <a:xfrm>
+            <a:off x="6931152" y="3493008"/>
+            <a:ext cx="1234440" cy="429768"/>
+          </a:xfrm>
+          <a:prstGeom prst="rect">
+            <a:avLst/>
+          </a:prstGeom>
+          <a:noFill/>
+          <a:ln/>
+        </p:spPr>
+        <p:txBody>
+          <a:bodyPr wrap="square" lIns="0" tIns="0" rIns="0" bIns="0" rtlCol="0" anchor="ctr">
+            <a:normAutofit/>
+          </a:bodyPr>
+          <a:lstStyle/>
+          <a:p>
+            <a:pPr algn="ctr" indent="0" marL="0">
+              <a:buNone/>
+            </a:pPr>
+            <a:r>
+              <a:rPr lang="en-US" sz="1190" dirty="0">
+                <a:solidFill>
+                  <a:srgbClr val="1A1A1A"/>
+                </a:solidFill>
+                <a:latin typeface="Cambria" pitchFamily="34" charset="0"/>
+                <a:ea typeface="Cambria" pitchFamily="34" charset="-122"/>
+                <a:cs typeface="Cambria" pitchFamily="34" charset="-120"/>
+              </a:rPr>
+              <a:t>+1,34</a:t>
+            </a:r>
+            <a:endParaRPr lang="en-US" sz="1190" dirty="0"/>
+          </a:p>
+        </p:txBody>
+      </p:sp>
+      <p:sp>
+        <p:nvSpPr>
+          <p:cNvPr id="46" name="Shape 44"/>
+          <p:cNvSpPr/>
+          <p:nvPr/>
+        </p:nvSpPr>
+        <p:spPr>
+          <a:xfrm>
+            <a:off x="502920" y="3922776"/>
+            <a:ext cx="7662672" cy="0"/>
+          </a:xfrm>
+          <a:prstGeom prst="line">
+            <a:avLst/>
+          </a:prstGeom>
+          <a:noFill/>
+          <a:ln w="12700">
+            <a:solidFill>
+              <a:srgbClr val="D9D6DF"/>
+            </a:solidFill>
+            <a:prstDash val="solid"/>
+            <a:tailEnd type="none"/>
+          </a:ln>
+        </p:spPr>
+      </p:sp>
+      <p:sp>
+        <p:nvSpPr>
+          <p:cNvPr id="47" name="Text 45"/>
+          <p:cNvSpPr/>
+          <p:nvPr/>
+        </p:nvSpPr>
+        <p:spPr>
+          <a:xfrm>
+            <a:off x="502920" y="3922776"/>
+            <a:ext cx="1691640" cy="429768"/>
+          </a:xfrm>
+          <a:prstGeom prst="rect">
+            <a:avLst/>
+          </a:prstGeom>
+          <a:noFill/>
+          <a:ln/>
+        </p:spPr>
+        <p:txBody>
+          <a:bodyPr wrap="square" lIns="0" tIns="0" rIns="0" bIns="0" rtlCol="0" anchor="ctr">
+            <a:normAutofit/>
+          </a:bodyPr>
+          <a:lstStyle/>
+          <a:p>
+            <a:pPr algn="l" indent="0" marL="0">
+              <a:buNone/>
+            </a:pPr>
+            <a:r>
+              <a:rPr lang="en-US" sz="1190" dirty="0">
+                <a:solidFill>
+                  <a:srgbClr val="1A1A1A"/>
+                </a:solidFill>
+                <a:latin typeface="Cambria" pitchFamily="34" charset="0"/>
+                <a:ea typeface="Cambria" pitchFamily="34" charset="-122"/>
+                <a:cs typeface="Cambria" pitchFamily="34" charset="-120"/>
+              </a:rPr>
+              <a:t>chrF</a:t>
+            </a:r>
+            <a:endParaRPr lang="en-US" sz="1190" dirty="0"/>
+          </a:p>
+        </p:txBody>
+      </p:sp>
+      <p:sp>
+        <p:nvSpPr>
+          <p:cNvPr id="48" name="Text 46"/>
+          <p:cNvSpPr/>
+          <p:nvPr/>
+        </p:nvSpPr>
+        <p:spPr>
+          <a:xfrm>
+            <a:off x="2194560" y="3922776"/>
+            <a:ext cx="1024128" cy="429768"/>
+          </a:xfrm>
+          <a:prstGeom prst="rect">
+            <a:avLst/>
+          </a:prstGeom>
+          <a:noFill/>
+          <a:ln/>
+        </p:spPr>
+        <p:txBody>
+          <a:bodyPr wrap="square" lIns="0" tIns="0" rIns="0" bIns="0" rtlCol="0" anchor="ctr">
+            <a:normAutofit/>
+          </a:bodyPr>
+          <a:lstStyle/>
+          <a:p>
+            <a:pPr algn="ctr" indent="0" marL="0">
+              <a:buNone/>
+            </a:pPr>
+            <a:r>
+              <a:rPr lang="en-US" sz="1190" dirty="0">
+                <a:solidFill>
+                  <a:srgbClr val="1A1A1A"/>
+                </a:solidFill>
+                <a:latin typeface="Cambria" pitchFamily="34" charset="0"/>
+                <a:ea typeface="Cambria" pitchFamily="34" charset="-122"/>
+                <a:cs typeface="Cambria" pitchFamily="34" charset="-120"/>
+              </a:rPr>
+              <a:t>40,20</a:t>
+            </a:r>
+            <a:endParaRPr lang="en-US" sz="1190" dirty="0"/>
+          </a:p>
+        </p:txBody>
+      </p:sp>
+      <p:sp>
+        <p:nvSpPr>
+          <p:cNvPr id="49" name="Text 47"/>
+          <p:cNvSpPr/>
+          <p:nvPr/>
+        </p:nvSpPr>
+        <p:spPr>
+          <a:xfrm>
+            <a:off x="3218688" y="3922776"/>
+            <a:ext cx="1024128" cy="429768"/>
+          </a:xfrm>
+          <a:prstGeom prst="rect">
+            <a:avLst/>
+          </a:prstGeom>
+          <a:noFill/>
+          <a:ln/>
+        </p:spPr>
+        <p:txBody>
+          <a:bodyPr wrap="square" lIns="0" tIns="0" rIns="0" bIns="0" rtlCol="0" anchor="ctr">
+            <a:normAutofit/>
+          </a:bodyPr>
+          <a:lstStyle/>
+          <a:p>
+            <a:pPr algn="ctr" indent="0" marL="0">
+              <a:buNone/>
+            </a:pPr>
+            <a:r>
+              <a:rPr lang="en-US" sz="1190" dirty="0">
+                <a:solidFill>
+                  <a:srgbClr val="1A1A1A"/>
+                </a:solidFill>
+                <a:latin typeface="Cambria" pitchFamily="34" charset="0"/>
+                <a:ea typeface="Cambria" pitchFamily="34" charset="-122"/>
+                <a:cs typeface="Cambria" pitchFamily="34" charset="-120"/>
+              </a:rPr>
+              <a:t>61,26</a:t>
+            </a:r>
+            <a:endParaRPr lang="en-US" sz="1190" dirty="0"/>
+          </a:p>
+        </p:txBody>
+      </p:sp>
+      <p:sp>
+        <p:nvSpPr>
+          <p:cNvPr id="50" name="Text 48"/>
+          <p:cNvSpPr/>
+          <p:nvPr/>
+        </p:nvSpPr>
+        <p:spPr>
+          <a:xfrm>
+            <a:off x="4242816" y="3922776"/>
+            <a:ext cx="1298448" cy="429768"/>
+          </a:xfrm>
+          <a:prstGeom prst="rect">
+            <a:avLst/>
+          </a:prstGeom>
+          <a:noFill/>
+          <a:ln/>
+        </p:spPr>
+        <p:txBody>
+          <a:bodyPr wrap="square" lIns="0" tIns="0" rIns="0" bIns="0" rtlCol="0" anchor="ctr">
+            <a:normAutofit/>
+          </a:bodyPr>
+          <a:lstStyle/>
+          <a:p>
+            <a:pPr algn="ctr" indent="0" marL="0">
+              <a:buNone/>
+            </a:pPr>
+            <a:r>
+              <a:rPr lang="en-US" sz="1190" dirty="0">
+                <a:solidFill>
+                  <a:srgbClr val="1A1A1A"/>
+                </a:solidFill>
+                <a:latin typeface="Cambria" pitchFamily="34" charset="0"/>
+                <a:ea typeface="Cambria" pitchFamily="34" charset="-122"/>
+                <a:cs typeface="Cambria" pitchFamily="34" charset="-120"/>
+              </a:rPr>
+              <a:t>62,87</a:t>
+            </a:r>
+            <a:endParaRPr lang="en-US" sz="1190" dirty="0"/>
+          </a:p>
+        </p:txBody>
+      </p:sp>
+      <p:sp>
+        <p:nvSpPr>
+          <p:cNvPr id="51" name="Text 49"/>
+          <p:cNvSpPr/>
+          <p:nvPr/>
+        </p:nvSpPr>
+        <p:spPr>
+          <a:xfrm>
+            <a:off x="5541264" y="3922776"/>
+            <a:ext cx="1389888" cy="429768"/>
+          </a:xfrm>
+          <a:prstGeom prst="rect">
+            <a:avLst/>
+          </a:prstGeom>
+          <a:noFill/>
+          <a:ln/>
+        </p:spPr>
+        <p:txBody>
+          <a:bodyPr wrap="square" lIns="0" tIns="0" rIns="0" bIns="0" rtlCol="0" anchor="ctr">
+            <a:normAutofit/>
+          </a:bodyPr>
+          <a:lstStyle/>
+          <a:p>
+            <a:pPr algn="ctr" indent="0" marL="0">
+              <a:buNone/>
+            </a:pPr>
+            <a:r>
+              <a:rPr lang="en-US" sz="1190" dirty="0">
+                <a:solidFill>
+                  <a:srgbClr val="1A1A1A"/>
+                </a:solidFill>
+                <a:latin typeface="Cambria" pitchFamily="34" charset="0"/>
+                <a:ea typeface="Cambria" pitchFamily="34" charset="-122"/>
+                <a:cs typeface="Cambria" pitchFamily="34" charset="-120"/>
+              </a:rPr>
+              <a:t>63,44</a:t>
+            </a:r>
+            <a:endParaRPr lang="en-US" sz="1190" dirty="0"/>
+          </a:p>
+        </p:txBody>
+      </p:sp>
+      <p:sp>
+        <p:nvSpPr>
+          <p:cNvPr id="52" name="Text 50"/>
+          <p:cNvSpPr/>
+          <p:nvPr/>
+        </p:nvSpPr>
+        <p:spPr>
+          <a:xfrm>
+            <a:off x="6931152" y="3922776"/>
+            <a:ext cx="1234440" cy="429768"/>
+          </a:xfrm>
+          <a:prstGeom prst="rect">
+            <a:avLst/>
+          </a:prstGeom>
+          <a:noFill/>
+          <a:ln/>
+        </p:spPr>
+        <p:txBody>
+          <a:bodyPr wrap="square" lIns="0" tIns="0" rIns="0" bIns="0" rtlCol="0" anchor="ctr">
+            <a:normAutofit/>
+          </a:bodyPr>
+          <a:lstStyle/>
+          <a:p>
+            <a:pPr algn="ctr" indent="0" marL="0">
+              <a:buNone/>
+            </a:pPr>
+            <a:r>
+              <a:rPr lang="en-US" sz="1190" dirty="0">
+                <a:solidFill>
+                  <a:srgbClr val="1A1A1A"/>
+                </a:solidFill>
+                <a:latin typeface="Cambria" pitchFamily="34" charset="0"/>
+                <a:ea typeface="Cambria" pitchFamily="34" charset="-122"/>
+                <a:cs typeface="Cambria" pitchFamily="34" charset="-120"/>
+              </a:rPr>
+              <a:t>+0,58</a:t>
+            </a:r>
+            <a:endParaRPr lang="en-US" sz="1190" dirty="0"/>
+          </a:p>
+        </p:txBody>
+      </p:sp>
+      <p:sp>
+        <p:nvSpPr>
+          <p:cNvPr id="53" name="Shape 51"/>
+          <p:cNvSpPr/>
+          <p:nvPr/>
+        </p:nvSpPr>
+        <p:spPr>
+          <a:xfrm>
+            <a:off x="502920" y="4352544"/>
+            <a:ext cx="7662672" cy="0"/>
+          </a:xfrm>
+          <a:prstGeom prst="line">
+            <a:avLst/>
+          </a:prstGeom>
+          <a:noFill/>
+          <a:ln w="12700">
+            <a:solidFill>
+              <a:srgbClr val="D9D6DF"/>
+            </a:solidFill>
+            <a:prstDash val="solid"/>
+            <a:tailEnd type="none"/>
+          </a:ln>
+        </p:spPr>
+      </p:sp>
+      <p:sp>
+        <p:nvSpPr>
+          <p:cNvPr id="54" name="Text 52"/>
+          <p:cNvSpPr/>
+          <p:nvPr/>
+        </p:nvSpPr>
+        <p:spPr>
+          <a:xfrm>
+            <a:off x="502920" y="4352544"/>
+            <a:ext cx="1691640" cy="429768"/>
+          </a:xfrm>
+          <a:prstGeom prst="rect">
+            <a:avLst/>
+          </a:prstGeom>
+          <a:noFill/>
+          <a:ln/>
+        </p:spPr>
+        <p:txBody>
+          <a:bodyPr wrap="square" lIns="0" tIns="0" rIns="0" bIns="0" rtlCol="0" anchor="ctr">
+            <a:normAutofit/>
+          </a:bodyPr>
+          <a:lstStyle/>
+          <a:p>
+            <a:pPr algn="l" indent="0" marL="0">
+              <a:buNone/>
+            </a:pPr>
+            <a:r>
+              <a:rPr lang="en-US" sz="1190" dirty="0">
+                <a:solidFill>
+                  <a:srgbClr val="1A1A1A"/>
+                </a:solidFill>
+                <a:latin typeface="Cambria" pitchFamily="34" charset="0"/>
+                <a:ea typeface="Cambria" pitchFamily="34" charset="-122"/>
+                <a:cs typeface="Cambria" pitchFamily="34" charset="-120"/>
+              </a:rPr>
               <a:t>BERTScore</a:t>
             </a:r>
-            <a:endParaRPr lang="en-US" sz="1250" dirty="0"/>
-          </a:p>
-        </p:txBody>
-      </p:sp>
-      <p:sp>
-        <p:nvSpPr>
-          <p:cNvPr id="11" name="Shape 9"/>
-          <p:cNvSpPr/>
-          <p:nvPr/>
-        </p:nvSpPr>
-        <p:spPr>
-          <a:xfrm>
-            <a:off x="960120" y="3383280"/>
-            <a:ext cx="7223760" cy="960120"/>
+            <a:endParaRPr lang="en-US" sz="1190" dirty="0"/>
+          </a:p>
+        </p:txBody>
+      </p:sp>
+      <p:sp>
+        <p:nvSpPr>
+          <p:cNvPr id="55" name="Text 53"/>
+          <p:cNvSpPr/>
+          <p:nvPr/>
+        </p:nvSpPr>
+        <p:spPr>
+          <a:xfrm>
+            <a:off x="2194560" y="4352544"/>
+            <a:ext cx="1024128" cy="429768"/>
+          </a:xfrm>
+          <a:prstGeom prst="rect">
+            <a:avLst/>
+          </a:prstGeom>
+          <a:noFill/>
+          <a:ln/>
+        </p:spPr>
+        <p:txBody>
+          <a:bodyPr wrap="square" lIns="0" tIns="0" rIns="0" bIns="0" rtlCol="0" anchor="ctr">
+            <a:normAutofit/>
+          </a:bodyPr>
+          <a:lstStyle/>
+          <a:p>
+            <a:pPr algn="ctr" indent="0" marL="0">
+              <a:buNone/>
+            </a:pPr>
+            <a:r>
+              <a:rPr lang="en-US" sz="1190" dirty="0">
+                <a:solidFill>
+                  <a:srgbClr val="1A1A1A"/>
+                </a:solidFill>
+                <a:latin typeface="Cambria" pitchFamily="34" charset="0"/>
+                <a:ea typeface="Cambria" pitchFamily="34" charset="-122"/>
+                <a:cs typeface="Cambria" pitchFamily="34" charset="-120"/>
+              </a:rPr>
+              <a:t>40,10</a:t>
+            </a:r>
+            <a:endParaRPr lang="en-US" sz="1190" dirty="0"/>
+          </a:p>
+        </p:txBody>
+      </p:sp>
+      <p:sp>
+        <p:nvSpPr>
+          <p:cNvPr id="56" name="Text 54"/>
+          <p:cNvSpPr/>
+          <p:nvPr/>
+        </p:nvSpPr>
+        <p:spPr>
+          <a:xfrm>
+            <a:off x="3218688" y="4352544"/>
+            <a:ext cx="1024128" cy="429768"/>
+          </a:xfrm>
+          <a:prstGeom prst="rect">
+            <a:avLst/>
+          </a:prstGeom>
+          <a:noFill/>
+          <a:ln/>
+        </p:spPr>
+        <p:txBody>
+          <a:bodyPr wrap="square" lIns="0" tIns="0" rIns="0" bIns="0" rtlCol="0" anchor="ctr">
+            <a:normAutofit/>
+          </a:bodyPr>
+          <a:lstStyle/>
+          <a:p>
+            <a:pPr algn="ctr" indent="0" marL="0">
+              <a:buNone/>
+            </a:pPr>
+            <a:r>
+              <a:rPr lang="en-US" sz="1190" dirty="0">
+                <a:solidFill>
+                  <a:srgbClr val="1A1A1A"/>
+                </a:solidFill>
+                <a:latin typeface="Cambria" pitchFamily="34" charset="0"/>
+                <a:ea typeface="Cambria" pitchFamily="34" charset="-122"/>
+                <a:cs typeface="Cambria" pitchFamily="34" charset="-120"/>
+              </a:rPr>
+              <a:t>66,33</a:t>
+            </a:r>
+            <a:endParaRPr lang="en-US" sz="1190" dirty="0"/>
+          </a:p>
+        </p:txBody>
+      </p:sp>
+      <p:sp>
+        <p:nvSpPr>
+          <p:cNvPr id="57" name="Text 55"/>
+          <p:cNvSpPr/>
+          <p:nvPr/>
+        </p:nvSpPr>
+        <p:spPr>
+          <a:xfrm>
+            <a:off x="4242816" y="4352544"/>
+            <a:ext cx="1298448" cy="429768"/>
+          </a:xfrm>
+          <a:prstGeom prst="rect">
+            <a:avLst/>
+          </a:prstGeom>
+          <a:noFill/>
+          <a:ln/>
+        </p:spPr>
+        <p:txBody>
+          <a:bodyPr wrap="square" lIns="0" tIns="0" rIns="0" bIns="0" rtlCol="0" anchor="ctr">
+            <a:normAutofit/>
+          </a:bodyPr>
+          <a:lstStyle/>
+          <a:p>
+            <a:pPr algn="ctr" indent="0" marL="0">
+              <a:buNone/>
+            </a:pPr>
+            <a:r>
+              <a:rPr lang="en-US" sz="1190" dirty="0">
+                <a:solidFill>
+                  <a:srgbClr val="1A1A1A"/>
+                </a:solidFill>
+                <a:latin typeface="Cambria" pitchFamily="34" charset="0"/>
+                <a:ea typeface="Cambria" pitchFamily="34" charset="-122"/>
+                <a:cs typeface="Cambria" pitchFamily="34" charset="-120"/>
+              </a:rPr>
+              <a:t>67,07</a:t>
+            </a:r>
+            <a:endParaRPr lang="en-US" sz="1190" dirty="0"/>
+          </a:p>
+        </p:txBody>
+      </p:sp>
+      <p:sp>
+        <p:nvSpPr>
+          <p:cNvPr id="58" name="Text 56"/>
+          <p:cNvSpPr/>
+          <p:nvPr/>
+        </p:nvSpPr>
+        <p:spPr>
+          <a:xfrm>
+            <a:off x="5541264" y="4352544"/>
+            <a:ext cx="1389888" cy="429768"/>
+          </a:xfrm>
+          <a:prstGeom prst="rect">
+            <a:avLst/>
+          </a:prstGeom>
+          <a:noFill/>
+          <a:ln/>
+        </p:spPr>
+        <p:txBody>
+          <a:bodyPr wrap="square" lIns="0" tIns="0" rIns="0" bIns="0" rtlCol="0" anchor="ctr">
+            <a:normAutofit/>
+          </a:bodyPr>
+          <a:lstStyle/>
+          <a:p>
+            <a:pPr algn="ctr" indent="0" marL="0">
+              <a:buNone/>
+            </a:pPr>
+            <a:r>
+              <a:rPr lang="en-US" sz="1190" dirty="0">
+                <a:solidFill>
+                  <a:srgbClr val="1A1A1A"/>
+                </a:solidFill>
+                <a:latin typeface="Cambria" pitchFamily="34" charset="0"/>
+                <a:ea typeface="Cambria" pitchFamily="34" charset="-122"/>
+                <a:cs typeface="Cambria" pitchFamily="34" charset="-120"/>
+              </a:rPr>
+              <a:t>67,73</a:t>
+            </a:r>
+            <a:endParaRPr lang="en-US" sz="1190" dirty="0"/>
+          </a:p>
+        </p:txBody>
+      </p:sp>
+      <p:sp>
+        <p:nvSpPr>
+          <p:cNvPr id="59" name="Text 57"/>
+          <p:cNvSpPr/>
+          <p:nvPr/>
+        </p:nvSpPr>
+        <p:spPr>
+          <a:xfrm>
+            <a:off x="6931152" y="4352544"/>
+            <a:ext cx="1234440" cy="429768"/>
+          </a:xfrm>
+          <a:prstGeom prst="rect">
+            <a:avLst/>
+          </a:prstGeom>
+          <a:noFill/>
+          <a:ln/>
+        </p:spPr>
+        <p:txBody>
+          <a:bodyPr wrap="square" lIns="0" tIns="0" rIns="0" bIns="0" rtlCol="0" anchor="ctr">
+            <a:normAutofit/>
+          </a:bodyPr>
+          <a:lstStyle/>
+          <a:p>
+            <a:pPr algn="ctr" indent="0" marL="0">
+              <a:buNone/>
+            </a:pPr>
+            <a:r>
+              <a:rPr lang="en-US" sz="1190" dirty="0">
+                <a:solidFill>
+                  <a:srgbClr val="1A1A1A"/>
+                </a:solidFill>
+                <a:latin typeface="Cambria" pitchFamily="34" charset="0"/>
+                <a:ea typeface="Cambria" pitchFamily="34" charset="-122"/>
+                <a:cs typeface="Cambria" pitchFamily="34" charset="-120"/>
+              </a:rPr>
+              <a:t>+0,66</a:t>
+            </a:r>
+            <a:endParaRPr lang="en-US" sz="1190" dirty="0"/>
+          </a:p>
+        </p:txBody>
+      </p:sp>
+      <p:sp>
+        <p:nvSpPr>
+          <p:cNvPr id="60" name="Shape 58"/>
+          <p:cNvSpPr/>
+          <p:nvPr/>
+        </p:nvSpPr>
+        <p:spPr>
+          <a:xfrm>
+            <a:off x="502920" y="5010912"/>
+            <a:ext cx="8138160" cy="749808"/>
           </a:xfrm>
           <a:prstGeom prst="roundRect">
             <a:avLst/>
@@ -15804,14 +17703,14 @@
       </p:sp>
       <p:sp>
         <p:nvSpPr>
-          <p:cNvPr id="12" name="Text 10"/>
-          <p:cNvSpPr/>
-          <p:nvPr/>
-        </p:nvSpPr>
-        <p:spPr>
-          <a:xfrm>
-            <a:off x="1170432" y="3383280"/>
-            <a:ext cx="6803136" cy="960120"/>
+          <p:cNvPr id="61" name="Text 59"/>
+          <p:cNvSpPr/>
+          <p:nvPr/>
+        </p:nvSpPr>
+        <p:spPr>
+          <a:xfrm>
+            <a:off x="667512" y="5010912"/>
+            <a:ext cx="7808976" cy="749808"/>
           </a:xfrm>
           <a:prstGeom prst="rect">
             <a:avLst/>
@@ -15829,7 +17728,7 @@
               <a:buNone/>
             </a:pPr>
             <a:r>
-              <a:rPr lang="en-US" sz="1550" b="1" dirty="0">
+              <a:rPr lang="en-US" sz="1340" b="1" dirty="0">
                 <a:solidFill>
                   <a:srgbClr val="25194B"/>
                 </a:solidFill>
@@ -15837,22 +17736,22 @@
                 <a:ea typeface="Cambria" pitchFamily="34" charset="-122"/>
                 <a:cs typeface="Cambria" pitchFamily="34" charset="-120"/>
               </a:rPr>
-              <a:t>BLEU-4, METEOR, ROUGE-L và chrF cũng tăng → 7/7 thước đo dựa trên câu tham chiếu đều tăng.</a:t>
-            </a:r>
-            <a:endParaRPr lang="en-US" sz="1550" dirty="0"/>
-          </a:p>
-        </p:txBody>
-      </p:sp>
-      <p:sp>
-        <p:nvSpPr>
-          <p:cNvPr id="13" name="Text 11"/>
-          <p:cNvSpPr/>
-          <p:nvPr/>
-        </p:nvSpPr>
-        <p:spPr>
-          <a:xfrm>
-            <a:off x="502920" y="4828032"/>
-            <a:ext cx="8138160" cy="713232"/>
+              <a:t>ACE làm cả 7 thước đo văn bản tăng; Executability gần như giữ nguyên: +0,02 điểm, KTC 95% [−0,21; +0,26].</a:t>
+            </a:r>
+            <a:endParaRPr lang="en-US" sz="1340" dirty="0"/>
+          </a:p>
+        </p:txBody>
+      </p:sp>
+      <p:sp>
+        <p:nvSpPr>
+          <p:cNvPr id="62" name="Text 60"/>
+          <p:cNvSpPr/>
+          <p:nvPr/>
+        </p:nvSpPr>
+        <p:spPr>
+          <a:xfrm>
+            <a:off x="502920" y="5879592"/>
+            <a:ext cx="8138160" cy="274320"/>
           </a:xfrm>
           <a:prstGeom prst="rect">
             <a:avLst/>
@@ -15870,23 +17769,23 @@
               <a:buNone/>
             </a:pPr>
             <a:r>
-              <a:rPr lang="en-US" sz="1460" dirty="0">
-                <a:solidFill>
-                  <a:srgbClr val="1A1A1A"/>
-                </a:solidFill>
-                <a:latin typeface="Cambria" pitchFamily="34" charset="0"/>
-                <a:ea typeface="Cambria" pitchFamily="34" charset="-122"/>
-                <a:cs typeface="Cambria" pitchFamily="34" charset="-120"/>
-              </a:rPr>
-              <a:t>Executability chỉ thay đổi +0,02 điểm [−0,21; +0,26]. Các mức tăng của 7 thước đo văn bản hiện chưa có khoảng tin cậy.</a:t>
-            </a:r>
-            <a:endParaRPr lang="en-US" sz="1460" dirty="0"/>
-          </a:p>
-        </p:txBody>
-      </p:sp>
-      <p:sp>
-        <p:nvSpPr>
-          <p:cNvPr id="14" name="Text 12"/>
+              <a:rPr lang="en-US" sz="1080" dirty="0">
+                <a:solidFill>
+                  <a:srgbClr val="5A5A66"/>
+                </a:solidFill>
+                <a:latin typeface="Cambria" pitchFamily="34" charset="0"/>
+                <a:ea typeface="Cambria" pitchFamily="34" charset="-122"/>
+                <a:cs typeface="Cambria" pitchFamily="34" charset="-120"/>
+              </a:rPr>
+              <a:t>Lưu ý: các mức tăng của 7 thước đo văn bản hiện chưa có khoảng tin cậy.</a:t>
+            </a:r>
+            <a:endParaRPr lang="en-US" sz="1080" dirty="0"/>
+          </a:p>
+        </p:txBody>
+      </p:sp>
+      <p:sp>
+        <p:nvSpPr>
+          <p:cNvPr id="63" name="Text 61"/>
           <p:cNvSpPr/>
           <p:nvPr/>
         </p:nvSpPr>
@@ -15917,7 +17816,7 @@
                 <a:ea typeface="Cambria" pitchFamily="34" charset="-122"/>
                 <a:cs typeface="Cambria" pitchFamily="34" charset="-120"/>
               </a:rPr>
-              <a:t>Bảng đầy đủ ở slide bổ sung · Luận văn §6.4, §6.6</a:t>
+              <a:t>Luận văn §6.4, §6.6</a:t>
             </a:r>
             <a:endParaRPr lang="en-US" sz="800" dirty="0"/>
           </a:p>
@@ -15925,7 +17824,7 @@
       </p:sp>
       <p:sp>
         <p:nvSpPr>
-          <p:cNvPr id="15" name="Shape 13"/>
+          <p:cNvPr id="64" name="Shape 62"/>
           <p:cNvSpPr/>
           <p:nvPr/>
         </p:nvSpPr>
@@ -15952,7 +17851,7 @@
       </p:sp>
       <p:sp>
         <p:nvSpPr>
-          <p:cNvPr id="16" name="Shape 14"/>
+          <p:cNvPr id="65" name="Shape 63"/>
           <p:cNvSpPr/>
           <p:nvPr/>
         </p:nvSpPr>
@@ -15979,7 +17878,7 @@
       </p:sp>
       <p:sp>
         <p:nvSpPr>
-          <p:cNvPr id="17" name="Shape 15"/>
+          <p:cNvPr id="66" name="Shape 64"/>
           <p:cNvSpPr/>
           <p:nvPr/>
         </p:nvSpPr>
@@ -16006,7 +17905,7 @@
       </p:sp>
       <p:sp>
         <p:nvSpPr>
-          <p:cNvPr id="18" name="Shape 16"/>
+          <p:cNvPr id="67" name="Shape 65"/>
           <p:cNvSpPr/>
           <p:nvPr/>
         </p:nvSpPr>
@@ -16033,7 +17932,7 @@
       </p:sp>
       <p:sp>
         <p:nvSpPr>
-          <p:cNvPr id="19" name="Text 17"/>
+          <p:cNvPr id="68" name="Text 66"/>
           <p:cNvSpPr/>
           <p:nvPr/>
         </p:nvSpPr>
@@ -16072,7 +17971,7 @@
       </p:sp>
       <p:sp>
         <p:nvSpPr>
-          <p:cNvPr id="20" name="Text 18"/>
+          <p:cNvPr id="69" name="Text 67"/>
           <p:cNvSpPr/>
           <p:nvPr/>
         </p:nvSpPr>
@@ -16111,7 +18010,7 @@
       </p:sp>
       <p:sp>
         <p:nvSpPr>
-          <p:cNvPr id="21" name="Text 19"/>
+          <p:cNvPr id="70" name="Text 68"/>
           <p:cNvSpPr/>
           <p:nvPr/>
         </p:nvSpPr>
@@ -16150,7 +18049,7 @@
       </p:sp>
       <p:sp>
         <p:nvSpPr>
-          <p:cNvPr id="22" name="Text 20"/>
+          <p:cNvPr id="71" name="Text 69"/>
           <p:cNvSpPr/>
           <p:nvPr/>
         </p:nvSpPr>

</xml_diff>

<commit_message>
Luận văn: cập nhật các chương, dựng lại PDF (148 trang) và PDF từng chương; slide bảo vệ rút gọn
Co-Authored-By: Claude Opus 5.5 <noreply@anthropic.com>
</commit_message>
<xml_diff>
--- a/slides/LUAN_VAN_SLIDE_BAO_VE_CONCISE.pptx
+++ b/slides/LUAN_VAN_SLIDE_BAO_VE_CONCISE.pptx
@@ -7405,8 +7405,8 @@
         </p:nvSpPr>
         <p:spPr>
           <a:xfrm>
-            <a:off x="502920" y="5010912"/>
-            <a:ext cx="8138160" cy="512064"/>
+            <a:off x="502920" y="4919472"/>
+            <a:ext cx="8138160" cy="658368"/>
           </a:xfrm>
           <a:prstGeom prst="rect">
             <a:avLst/>
@@ -7424,7 +7424,7 @@
               <a:buNone/>
             </a:pPr>
             <a:r>
-              <a:rPr lang="en-US" sz="1420" b="1" dirty="0">
+              <a:rPr lang="en-US" sz="1280" b="1" dirty="0">
                 <a:solidFill>
                   <a:srgbClr val="25194B"/>
                 </a:solidFill>
@@ -7432,9 +7432,9 @@
                 <a:ea typeface="Cambria" pitchFamily="34" charset="-122"/>
                 <a:cs typeface="Cambria" pitchFamily="34" charset="-120"/>
               </a:rPr>
-              <a:t>Lượt GRPO thứ hai cũng cao hơn S1 về executability (+0,83) và 6/6 thước chữ có KTC.</a:t>
-            </a:r>
-            <a:endParaRPr lang="en-US" sz="1420" dirty="0"/>
+              <a:t>Hai lượt S1: 59,11 / 59,62 · Hai lượt GRPO-SPICE: 60,65 / 59,94 · Lượt GRPO thứ hai vẫn cao hơn S1 lượt đầu +0,83 điểm.</a:t>
+            </a:r>
+            <a:endParaRPr lang="en-US" sz="1280" dirty="0"/>
           </a:p>
         </p:txBody>
       </p:sp>
@@ -8311,6 +8311,47 @@
         </p:nvSpPr>
         <p:spPr>
           <a:xfrm>
+            <a:off x="502920" y="5705856"/>
+            <a:ext cx="8138160" cy="274320"/>
+          </a:xfrm>
+          <a:prstGeom prst="rect">
+            <a:avLst/>
+          </a:prstGeom>
+          <a:noFill/>
+          <a:ln/>
+        </p:spPr>
+        <p:txBody>
+          <a:bodyPr wrap="square" lIns="0" tIns="0" rIns="0" bIns="0" rtlCol="0" anchor="ctr">
+            <a:normAutofit/>
+          </a:bodyPr>
+          <a:lstStyle/>
+          <a:p>
+            <a:pPr algn="ctr" indent="0" marL="0">
+              <a:buNone/>
+            </a:pPr>
+            <a:r>
+              <a:rPr lang="en-US" sz="1080" dirty="0">
+                <a:solidFill>
+                  <a:srgbClr val="5A5A66"/>
+                </a:solidFill>
+                <a:latin typeface="Cambria" pitchFamily="34" charset="0"/>
+                <a:ea typeface="Cambria" pitchFamily="34" charset="-122"/>
+                <a:cs typeface="Cambria" pitchFamily="34" charset="-120"/>
+              </a:rPr>
+              <a:t>ACU là tập bổ sung theo tác vụ để kiểm tra tổng quát hóa, không thay thế tập kiểm chính.</a:t>
+            </a:r>
+            <a:endParaRPr lang="en-US" sz="1080" dirty="0"/>
+          </a:p>
+        </p:txBody>
+      </p:sp>
+      <p:sp>
+        <p:nvSpPr>
+          <p:cNvPr id="17" name="Text 15"/>
+          <p:cNvSpPr/>
+          <p:nvPr/>
+        </p:nvSpPr>
+        <p:spPr>
+          <a:xfrm>
             <a:off x="502920" y="6327648"/>
             <a:ext cx="8138160" cy="137160"/>
           </a:xfrm>
@@ -8344,7 +8385,7 @@
       </p:sp>
       <p:sp>
         <p:nvSpPr>
-          <p:cNvPr id="17" name="Shape 15"/>
+          <p:cNvPr id="18" name="Shape 16"/>
           <p:cNvSpPr/>
           <p:nvPr/>
         </p:nvSpPr>
@@ -8371,7 +8412,7 @@
       </p:sp>
       <p:sp>
         <p:nvSpPr>
-          <p:cNvPr id="18" name="Shape 16"/>
+          <p:cNvPr id="19" name="Shape 17"/>
           <p:cNvSpPr/>
           <p:nvPr/>
         </p:nvSpPr>
@@ -8398,7 +8439,7 @@
       </p:sp>
       <p:sp>
         <p:nvSpPr>
-          <p:cNvPr id="19" name="Shape 17"/>
+          <p:cNvPr id="20" name="Shape 18"/>
           <p:cNvSpPr/>
           <p:nvPr/>
         </p:nvSpPr>
@@ -8425,7 +8466,7 @@
       </p:sp>
       <p:sp>
         <p:nvSpPr>
-          <p:cNvPr id="20" name="Shape 18"/>
+          <p:cNvPr id="21" name="Shape 19"/>
           <p:cNvSpPr/>
           <p:nvPr/>
         </p:nvSpPr>
@@ -8452,7 +8493,7 @@
       </p:sp>
       <p:sp>
         <p:nvSpPr>
-          <p:cNvPr id="21" name="Text 19"/>
+          <p:cNvPr id="22" name="Text 20"/>
           <p:cNvSpPr/>
           <p:nvPr/>
         </p:nvSpPr>
@@ -8491,7 +8532,7 @@
       </p:sp>
       <p:sp>
         <p:nvSpPr>
-          <p:cNvPr id="22" name="Text 20"/>
+          <p:cNvPr id="23" name="Text 21"/>
           <p:cNvSpPr/>
           <p:nvPr/>
         </p:nvSpPr>
@@ -8530,7 +8571,7 @@
       </p:sp>
       <p:sp>
         <p:nvSpPr>
-          <p:cNvPr id="23" name="Text 21"/>
+          <p:cNvPr id="24" name="Text 22"/>
           <p:cNvSpPr/>
           <p:nvPr/>
         </p:nvSpPr>
@@ -8569,7 +8610,7 @@
       </p:sp>
       <p:sp>
         <p:nvSpPr>
-          <p:cNvPr id="24" name="Text 22"/>
+          <p:cNvPr id="25" name="Text 23"/>
           <p:cNvSpPr/>
           <p:nvPr/>
         </p:nvSpPr>
@@ -9151,7 +9192,7 @@
                 <a:ea typeface="Cambria" pitchFamily="34" charset="-122"/>
                 <a:cs typeface="Cambria" pitchFamily="34" charset="-120"/>
               </a:rPr>
-              <a:t>1 · Câu ứng viên phải đúng bằng một trong bốn câu ví dụ được truy hồi.</a:t>
+              <a:t>1 · Câu ứng viên phải giống hoàn toàn một trong bốn câu ví dụ được truy hồi.</a:t>
             </a:r>
             <a:endParaRPr lang="en-US" sz="1400" dirty="0"/>
           </a:p>
@@ -12824,7 +12865,7 @@
                 <a:ea typeface="Cambria" pitchFamily="34" charset="-122"/>
                 <a:cs typeface="Cambria" pitchFamily="34" charset="-120"/>
               </a:rPr>
-              <a:t>Thứ tự chung Base &lt; S1 &lt; GRPO-SPICE ≈ ACE &lt; câu chuẩn được giữ qua các công cụ.</a:t>
+              <a:t>Quan hệ S1 &lt; GRPO-SPICE ≈ ACE được giữ ở cả bốn công cụ đánh giá.</a:t>
             </a:r>
             <a:endParaRPr lang="en-US" sz="1440" dirty="0"/>
           </a:p>
@@ -13675,7 +13716,7 @@
                 <a:ea typeface="Cambria" pitchFamily="34" charset="-122"/>
                 <a:cs typeface="Cambria" pitchFamily="34" charset="-120"/>
               </a:rPr>
-              <a:t>GRPO-SPICE vẫn cao hơn S1 ở 6/7 điểm thước chữ; SPICE, chrF và BLEU-4 có KTC nằm trên 0.</a:t>
+              <a:t>Về thước chữ, GRPO-SPICE và S1 nhìn chung gần tương đương; BLEU-4, SPICE và chrF là ba thước có KTC nằm trên 0.</a:t>
             </a:r>
             <a:endParaRPr lang="en-US" sz="1310" dirty="0"/>
           </a:p>
@@ -17647,7 +17688,7 @@
         </p:nvSpPr>
         <p:spPr>
           <a:xfrm>
-            <a:off x="521208" y="1417320"/>
+            <a:off x="521208" y="1380744"/>
             <a:ext cx="64008" cy="64008"/>
           </a:xfrm>
           <a:prstGeom prst="ellipse">
@@ -17674,8 +17715,8 @@
         </p:nvSpPr>
         <p:spPr>
           <a:xfrm>
-            <a:off x="713232" y="1280160"/>
-            <a:ext cx="7927848" cy="548640"/>
+            <a:off x="713232" y="1243584"/>
+            <a:ext cx="7927848" cy="457200"/>
           </a:xfrm>
           <a:prstGeom prst="rect">
             <a:avLst/>
@@ -17696,7 +17737,7 @@
               <a:buNone/>
             </a:pPr>
             <a:r>
-              <a:rPr lang="en-US" sz="1380" dirty="0">
+              <a:rPr lang="en-US" sz="1290" dirty="0">
                 <a:solidFill>
                   <a:srgbClr val="1A1A1A"/>
                 </a:solidFill>
@@ -17706,7 +17747,7 @@
               </a:rPr>
               <a:t>Kết luận chính về executability tập trung vào các bước có thao tác chạm.</a:t>
             </a:r>
-            <a:endParaRPr lang="en-US" sz="1380" dirty="0"/>
+            <a:endParaRPr lang="en-US" sz="1290" dirty="0"/>
           </a:p>
         </p:txBody>
       </p:sp>
@@ -17718,7 +17759,7 @@
         </p:nvSpPr>
         <p:spPr>
           <a:xfrm>
-            <a:off x="521208" y="2075688"/>
+            <a:off x="521208" y="1892808"/>
             <a:ext cx="64008" cy="64008"/>
           </a:xfrm>
           <a:prstGeom prst="ellipse">
@@ -17745,8 +17786,8 @@
         </p:nvSpPr>
         <p:spPr>
           <a:xfrm>
-            <a:off x="713232" y="1938528"/>
-            <a:ext cx="7927848" cy="548640"/>
+            <a:off x="713232" y="1755648"/>
+            <a:ext cx="7927848" cy="457200"/>
           </a:xfrm>
           <a:prstGeom prst="rect">
             <a:avLst/>
@@ -17767,7 +17808,7 @@
               <a:buNone/>
             </a:pPr>
             <a:r>
-              <a:rPr lang="en-US" sz="1380" dirty="0">
+              <a:rPr lang="en-US" sz="1290" dirty="0">
                 <a:solidFill>
                   <a:srgbClr val="1A1A1A"/>
                 </a:solidFill>
@@ -17777,7 +17818,7 @@
               </a:rPr>
               <a:t>Thực nghiệm chính dùng AndroidControl tiếng Anh và backbone Qwen2.5-VL-3B.</a:t>
             </a:r>
-            <a:endParaRPr lang="en-US" sz="1380" dirty="0"/>
+            <a:endParaRPr lang="en-US" sz="1290" dirty="0"/>
           </a:p>
         </p:txBody>
       </p:sp>
@@ -17789,7 +17830,7 @@
         </p:nvSpPr>
         <p:spPr>
           <a:xfrm>
-            <a:off x="521208" y="2734056"/>
+            <a:off x="521208" y="2404872"/>
             <a:ext cx="64008" cy="64008"/>
           </a:xfrm>
           <a:prstGeom prst="ellipse">
@@ -17816,8 +17857,8 @@
         </p:nvSpPr>
         <p:spPr>
           <a:xfrm>
-            <a:off x="713232" y="2596896"/>
-            <a:ext cx="7927848" cy="548640"/>
+            <a:off x="713232" y="2267712"/>
+            <a:ext cx="7927848" cy="457200"/>
           </a:xfrm>
           <a:prstGeom prst="rect">
             <a:avLst/>
@@ -17838,7 +17879,7 @@
               <a:buNone/>
             </a:pPr>
             <a:r>
-              <a:rPr lang="en-US" sz="1380" dirty="0">
+              <a:rPr lang="en-US" sz="1290" dirty="0">
                 <a:solidFill>
                   <a:srgbClr val="1A1A1A"/>
                 </a:solidFill>
@@ -17846,60 +17887,21 @@
                 <a:ea typeface="Cambria" pitchFamily="34" charset="-122"/>
                 <a:cs typeface="Cambria" pitchFamily="34" charset="-120"/>
               </a:rPr>
-              <a:t>AitZ cho thấy lợi ích bổ sung của SPICE phụ thuộc vào phân phối câu chuẩn.</a:t>
-            </a:r>
-            <a:endParaRPr lang="en-US" sz="1380" dirty="0"/>
-          </a:p>
-        </p:txBody>
-      </p:sp>
-      <p:sp>
-        <p:nvSpPr>
-          <p:cNvPr id="11" name="Text 9"/>
-          <p:cNvSpPr/>
-          <p:nvPr/>
-        </p:nvSpPr>
-        <p:spPr>
-          <a:xfrm>
-            <a:off x="502920" y="3429000"/>
-            <a:ext cx="1828800" cy="320040"/>
-          </a:xfrm>
-          <a:prstGeom prst="rect">
-            <a:avLst/>
-          </a:prstGeom>
-          <a:noFill/>
-          <a:ln/>
-        </p:spPr>
-        <p:txBody>
-          <a:bodyPr wrap="square" lIns="0" tIns="0" rIns="0" bIns="0" rtlCol="0" anchor="ctr"/>
-          <a:lstStyle/>
-          <a:p>
-            <a:pPr indent="0" marL="0">
-              <a:buNone/>
-            </a:pPr>
-            <a:r>
-              <a:rPr lang="en-US" sz="1700" b="1" dirty="0">
-                <a:solidFill>
-                  <a:srgbClr val="25194B"/>
-                </a:solidFill>
-                <a:latin typeface="Cambria" pitchFamily="34" charset="0"/>
-                <a:ea typeface="Cambria" pitchFamily="34" charset="-122"/>
-                <a:cs typeface="Cambria" pitchFamily="34" charset="-120"/>
-              </a:rPr>
-              <a:t>Hướng mở rộng</a:t>
-            </a:r>
-            <a:endParaRPr lang="en-US" sz="1700" dirty="0"/>
-          </a:p>
-        </p:txBody>
-      </p:sp>
-      <p:sp>
-        <p:nvSpPr>
-          <p:cNvPr id="12" name="Shape 10"/>
-          <p:cNvSpPr/>
-          <p:nvPr/>
-        </p:nvSpPr>
-        <p:spPr>
-          <a:xfrm>
-            <a:off x="521208" y="3977640"/>
+              <a:t>Đa số nhánh được chạy một lượt; S1 và GRPO-SPICE có hai lượt để kiểm tra độ ổn định về hướng.</a:t>
+            </a:r>
+            <a:endParaRPr lang="en-US" sz="1290" dirty="0"/>
+          </a:p>
+        </p:txBody>
+      </p:sp>
+      <p:sp>
+        <p:nvSpPr>
+          <p:cNvPr id="11" name="Shape 9"/>
+          <p:cNvSpPr/>
+          <p:nvPr/>
+        </p:nvSpPr>
+        <p:spPr>
+          <a:xfrm>
+            <a:off x="521208" y="2916936"/>
             <a:ext cx="64008" cy="64008"/>
           </a:xfrm>
           <a:prstGeom prst="ellipse">
@@ -17920,14 +17922,14 @@
       </p:sp>
       <p:sp>
         <p:nvSpPr>
-          <p:cNvPr id="13" name="Text 11"/>
-          <p:cNvSpPr/>
-          <p:nvPr/>
-        </p:nvSpPr>
-        <p:spPr>
-          <a:xfrm>
-            <a:off x="713232" y="3840480"/>
-            <a:ext cx="7927848" cy="548640"/>
+          <p:cNvPr id="12" name="Text 10"/>
+          <p:cNvSpPr/>
+          <p:nvPr/>
+        </p:nvSpPr>
+        <p:spPr>
+          <a:xfrm>
+            <a:off x="713232" y="2779776"/>
+            <a:ext cx="7927848" cy="457200"/>
           </a:xfrm>
           <a:prstGeom prst="rect">
             <a:avLst/>
@@ -17948,7 +17950,7 @@
               <a:buNone/>
             </a:pPr>
             <a:r>
-              <a:rPr lang="en-US" sz="1380" dirty="0">
+              <a:rPr lang="en-US" sz="1290" dirty="0">
                 <a:solidFill>
                   <a:srgbClr val="1A1A1A"/>
                 </a:solidFill>
@@ -17956,9 +17958,48 @@
                 <a:ea typeface="Cambria" pitchFamily="34" charset="-122"/>
                 <a:cs typeface="Cambria" pitchFamily="34" charset="-120"/>
               </a:rPr>
-              <a:t>Mở rộng sang nhiều miền giao diện, câu chuẩn do người viết và giao diện tiếng Việt.</a:t>
-            </a:r>
-            <a:endParaRPr lang="en-US" sz="1380" dirty="0"/>
+              <a:t>AitZ cho thấy lợi ích bổ sung của SPICE phụ thuộc vào phân phối câu chuẩn.</a:t>
+            </a:r>
+            <a:endParaRPr lang="en-US" sz="1290" dirty="0"/>
+          </a:p>
+        </p:txBody>
+      </p:sp>
+      <p:sp>
+        <p:nvSpPr>
+          <p:cNvPr id="13" name="Text 11"/>
+          <p:cNvSpPr/>
+          <p:nvPr/>
+        </p:nvSpPr>
+        <p:spPr>
+          <a:xfrm>
+            <a:off x="502920" y="3429000"/>
+            <a:ext cx="1828800" cy="320040"/>
+          </a:xfrm>
+          <a:prstGeom prst="rect">
+            <a:avLst/>
+          </a:prstGeom>
+          <a:noFill/>
+          <a:ln/>
+        </p:spPr>
+        <p:txBody>
+          <a:bodyPr wrap="square" lIns="0" tIns="0" rIns="0" bIns="0" rtlCol="0" anchor="ctr"/>
+          <a:lstStyle/>
+          <a:p>
+            <a:pPr indent="0" marL="0">
+              <a:buNone/>
+            </a:pPr>
+            <a:r>
+              <a:rPr lang="en-US" sz="1700" b="1" dirty="0">
+                <a:solidFill>
+                  <a:srgbClr val="25194B"/>
+                </a:solidFill>
+                <a:latin typeface="Cambria" pitchFamily="34" charset="0"/>
+                <a:ea typeface="Cambria" pitchFamily="34" charset="-122"/>
+                <a:cs typeface="Cambria" pitchFamily="34" charset="-120"/>
+              </a:rPr>
+              <a:t>Hướng mở rộng</a:t>
+            </a:r>
+            <a:endParaRPr lang="en-US" sz="1700" dirty="0"/>
           </a:p>
         </p:txBody>
       </p:sp>
@@ -17970,7 +18011,7 @@
         </p:nvSpPr>
         <p:spPr>
           <a:xfrm>
-            <a:off x="521208" y="4636008"/>
+            <a:off x="521208" y="3977640"/>
             <a:ext cx="64008" cy="64008"/>
           </a:xfrm>
           <a:prstGeom prst="ellipse">
@@ -17997,7 +18038,7 @@
         </p:nvSpPr>
         <p:spPr>
           <a:xfrm>
-            <a:off x="713232" y="4498848"/>
+            <a:off x="713232" y="3840480"/>
             <a:ext cx="7927848" cy="548640"/>
           </a:xfrm>
           <a:prstGeom prst="rect">
@@ -18027,7 +18068,7 @@
                 <a:ea typeface="Cambria" pitchFamily="34" charset="-122"/>
                 <a:cs typeface="Cambria" pitchFamily="34" charset="-120"/>
               </a:rPr>
-              <a:t>Tăng độ bao phủ cho thao tác ngoài thao tác chạm và chuỗi nhiều màn hình.</a:t>
+              <a:t>Mở rộng sang nhiều miền giao diện, câu chuẩn do người viết và giao diện tiếng Việt.</a:t>
             </a:r>
             <a:endParaRPr lang="en-US" sz="1380" dirty="0"/>
           </a:p>
@@ -18041,7 +18082,7 @@
         </p:nvSpPr>
         <p:spPr>
           <a:xfrm>
-            <a:off x="521208" y="5294376"/>
+            <a:off x="521208" y="4636008"/>
             <a:ext cx="64008" cy="64008"/>
           </a:xfrm>
           <a:prstGeom prst="ellipse">
@@ -18068,7 +18109,7 @@
         </p:nvSpPr>
         <p:spPr>
           <a:xfrm>
-            <a:off x="713232" y="5157216"/>
+            <a:off x="713232" y="4498848"/>
             <a:ext cx="7927848" cy="548640"/>
           </a:xfrm>
           <a:prstGeom prst="rect">
@@ -18098,6 +18139,77 @@
                 <a:ea typeface="Cambria" pitchFamily="34" charset="-122"/>
                 <a:cs typeface="Cambria" pitchFamily="34" charset="-120"/>
               </a:rPr>
+              <a:t>Tăng độ bao phủ cho thao tác ngoài thao tác chạm và chuỗi nhiều màn hình.</a:t>
+            </a:r>
+            <a:endParaRPr lang="en-US" sz="1380" dirty="0"/>
+          </a:p>
+        </p:txBody>
+      </p:sp>
+      <p:sp>
+        <p:nvSpPr>
+          <p:cNvPr id="18" name="Shape 16"/>
+          <p:cNvSpPr/>
+          <p:nvPr/>
+        </p:nvSpPr>
+        <p:spPr>
+          <a:xfrm>
+            <a:off x="521208" y="5294376"/>
+            <a:ext cx="64008" cy="64008"/>
+          </a:xfrm>
+          <a:prstGeom prst="ellipse">
+            <a:avLst/>
+          </a:prstGeom>
+          <a:solidFill>
+            <a:srgbClr val="4F417A"/>
+          </a:solidFill>
+          <a:ln w="12700">
+            <a:solidFill>
+              <a:srgbClr val="4F417A">
+                <a:alpha val="0"/>
+              </a:srgbClr>
+            </a:solidFill>
+            <a:prstDash val="solid"/>
+          </a:ln>
+        </p:spPr>
+      </p:sp>
+      <p:sp>
+        <p:nvSpPr>
+          <p:cNvPr id="19" name="Text 17"/>
+          <p:cNvSpPr/>
+          <p:nvPr/>
+        </p:nvSpPr>
+        <p:spPr>
+          <a:xfrm>
+            <a:off x="713232" y="5157216"/>
+            <a:ext cx="7927848" cy="548640"/>
+          </a:xfrm>
+          <a:prstGeom prst="rect">
+            <a:avLst/>
+          </a:prstGeom>
+          <a:noFill/>
+          <a:ln/>
+        </p:spPr>
+        <p:txBody>
+          <a:bodyPr wrap="square" lIns="0" tIns="0" rIns="0" bIns="0" rtlCol="0" anchor="t">
+            <a:normAutofit/>
+          </a:bodyPr>
+          <a:lstStyle/>
+          <a:p>
+            <a:pPr indent="0" marL="0">
+              <a:lnSpc>
+                <a:spcPct val="112000"/>
+              </a:lnSpc>
+              <a:buNone/>
+            </a:pPr>
+            <a:r>
+              <a:rPr lang="en-US" sz="1380" dirty="0">
+                <a:solidFill>
+                  <a:srgbClr val="1A1A1A"/>
+                </a:solidFill>
+                <a:latin typeface="Cambria" pitchFamily="34" charset="0"/>
+                <a:ea typeface="Cambria" pitchFamily="34" charset="-122"/>
+                <a:cs typeface="Cambria" pitchFamily="34" charset="-120"/>
+              </a:rPr>
               <a:t>Lặp thêm lượt huấn luyện để ước lượng chính xác hơn độ biến thiên của mức tăng.</a:t>
             </a:r>
             <a:endParaRPr lang="en-US" sz="1380" dirty="0"/>
@@ -18106,7 +18218,7 @@
       </p:sp>
       <p:sp>
         <p:nvSpPr>
-          <p:cNvPr id="18" name="Text 16"/>
+          <p:cNvPr id="20" name="Text 18"/>
           <p:cNvSpPr/>
           <p:nvPr/>
         </p:nvSpPr>
@@ -18145,7 +18257,7 @@
       </p:sp>
       <p:sp>
         <p:nvSpPr>
-          <p:cNvPr id="19" name="Shape 17"/>
+          <p:cNvPr id="21" name="Shape 19"/>
           <p:cNvSpPr/>
           <p:nvPr/>
         </p:nvSpPr>
@@ -18172,7 +18284,7 @@
       </p:sp>
       <p:sp>
         <p:nvSpPr>
-          <p:cNvPr id="20" name="Shape 18"/>
+          <p:cNvPr id="22" name="Shape 20"/>
           <p:cNvSpPr/>
           <p:nvPr/>
         </p:nvSpPr>
@@ -18199,7 +18311,7 @@
       </p:sp>
       <p:sp>
         <p:nvSpPr>
-          <p:cNvPr id="21" name="Shape 19"/>
+          <p:cNvPr id="23" name="Shape 21"/>
           <p:cNvSpPr/>
           <p:nvPr/>
         </p:nvSpPr>
@@ -18226,7 +18338,7 @@
       </p:sp>
       <p:sp>
         <p:nvSpPr>
-          <p:cNvPr id="22" name="Shape 20"/>
+          <p:cNvPr id="24" name="Shape 22"/>
           <p:cNvSpPr/>
           <p:nvPr/>
         </p:nvSpPr>
@@ -18253,7 +18365,7 @@
       </p:sp>
       <p:sp>
         <p:nvSpPr>
-          <p:cNvPr id="23" name="Text 21"/>
+          <p:cNvPr id="25" name="Text 23"/>
           <p:cNvSpPr/>
           <p:nvPr/>
         </p:nvSpPr>
@@ -18292,7 +18404,7 @@
       </p:sp>
       <p:sp>
         <p:nvSpPr>
-          <p:cNvPr id="24" name="Text 22"/>
+          <p:cNvPr id="26" name="Text 24"/>
           <p:cNvSpPr/>
           <p:nvPr/>
         </p:nvSpPr>
@@ -18331,7 +18443,7 @@
       </p:sp>
       <p:sp>
         <p:nvSpPr>
-          <p:cNvPr id="25" name="Text 23"/>
+          <p:cNvPr id="27" name="Text 25"/>
           <p:cNvSpPr/>
           <p:nvPr/>
         </p:nvSpPr>
@@ -18370,7 +18482,7 @@
       </p:sp>
       <p:sp>
         <p:nvSpPr>
-          <p:cNvPr id="26" name="Text 24"/>
+          <p:cNvPr id="28" name="Text 26"/>
           <p:cNvSpPr/>
           <p:nvPr/>
         </p:nvSpPr>
@@ -18855,7 +18967,7 @@
                 <a:ea typeface="Cambria" pitchFamily="34" charset="-122"/>
                 <a:cs typeface="Cambria" pitchFamily="34" charset="-120"/>
               </a:rPr>
-              <a:t>Điểm mạnh của luận văn không chỉ là một con số, mà là chuỗi bằng chứng giải thích được con số đó.</a:t>
+              <a:t>Các thí nghiệm bổ sung giúp làm rõ mức tăng giữ được ở đâu và giới hạn xuất hiện khi nào.</a:t>
             </a:r>
             <a:endParaRPr lang="en-US" sz="1550" dirty="0"/>
           </a:p>
@@ -19870,7 +19982,7 @@
                 <a:ea typeface="Cambria" pitchFamily="34" charset="-122"/>
                 <a:cs typeface="Cambria" pitchFamily="34" charset="-120"/>
               </a:rPr>
-              <a:t>Kết luận chính: tối ưu trực tiếp chất lượng câu giúp tăng khả năng người dùng xác định đúng phần tử cần thao tác.</a:t>
+              <a:t>Kết luận chính: trong thiết lập AndroidControl, GRPO-SPICE làm tăng đồng thời chất lượng câu và executability.</a:t>
             </a:r>
             <a:endParaRPr lang="en-US" sz="1320" dirty="0"/>
           </a:p>
@@ -30211,7 +30323,7 @@
                 <a:ea typeface="Cambria" pitchFamily="34" charset="-122"/>
                 <a:cs typeface="Cambria" pitchFamily="34" charset="-120"/>
               </a:rPr>
-              <a:t>6. Tinh chỉnh dữ liệu phù hợp quan trọng hơn chỉ tăng kích thước mô hình</a:t>
+              <a:t>6. Trong thiết lập đã thử, 3B sau tinh chỉnh vượt 7B chỉ prompting</a:t>
             </a:r>
             <a:endParaRPr lang="en-US" sz="2000" dirty="0"/>
           </a:p>
@@ -31758,7 +31870,7 @@
                 <a:ea typeface="Cambria" pitchFamily="34" charset="-122"/>
                 <a:cs typeface="Cambria" pitchFamily="34" charset="-120"/>
               </a:rPr>
-              <a:t>không mô tả trạng thái theo nghĩa ngược</a:t>
+              <a:t>không diễn đạt ngược thao tác cần làm</a:t>
             </a:r>
             <a:endParaRPr lang="en-US" sz="1500" dirty="0"/>
           </a:p>

</xml_diff>

<commit_message>
Luận văn: cắt lại PDF từng chương theo main.pdf mới; slide: cập nhật deck bảo vệ rút gọn và bản xem thử
Co-Authored-By: Claude Opus 5.5 <noreply@anthropic.com>
</commit_message>
<xml_diff>
--- a/slides/LUAN_VAN_SLIDE_BAO_VE_CONCISE.pptx
+++ b/slides/LUAN_VAN_SLIDE_BAO_VE_CONCISE.pptx
@@ -6376,7 +6376,7 @@
               <a:buNone/>
             </a:pPr>
             <a:r>
-              <a:rPr lang="en-US" sz="1390" b="1" dirty="0">
+              <a:rPr lang="en-US" sz="1390" dirty="0">
                 <a:solidFill>
                   <a:srgbClr val="7A7099"/>
                 </a:solidFill>
@@ -6518,7 +6518,7 @@
               <a:buNone/>
             </a:pPr>
             <a:r>
-              <a:rPr lang="en-US" sz="1390" b="1" dirty="0">
+              <a:rPr lang="en-US" sz="1390" dirty="0">
                 <a:solidFill>
                   <a:srgbClr val="7A7099"/>
                 </a:solidFill>
@@ -6660,7 +6660,7 @@
               <a:buNone/>
             </a:pPr>
             <a:r>
-              <a:rPr lang="en-US" sz="1390" b="1" dirty="0">
+              <a:rPr lang="en-US" sz="1390" dirty="0">
                 <a:solidFill>
                   <a:srgbClr val="4F417A"/>
                 </a:solidFill>
@@ -7338,7 +7338,7 @@
               <a:buNone/>
             </a:pPr>
             <a:r>
-              <a:rPr lang="en-US" sz="1580" b="1" dirty="0">
+              <a:rPr lang="en-US" sz="1580" dirty="0">
                 <a:solidFill>
                   <a:srgbClr val="25194B"/>
                 </a:solidFill>
@@ -7346,7 +7346,7 @@
                 <a:ea typeface="Cambria" pitchFamily="34" charset="-122"/>
                 <a:cs typeface="Cambria" pitchFamily="34" charset="-120"/>
               </a:rPr>
-              <a:t>Cùng 500 bước GRPO, nhánh dùng SPICE từ mẫu khác vẫn ở mức S1; GRPO-SPICE tăng +1,55 điểm.</a:t>
+              <a:t>Cùng 500 bước GRPO, nhánh dùng SPICE từ mẫu khác vẫn ở mức S1. GRPO-SPICE tăng +1,55 điểm.</a:t>
             </a:r>
             <a:endParaRPr lang="en-US" sz="1580" dirty="0"/>
           </a:p>
@@ -7750,7 +7750,7 @@
                 <a:ea typeface="Cambria" pitchFamily="34" charset="-122"/>
                 <a:cs typeface="Cambria" pitchFamily="34" charset="-120"/>
               </a:rPr>
-              <a:t>GRPO-SPICE cao hơn nhánh dùng SPICE từ mẫu khác +1,55 điểm · KTC 95% [+0,81; +2,30]</a:t>
+              <a:t>GRPO-SPICE cao hơn nhánh dùng SPICE từ mẫu khác +1,55 điểm · KTC 95% từ +0,81 đến +2,30</a:t>
             </a:r>
             <a:endParaRPr lang="en-US" sz="1600" dirty="0"/>
           </a:p>
@@ -7784,7 +7784,7 @@
               <a:buNone/>
             </a:pPr>
             <a:r>
-              <a:rPr lang="en-US" sz="1380" b="1" dirty="0">
+              <a:rPr lang="en-US" sz="1380" dirty="0">
                 <a:solidFill>
                   <a:srgbClr val="25194B"/>
                 </a:solidFill>
@@ -8205,7 +8205,7 @@
               <a:buNone/>
             </a:pPr>
             <a:r>
-              <a:rPr lang="en-US" sz="1670" b="1" dirty="0">
+              <a:rPr lang="en-US" sz="1670" dirty="0">
                 <a:solidFill>
                   <a:srgbClr val="25194B"/>
                 </a:solidFill>
@@ -9449,7 +9449,7 @@
               <a:buNone/>
             </a:pPr>
             <a:r>
-              <a:rPr lang="en-US" sz="1250" b="1" dirty="0">
+              <a:rPr lang="en-US" sz="1250" dirty="0">
                 <a:solidFill>
                   <a:srgbClr val="1A1A1A"/>
                 </a:solidFill>
@@ -9535,7 +9535,7 @@
               <a:buNone/>
             </a:pPr>
             <a:r>
-              <a:rPr lang="en-US" sz="1250" b="1" dirty="0">
+              <a:rPr lang="en-US" sz="1250" dirty="0">
                 <a:solidFill>
                   <a:srgbClr val="1A1A1A"/>
                 </a:solidFill>
@@ -9621,7 +9621,7 @@
               <a:buNone/>
             </a:pPr>
             <a:r>
-              <a:rPr lang="en-US" sz="1250" b="1" dirty="0">
+              <a:rPr lang="en-US" sz="1250" dirty="0">
                 <a:solidFill>
                   <a:srgbClr val="1A1A1A"/>
                 </a:solidFill>
@@ -9665,7 +9665,7 @@
               <a:buNone/>
             </a:pPr>
             <a:r>
-              <a:rPr lang="en-US" sz="1360" b="1" dirty="0">
+              <a:rPr lang="en-US" sz="1360" dirty="0">
                 <a:solidFill>
                   <a:srgbClr val="25194B"/>
                 </a:solidFill>
@@ -9673,7 +9673,7 @@
                 <a:ea typeface="Cambria" pitchFamily="34" charset="-122"/>
                 <a:cs typeface="Cambria" pitchFamily="34" charset="-120"/>
               </a:rPr>
-              <a:t>12/12 độ đo có KTC nằm trên 0; METEOR tăng nhưng chưa có KTC.</a:t>
+              <a:t>12/12 độ đo có KTC nằm trên 0. METEOR tăng nhưng chưa có KTC.</a:t>
             </a:r>
             <a:endParaRPr lang="en-US" sz="1360" dirty="0"/>
           </a:p>
@@ -10088,7 +10088,7 @@
               <a:buNone/>
             </a:pPr>
             <a:r>
-              <a:rPr lang="en-US" sz="1540" b="1" dirty="0">
+              <a:rPr lang="en-US" sz="1540" dirty="0">
                 <a:solidFill>
                   <a:srgbClr val="25194B"/>
                 </a:solidFill>
@@ -10372,7 +10372,7 @@
               <a:buNone/>
             </a:pPr>
             <a:r>
-              <a:rPr lang="en-US" sz="1420" b="1" dirty="0">
+              <a:rPr lang="en-US" sz="1420" dirty="0">
                 <a:solidFill>
                   <a:srgbClr val="4F417A"/>
                 </a:solidFill>
@@ -10556,7 +10556,7 @@
               <a:buNone/>
             </a:pPr>
             <a:r>
-              <a:rPr lang="en-US" sz="1370" b="1" dirty="0">
+              <a:rPr lang="en-US" sz="1370" dirty="0">
                 <a:solidFill>
                   <a:srgbClr val="25194B"/>
                 </a:solidFill>
@@ -10625,7 +10625,7 @@
               <a:buNone/>
             </a:pPr>
             <a:r>
-              <a:rPr lang="en-US" sz="1480" b="1" dirty="0">
+              <a:rPr lang="en-US" sz="1480" dirty="0">
                 <a:solidFill>
                   <a:srgbClr val="25194B"/>
                 </a:solidFill>
@@ -10633,7 +10633,7 @@
                 <a:ea typeface="Cambria" pitchFamily="34" charset="-122"/>
                 <a:cs typeface="Cambria" pitchFamily="34" charset="-120"/>
               </a:rPr>
-              <a:t>Tập kiểm chính + ACU: GRPO-SPICE − S1 = +2,30  [ +1,62; +2,99 ]</a:t>
+              <a:t>Tập kiểm chính + ACU: GRPO-SPICE − S1 = +2,30 · KTC 95% từ +1,62 đến +2,99</a:t>
             </a:r>
             <a:endParaRPr lang="en-US" sz="1480" dirty="0"/>
           </a:p>
@@ -11090,7 +11090,7 @@
               <a:buNone/>
             </a:pPr>
             <a:r>
-              <a:rPr lang="en-US" sz="1250" b="1" dirty="0">
+              <a:rPr lang="en-US" sz="1250" dirty="0">
                 <a:solidFill>
                   <a:srgbClr val="1A1A1A"/>
                 </a:solidFill>
@@ -11176,7 +11176,7 @@
               <a:buNone/>
             </a:pPr>
             <a:r>
-              <a:rPr lang="en-US" sz="1250" b="1" dirty="0">
+              <a:rPr lang="en-US" sz="1250" dirty="0">
                 <a:solidFill>
                   <a:srgbClr val="1A1A1A"/>
                 </a:solidFill>
@@ -11262,7 +11262,7 @@
               <a:buNone/>
             </a:pPr>
             <a:r>
-              <a:rPr lang="en-US" sz="1250" b="1" dirty="0">
+              <a:rPr lang="en-US" sz="1250" dirty="0">
                 <a:solidFill>
                   <a:srgbClr val="1A1A1A"/>
                 </a:solidFill>
@@ -11306,7 +11306,7 @@
               <a:buNone/>
             </a:pPr>
             <a:r>
-              <a:rPr lang="en-US" sz="1400" b="1" dirty="0">
+              <a:rPr lang="en-US" sz="1400" dirty="0">
                 <a:solidFill>
                   <a:srgbClr val="25194B"/>
                 </a:solidFill>
@@ -13308,7 +13308,7 @@
               <a:buNone/>
             </a:pPr>
             <a:r>
-              <a:rPr lang="en-US" sz="1280" b="1" dirty="0">
+              <a:rPr lang="en-US" sz="1280" dirty="0">
                 <a:solidFill>
                   <a:srgbClr val="25194B"/>
                 </a:solidFill>
@@ -13316,7 +13316,7 @@
                 <a:ea typeface="Cambria" pitchFamily="34" charset="-122"/>
                 <a:cs typeface="Cambria" pitchFamily="34" charset="-120"/>
               </a:rPr>
-              <a:t>6/6 độ đo có KTC nằm trên 0; METEOR chưa có KTC.</a:t>
+              <a:t>6/6 độ đo có KTC nằm trên 0. METEOR chưa có KTC.</a:t>
             </a:r>
             <a:endParaRPr lang="en-US" sz="1280" dirty="0"/>
           </a:p>
@@ -13710,28 +13710,28 @@
         <p:spPr>
           <a:xfrm>
             <a:off x="502920" y="822960"/>
-            <a:ext cx="8138160" cy="640080"/>
-          </a:xfrm>
-          <a:prstGeom prst="rect">
-            <a:avLst/>
-          </a:prstGeom>
-          <a:noFill/>
-          <a:ln/>
-        </p:spPr>
-        <p:txBody>
-          <a:bodyPr wrap="square" lIns="0" tIns="0" rIns="0" bIns="0" rtlCol="0" anchor="ctr">
-            <a:normAutofit/>
-          </a:bodyPr>
-          <a:lstStyle/>
-          <a:p>
-            <a:pPr algn="ctr" indent="0" marL="0">
-              <a:lnSpc>
-                <a:spcPct val="125000"/>
-              </a:lnSpc>
-              <a:buNone/>
-            </a:pPr>
-            <a:r>
-              <a:rPr lang="en-US" sz="1520" b="1" dirty="0">
+            <a:ext cx="8138160" cy="530352"/>
+          </a:xfrm>
+          <a:prstGeom prst="rect">
+            <a:avLst/>
+          </a:prstGeom>
+          <a:noFill/>
+          <a:ln/>
+        </p:spPr>
+        <p:txBody>
+          <a:bodyPr wrap="square" lIns="0" tIns="0" rIns="0" bIns="0" rtlCol="0" anchor="ctr">
+            <a:normAutofit/>
+          </a:bodyPr>
+          <a:lstStyle/>
+          <a:p>
+            <a:pPr algn="ctr" indent="0" marL="0">
+              <a:lnSpc>
+                <a:spcPct val="125000"/>
+              </a:lnSpc>
+              <a:buNone/>
+            </a:pPr>
+            <a:r>
+              <a:rPr lang="en-US" sz="1520" dirty="0">
                 <a:solidFill>
                   <a:srgbClr val="25194B"/>
                 </a:solidFill>
@@ -13739,7 +13739,7 @@
                 <a:ea typeface="Cambria" pitchFamily="34" charset="-122"/>
                 <a:cs typeface="Cambria" pitchFamily="34" charset="-120"/>
               </a:rPr>
-              <a:t>Để kiểm tra kết quả không phụ thuộc vào một mô hình định vị duy nhất, executability được tính lại bằng 4 mô hình: UGround, UI-Venus, Phi-Ground và Phi-4.</a:t>
+              <a:t>Executability được tính lại bằng bốn mô hình định vị để kiểm tra độ ổn định của kết quả.</a:t>
             </a:r>
             <a:endParaRPr lang="en-US" sz="1520" dirty="0"/>
           </a:p>
@@ -13753,8 +13753,8 @@
         </p:nvSpPr>
         <p:spPr>
           <a:xfrm>
-            <a:off x="1051560" y="1572768"/>
-            <a:ext cx="7040880" cy="502920"/>
+            <a:off x="566928" y="1481328"/>
+            <a:ext cx="7680960" cy="512064"/>
           </a:xfrm>
           <a:prstGeom prst="rect">
             <a:avLst/>
@@ -13780,8 +13780,8 @@
         </p:nvSpPr>
         <p:spPr>
           <a:xfrm>
-            <a:off x="1051560" y="1572768"/>
-            <a:ext cx="2834640" cy="502920"/>
+            <a:off x="566928" y="1481328"/>
+            <a:ext cx="2011680" cy="512064"/>
           </a:xfrm>
           <a:prstGeom prst="rect">
             <a:avLst/>
@@ -13802,7 +13802,7 @@
               <a:buNone/>
             </a:pPr>
             <a:r>
-              <a:rPr lang="en-US" sz="1320" b="1" dirty="0">
+              <a:rPr lang="en-US" sz="1240" b="1" dirty="0">
                 <a:solidFill>
                   <a:srgbClr val="FFFFFF"/>
                 </a:solidFill>
@@ -13810,7 +13810,227 @@
                 <a:ea typeface="Cambria" pitchFamily="34" charset="-122"/>
                 <a:cs typeface="Cambria" pitchFamily="34" charset="-120"/>
               </a:rPr>
-              <a:t>Mô hình định vị</a:t>
+              <a:t>Mô hình</a:t>
+            </a:r>
+            <a:endParaRPr lang="en-US" sz="1240" dirty="0"/>
+          </a:p>
+        </p:txBody>
+      </p:sp>
+      <p:sp>
+        <p:nvSpPr>
+          <p:cNvPr id="7" name="Text 5"/>
+          <p:cNvSpPr/>
+          <p:nvPr/>
+        </p:nvSpPr>
+        <p:spPr>
+          <a:xfrm>
+            <a:off x="2578608" y="1481328"/>
+            <a:ext cx="1417320" cy="512064"/>
+          </a:xfrm>
+          <a:prstGeom prst="rect">
+            <a:avLst/>
+          </a:prstGeom>
+          <a:noFill/>
+          <a:ln/>
+        </p:spPr>
+        <p:txBody>
+          <a:bodyPr wrap="square" lIns="0" tIns="0" rIns="0" bIns="0" rtlCol="0" anchor="ctr">
+            <a:normAutofit/>
+          </a:bodyPr>
+          <a:lstStyle/>
+          <a:p>
+            <a:pPr algn="ctr" indent="0" marL="0">
+              <a:lnSpc>
+                <a:spcPct val="125000"/>
+              </a:lnSpc>
+              <a:buNone/>
+            </a:pPr>
+            <a:r>
+              <a:rPr lang="en-US" sz="1240" b="1" dirty="0">
+                <a:solidFill>
+                  <a:srgbClr val="FFFFFF"/>
+                </a:solidFill>
+                <a:latin typeface="Cambria" pitchFamily="34" charset="0"/>
+                <a:ea typeface="Cambria" pitchFamily="34" charset="-122"/>
+                <a:cs typeface="Cambria" pitchFamily="34" charset="-120"/>
+              </a:rPr>
+              <a:t>UGround</a:t>
+            </a:r>
+            <a:endParaRPr lang="en-US" sz="1240" dirty="0"/>
+          </a:p>
+        </p:txBody>
+      </p:sp>
+      <p:sp>
+        <p:nvSpPr>
+          <p:cNvPr id="8" name="Text 6"/>
+          <p:cNvSpPr/>
+          <p:nvPr/>
+        </p:nvSpPr>
+        <p:spPr>
+          <a:xfrm>
+            <a:off x="3995928" y="1481328"/>
+            <a:ext cx="1417320" cy="512064"/>
+          </a:xfrm>
+          <a:prstGeom prst="rect">
+            <a:avLst/>
+          </a:prstGeom>
+          <a:noFill/>
+          <a:ln/>
+        </p:spPr>
+        <p:txBody>
+          <a:bodyPr wrap="square" lIns="0" tIns="0" rIns="0" bIns="0" rtlCol="0" anchor="ctr">
+            <a:normAutofit/>
+          </a:bodyPr>
+          <a:lstStyle/>
+          <a:p>
+            <a:pPr algn="ctr" indent="0" marL="0">
+              <a:lnSpc>
+                <a:spcPct val="125000"/>
+              </a:lnSpc>
+              <a:buNone/>
+            </a:pPr>
+            <a:r>
+              <a:rPr lang="en-US" sz="1240" b="1" dirty="0">
+                <a:solidFill>
+                  <a:srgbClr val="FFFFFF"/>
+                </a:solidFill>
+                <a:latin typeface="Cambria" pitchFamily="34" charset="0"/>
+                <a:ea typeface="Cambria" pitchFamily="34" charset="-122"/>
+                <a:cs typeface="Cambria" pitchFamily="34" charset="-120"/>
+              </a:rPr>
+              <a:t>UI-Venus</a:t>
+            </a:r>
+            <a:endParaRPr lang="en-US" sz="1240" dirty="0"/>
+          </a:p>
+        </p:txBody>
+      </p:sp>
+      <p:sp>
+        <p:nvSpPr>
+          <p:cNvPr id="9" name="Text 7"/>
+          <p:cNvSpPr/>
+          <p:nvPr/>
+        </p:nvSpPr>
+        <p:spPr>
+          <a:xfrm>
+            <a:off x="5413248" y="1481328"/>
+            <a:ext cx="1417320" cy="512064"/>
+          </a:xfrm>
+          <a:prstGeom prst="rect">
+            <a:avLst/>
+          </a:prstGeom>
+          <a:noFill/>
+          <a:ln/>
+        </p:spPr>
+        <p:txBody>
+          <a:bodyPr wrap="square" lIns="0" tIns="0" rIns="0" bIns="0" rtlCol="0" anchor="ctr">
+            <a:normAutofit/>
+          </a:bodyPr>
+          <a:lstStyle/>
+          <a:p>
+            <a:pPr algn="ctr" indent="0" marL="0">
+              <a:lnSpc>
+                <a:spcPct val="125000"/>
+              </a:lnSpc>
+              <a:buNone/>
+            </a:pPr>
+            <a:r>
+              <a:rPr lang="en-US" sz="1240" b="1" dirty="0">
+                <a:solidFill>
+                  <a:srgbClr val="FFFFFF"/>
+                </a:solidFill>
+                <a:latin typeface="Cambria" pitchFamily="34" charset="0"/>
+                <a:ea typeface="Cambria" pitchFamily="34" charset="-122"/>
+                <a:cs typeface="Cambria" pitchFamily="34" charset="-120"/>
+              </a:rPr>
+              <a:t>Phi-Ground</a:t>
+            </a:r>
+            <a:endParaRPr lang="en-US" sz="1240" dirty="0"/>
+          </a:p>
+        </p:txBody>
+      </p:sp>
+      <p:sp>
+        <p:nvSpPr>
+          <p:cNvPr id="10" name="Text 8"/>
+          <p:cNvSpPr/>
+          <p:nvPr/>
+        </p:nvSpPr>
+        <p:spPr>
+          <a:xfrm>
+            <a:off x="6830568" y="1481328"/>
+            <a:ext cx="1417320" cy="512064"/>
+          </a:xfrm>
+          <a:prstGeom prst="rect">
+            <a:avLst/>
+          </a:prstGeom>
+          <a:noFill/>
+          <a:ln/>
+        </p:spPr>
+        <p:txBody>
+          <a:bodyPr wrap="square" lIns="0" tIns="0" rIns="0" bIns="0" rtlCol="0" anchor="ctr">
+            <a:normAutofit/>
+          </a:bodyPr>
+          <a:lstStyle/>
+          <a:p>
+            <a:pPr algn="ctr" indent="0" marL="0">
+              <a:lnSpc>
+                <a:spcPct val="125000"/>
+              </a:lnSpc>
+              <a:buNone/>
+            </a:pPr>
+            <a:r>
+              <a:rPr lang="en-US" sz="1240" b="1" dirty="0">
+                <a:solidFill>
+                  <a:srgbClr val="FFFFFF"/>
+                </a:solidFill>
+                <a:latin typeface="Cambria" pitchFamily="34" charset="0"/>
+                <a:ea typeface="Cambria" pitchFamily="34" charset="-122"/>
+                <a:cs typeface="Cambria" pitchFamily="34" charset="-120"/>
+              </a:rPr>
+              <a:t>Phi-4</a:t>
+            </a:r>
+            <a:endParaRPr lang="en-US" sz="1240" dirty="0"/>
+          </a:p>
+        </p:txBody>
+      </p:sp>
+      <p:sp>
+        <p:nvSpPr>
+          <p:cNvPr id="11" name="Text 9"/>
+          <p:cNvSpPr/>
+          <p:nvPr/>
+        </p:nvSpPr>
+        <p:spPr>
+          <a:xfrm>
+            <a:off x="566928" y="1993392"/>
+            <a:ext cx="2011680" cy="621792"/>
+          </a:xfrm>
+          <a:prstGeom prst="rect">
+            <a:avLst/>
+          </a:prstGeom>
+          <a:noFill/>
+          <a:ln/>
+        </p:spPr>
+        <p:txBody>
+          <a:bodyPr wrap="square" lIns="0" tIns="0" rIns="0" bIns="0" rtlCol="0" anchor="ctr">
+            <a:normAutofit/>
+          </a:bodyPr>
+          <a:lstStyle/>
+          <a:p>
+            <a:pPr algn="l" indent="0" marL="0">
+              <a:lnSpc>
+                <a:spcPct val="125000"/>
+              </a:lnSpc>
+              <a:buNone/>
+            </a:pPr>
+            <a:r>
+              <a:rPr lang="en-US" sz="1320" dirty="0">
+                <a:solidFill>
+                  <a:srgbClr val="1A1A1A"/>
+                </a:solidFill>
+                <a:latin typeface="Cambria" pitchFamily="34" charset="0"/>
+                <a:ea typeface="Cambria" pitchFamily="34" charset="-122"/>
+                <a:cs typeface="Cambria" pitchFamily="34" charset="-120"/>
+              </a:rPr>
+              <a:t>Base</a:t>
             </a:r>
             <a:endParaRPr lang="en-US" sz="1320" dirty="0"/>
           </a:p>
@@ -13818,43 +14038,43 @@
       </p:sp>
       <p:sp>
         <p:nvSpPr>
-          <p:cNvPr id="7" name="Text 5"/>
-          <p:cNvSpPr/>
-          <p:nvPr/>
-        </p:nvSpPr>
-        <p:spPr>
-          <a:xfrm>
-            <a:off x="3886200" y="1572768"/>
-            <a:ext cx="1828800" cy="502920"/>
-          </a:xfrm>
-          <a:prstGeom prst="rect">
-            <a:avLst/>
-          </a:prstGeom>
-          <a:noFill/>
-          <a:ln/>
-        </p:spPr>
-        <p:txBody>
-          <a:bodyPr wrap="square" lIns="0" tIns="0" rIns="0" bIns="0" rtlCol="0" anchor="ctr">
-            <a:normAutofit/>
-          </a:bodyPr>
-          <a:lstStyle/>
-          <a:p>
-            <a:pPr algn="ctr" indent="0" marL="0">
-              <a:lnSpc>
-                <a:spcPct val="125000"/>
-              </a:lnSpc>
-              <a:buNone/>
-            </a:pPr>
-            <a:r>
-              <a:rPr lang="en-US" sz="1320" b="1" dirty="0">
-                <a:solidFill>
-                  <a:srgbClr val="FFFFFF"/>
-                </a:solidFill>
-                <a:latin typeface="Cambria" pitchFamily="34" charset="0"/>
-                <a:ea typeface="Cambria" pitchFamily="34" charset="-122"/>
-                <a:cs typeface="Cambria" pitchFamily="34" charset="-120"/>
-              </a:rPr>
-              <a:t>GRPO-SPICE − baseline S1</a:t>
+          <p:cNvPr id="12" name="Text 10"/>
+          <p:cNvSpPr/>
+          <p:nvPr/>
+        </p:nvSpPr>
+        <p:spPr>
+          <a:xfrm>
+            <a:off x="2578608" y="1993392"/>
+            <a:ext cx="1417320" cy="621792"/>
+          </a:xfrm>
+          <a:prstGeom prst="rect">
+            <a:avLst/>
+          </a:prstGeom>
+          <a:noFill/>
+          <a:ln/>
+        </p:spPr>
+        <p:txBody>
+          <a:bodyPr wrap="square" lIns="0" tIns="0" rIns="0" bIns="0" rtlCol="0" anchor="ctr">
+            <a:normAutofit/>
+          </a:bodyPr>
+          <a:lstStyle/>
+          <a:p>
+            <a:pPr algn="ctr" indent="0" marL="0">
+              <a:lnSpc>
+                <a:spcPct val="125000"/>
+              </a:lnSpc>
+              <a:buNone/>
+            </a:pPr>
+            <a:r>
+              <a:rPr lang="en-US" sz="1320" dirty="0">
+                <a:solidFill>
+                  <a:srgbClr val="1A1A1A"/>
+                </a:solidFill>
+                <a:latin typeface="Cambria" pitchFamily="34" charset="0"/>
+                <a:ea typeface="Cambria" pitchFamily="34" charset="-122"/>
+                <a:cs typeface="Cambria" pitchFamily="34" charset="-120"/>
+              </a:rPr>
+              <a:t>47,59</a:t>
             </a:r>
             <a:endParaRPr lang="en-US" sz="1320" dirty="0"/>
           </a:p>
@@ -13862,43 +14082,43 @@
       </p:sp>
       <p:sp>
         <p:nvSpPr>
-          <p:cNvPr id="8" name="Text 6"/>
-          <p:cNvSpPr/>
-          <p:nvPr/>
-        </p:nvSpPr>
-        <p:spPr>
-          <a:xfrm>
-            <a:off x="5715000" y="1572768"/>
-            <a:ext cx="2377440" cy="502920"/>
-          </a:xfrm>
-          <a:prstGeom prst="rect">
-            <a:avLst/>
-          </a:prstGeom>
-          <a:noFill/>
-          <a:ln/>
-        </p:spPr>
-        <p:txBody>
-          <a:bodyPr wrap="square" lIns="0" tIns="0" rIns="0" bIns="0" rtlCol="0" anchor="ctr">
-            <a:normAutofit/>
-          </a:bodyPr>
-          <a:lstStyle/>
-          <a:p>
-            <a:pPr algn="ctr" indent="0" marL="0">
-              <a:lnSpc>
-                <a:spcPct val="125000"/>
-              </a:lnSpc>
-              <a:buNone/>
-            </a:pPr>
-            <a:r>
-              <a:rPr lang="en-US" sz="1320" b="1" dirty="0">
-                <a:solidFill>
-                  <a:srgbClr val="FFFFFF"/>
-                </a:solidFill>
-                <a:latin typeface="Cambria" pitchFamily="34" charset="0"/>
-                <a:ea typeface="Cambria" pitchFamily="34" charset="-122"/>
-                <a:cs typeface="Cambria" pitchFamily="34" charset="-120"/>
-              </a:rPr>
-              <a:t>KTC 95%</a:t>
+          <p:cNvPr id="13" name="Text 11"/>
+          <p:cNvSpPr/>
+          <p:nvPr/>
+        </p:nvSpPr>
+        <p:spPr>
+          <a:xfrm>
+            <a:off x="3995928" y="1993392"/>
+            <a:ext cx="1417320" cy="621792"/>
+          </a:xfrm>
+          <a:prstGeom prst="rect">
+            <a:avLst/>
+          </a:prstGeom>
+          <a:noFill/>
+          <a:ln/>
+        </p:spPr>
+        <p:txBody>
+          <a:bodyPr wrap="square" lIns="0" tIns="0" rIns="0" bIns="0" rtlCol="0" anchor="ctr">
+            <a:normAutofit/>
+          </a:bodyPr>
+          <a:lstStyle/>
+          <a:p>
+            <a:pPr algn="ctr" indent="0" marL="0">
+              <a:lnSpc>
+                <a:spcPct val="125000"/>
+              </a:lnSpc>
+              <a:buNone/>
+            </a:pPr>
+            <a:r>
+              <a:rPr lang="en-US" sz="1320" dirty="0">
+                <a:solidFill>
+                  <a:srgbClr val="1A1A1A"/>
+                </a:solidFill>
+                <a:latin typeface="Cambria" pitchFamily="34" charset="0"/>
+                <a:ea typeface="Cambria" pitchFamily="34" charset="-122"/>
+                <a:cs typeface="Cambria" pitchFamily="34" charset="-120"/>
+              </a:rPr>
+              <a:t>—</a:t>
             </a:r>
             <a:endParaRPr lang="en-US" sz="1320" dirty="0"/>
           </a:p>
@@ -13906,35 +14126,35 @@
       </p:sp>
       <p:sp>
         <p:nvSpPr>
-          <p:cNvPr id="9" name="Text 7"/>
-          <p:cNvSpPr/>
-          <p:nvPr/>
-        </p:nvSpPr>
-        <p:spPr>
-          <a:xfrm>
-            <a:off x="1051560" y="2075688"/>
-            <a:ext cx="2834640" cy="621792"/>
-          </a:xfrm>
-          <a:prstGeom prst="rect">
-            <a:avLst/>
-          </a:prstGeom>
-          <a:noFill/>
-          <a:ln/>
-        </p:spPr>
-        <p:txBody>
-          <a:bodyPr wrap="square" lIns="0" tIns="0" rIns="0" bIns="0" rtlCol="0" anchor="ctr">
-            <a:normAutofit/>
-          </a:bodyPr>
-          <a:lstStyle/>
-          <a:p>
-            <a:pPr algn="l" indent="0" marL="0">
-              <a:lnSpc>
-                <a:spcPct val="125000"/>
-              </a:lnSpc>
-              <a:buNone/>
-            </a:pPr>
-            <a:r>
-              <a:rPr lang="en-US" sz="1370" dirty="0">
+          <p:cNvPr id="14" name="Text 12"/>
+          <p:cNvSpPr/>
+          <p:nvPr/>
+        </p:nvSpPr>
+        <p:spPr>
+          <a:xfrm>
+            <a:off x="5413248" y="1993392"/>
+            <a:ext cx="1417320" cy="621792"/>
+          </a:xfrm>
+          <a:prstGeom prst="rect">
+            <a:avLst/>
+          </a:prstGeom>
+          <a:noFill/>
+          <a:ln/>
+        </p:spPr>
+        <p:txBody>
+          <a:bodyPr wrap="square" lIns="0" tIns="0" rIns="0" bIns="0" rtlCol="0" anchor="ctr">
+            <a:normAutofit/>
+          </a:bodyPr>
+          <a:lstStyle/>
+          <a:p>
+            <a:pPr algn="ctr" indent="0" marL="0">
+              <a:lnSpc>
+                <a:spcPct val="125000"/>
+              </a:lnSpc>
+              <a:buNone/>
+            </a:pPr>
+            <a:r>
+              <a:rPr lang="en-US" sz="1320" dirty="0">
                 <a:solidFill>
                   <a:srgbClr val="1A1A1A"/>
                 </a:solidFill>
@@ -13942,87 +14162,43 @@
                 <a:ea typeface="Cambria" pitchFamily="34" charset="-122"/>
                 <a:cs typeface="Cambria" pitchFamily="34" charset="-120"/>
               </a:rPr>
-              <a:t>UGround</a:t>
-            </a:r>
-            <a:endParaRPr lang="en-US" sz="1370" dirty="0"/>
-          </a:p>
-        </p:txBody>
-      </p:sp>
-      <p:sp>
-        <p:nvSpPr>
-          <p:cNvPr id="10" name="Text 8"/>
-          <p:cNvSpPr/>
-          <p:nvPr/>
-        </p:nvSpPr>
-        <p:spPr>
-          <a:xfrm>
-            <a:off x="3886200" y="2075688"/>
-            <a:ext cx="1828800" cy="621792"/>
-          </a:xfrm>
-          <a:prstGeom prst="rect">
-            <a:avLst/>
-          </a:prstGeom>
-          <a:noFill/>
-          <a:ln/>
-        </p:spPr>
-        <p:txBody>
-          <a:bodyPr wrap="square" lIns="0" tIns="0" rIns="0" bIns="0" rtlCol="0" anchor="ctr">
-            <a:normAutofit/>
-          </a:bodyPr>
-          <a:lstStyle/>
-          <a:p>
-            <a:pPr algn="ctr" indent="0" marL="0">
-              <a:lnSpc>
-                <a:spcPct val="125000"/>
-              </a:lnSpc>
-              <a:buNone/>
-            </a:pPr>
-            <a:r>
-              <a:rPr lang="en-US" sz="1370" b="1" dirty="0">
-                <a:solidFill>
-                  <a:srgbClr val="4F417A"/>
-                </a:solidFill>
-                <a:latin typeface="Cambria" pitchFamily="34" charset="0"/>
-                <a:ea typeface="Cambria" pitchFamily="34" charset="-122"/>
-                <a:cs typeface="Cambria" pitchFamily="34" charset="-120"/>
-              </a:rPr>
-              <a:t>+1,55</a:t>
-            </a:r>
-            <a:endParaRPr lang="en-US" sz="1370" dirty="0"/>
-          </a:p>
-        </p:txBody>
-      </p:sp>
-      <p:sp>
-        <p:nvSpPr>
-          <p:cNvPr id="11" name="Text 9"/>
-          <p:cNvSpPr/>
-          <p:nvPr/>
-        </p:nvSpPr>
-        <p:spPr>
-          <a:xfrm>
-            <a:off x="5715000" y="2075688"/>
-            <a:ext cx="2377440" cy="621792"/>
-          </a:xfrm>
-          <a:prstGeom prst="rect">
-            <a:avLst/>
-          </a:prstGeom>
-          <a:noFill/>
-          <a:ln/>
-        </p:spPr>
-        <p:txBody>
-          <a:bodyPr wrap="square" lIns="0" tIns="0" rIns="0" bIns="0" rtlCol="0" anchor="ctr">
-            <a:normAutofit/>
-          </a:bodyPr>
-          <a:lstStyle/>
-          <a:p>
-            <a:pPr algn="ctr" indent="0" marL="0">
-              <a:lnSpc>
-                <a:spcPct val="125000"/>
-              </a:lnSpc>
-              <a:buNone/>
-            </a:pPr>
-            <a:r>
-              <a:rPr lang="en-US" sz="1370" dirty="0">
+              <a:t>40,80</a:t>
+            </a:r>
+            <a:endParaRPr lang="en-US" sz="1320" dirty="0"/>
+          </a:p>
+        </p:txBody>
+      </p:sp>
+      <p:sp>
+        <p:nvSpPr>
+          <p:cNvPr id="15" name="Text 13"/>
+          <p:cNvSpPr/>
+          <p:nvPr/>
+        </p:nvSpPr>
+        <p:spPr>
+          <a:xfrm>
+            <a:off x="6830568" y="1993392"/>
+            <a:ext cx="1417320" cy="621792"/>
+          </a:xfrm>
+          <a:prstGeom prst="rect">
+            <a:avLst/>
+          </a:prstGeom>
+          <a:noFill/>
+          <a:ln/>
+        </p:spPr>
+        <p:txBody>
+          <a:bodyPr wrap="square" lIns="0" tIns="0" rIns="0" bIns="0" rtlCol="0" anchor="ctr">
+            <a:normAutofit/>
+          </a:bodyPr>
+          <a:lstStyle/>
+          <a:p>
+            <a:pPr algn="ctr" indent="0" marL="0">
+              <a:lnSpc>
+                <a:spcPct val="125000"/>
+              </a:lnSpc>
+              <a:buNone/>
+            </a:pPr>
+            <a:r>
+              <a:rPr lang="en-US" sz="1320" dirty="0">
                 <a:solidFill>
                   <a:srgbClr val="1A1A1A"/>
                 </a:solidFill>
@@ -14030,22 +14206,22 @@
                 <a:ea typeface="Cambria" pitchFamily="34" charset="-122"/>
                 <a:cs typeface="Cambria" pitchFamily="34" charset="-120"/>
               </a:rPr>
-              <a:t>[+0,80; +2,33]</a:t>
-            </a:r>
-            <a:endParaRPr lang="en-US" sz="1370" dirty="0"/>
-          </a:p>
-        </p:txBody>
-      </p:sp>
-      <p:sp>
-        <p:nvSpPr>
-          <p:cNvPr id="12" name="Shape 10"/>
-          <p:cNvSpPr/>
-          <p:nvPr/>
-        </p:nvSpPr>
-        <p:spPr>
-          <a:xfrm>
-            <a:off x="1051560" y="2697480"/>
-            <a:ext cx="7040880" cy="0"/>
+              <a:t>38,23</a:t>
+            </a:r>
+            <a:endParaRPr lang="en-US" sz="1320" dirty="0"/>
+          </a:p>
+        </p:txBody>
+      </p:sp>
+      <p:sp>
+        <p:nvSpPr>
+          <p:cNvPr id="16" name="Shape 14"/>
+          <p:cNvSpPr/>
+          <p:nvPr/>
+        </p:nvSpPr>
+        <p:spPr>
+          <a:xfrm>
+            <a:off x="566928" y="2615184"/>
+            <a:ext cx="7680960" cy="0"/>
           </a:xfrm>
           <a:prstGeom prst="line">
             <a:avLst/>
@@ -14062,14 +14238,14 @@
       </p:sp>
       <p:sp>
         <p:nvSpPr>
-          <p:cNvPr id="13" name="Text 11"/>
-          <p:cNvSpPr/>
-          <p:nvPr/>
-        </p:nvSpPr>
-        <p:spPr>
-          <a:xfrm>
-            <a:off x="1051560" y="2697480"/>
-            <a:ext cx="2834640" cy="621792"/>
+          <p:cNvPr id="17" name="Text 15"/>
+          <p:cNvSpPr/>
+          <p:nvPr/>
+        </p:nvSpPr>
+        <p:spPr>
+          <a:xfrm>
+            <a:off x="566928" y="2615184"/>
+            <a:ext cx="2011680" cy="621792"/>
           </a:xfrm>
           <a:prstGeom prst="rect">
             <a:avLst/>
@@ -14090,7 +14266,7 @@
               <a:buNone/>
             </a:pPr>
             <a:r>
-              <a:rPr lang="en-US" sz="1370" dirty="0">
+              <a:rPr lang="en-US" sz="1320" dirty="0">
                 <a:solidFill>
                   <a:srgbClr val="1A1A1A"/>
                 </a:solidFill>
@@ -14098,87 +14274,43 @@
                 <a:ea typeface="Cambria" pitchFamily="34" charset="-122"/>
                 <a:cs typeface="Cambria" pitchFamily="34" charset="-120"/>
               </a:rPr>
-              <a:t>UI-Venus</a:t>
-            </a:r>
-            <a:endParaRPr lang="en-US" sz="1370" dirty="0"/>
-          </a:p>
-        </p:txBody>
-      </p:sp>
-      <p:sp>
-        <p:nvSpPr>
-          <p:cNvPr id="14" name="Text 12"/>
-          <p:cNvSpPr/>
-          <p:nvPr/>
-        </p:nvSpPr>
-        <p:spPr>
-          <a:xfrm>
-            <a:off x="3886200" y="2697480"/>
-            <a:ext cx="1828800" cy="621792"/>
-          </a:xfrm>
-          <a:prstGeom prst="rect">
-            <a:avLst/>
-          </a:prstGeom>
-          <a:noFill/>
-          <a:ln/>
-        </p:spPr>
-        <p:txBody>
-          <a:bodyPr wrap="square" lIns="0" tIns="0" rIns="0" bIns="0" rtlCol="0" anchor="ctr">
-            <a:normAutofit/>
-          </a:bodyPr>
-          <a:lstStyle/>
-          <a:p>
-            <a:pPr algn="ctr" indent="0" marL="0">
-              <a:lnSpc>
-                <a:spcPct val="125000"/>
-              </a:lnSpc>
-              <a:buNone/>
-            </a:pPr>
-            <a:r>
-              <a:rPr lang="en-US" sz="1370" b="1" dirty="0">
-                <a:solidFill>
-                  <a:srgbClr val="4F417A"/>
-                </a:solidFill>
-                <a:latin typeface="Cambria" pitchFamily="34" charset="0"/>
-                <a:ea typeface="Cambria" pitchFamily="34" charset="-122"/>
-                <a:cs typeface="Cambria" pitchFamily="34" charset="-120"/>
-              </a:rPr>
-              <a:t>+1,55</a:t>
-            </a:r>
-            <a:endParaRPr lang="en-US" sz="1370" dirty="0"/>
-          </a:p>
-        </p:txBody>
-      </p:sp>
-      <p:sp>
-        <p:nvSpPr>
-          <p:cNvPr id="15" name="Text 13"/>
-          <p:cNvSpPr/>
-          <p:nvPr/>
-        </p:nvSpPr>
-        <p:spPr>
-          <a:xfrm>
-            <a:off x="5715000" y="2697480"/>
-            <a:ext cx="2377440" cy="621792"/>
-          </a:xfrm>
-          <a:prstGeom prst="rect">
-            <a:avLst/>
-          </a:prstGeom>
-          <a:noFill/>
-          <a:ln/>
-        </p:spPr>
-        <p:txBody>
-          <a:bodyPr wrap="square" lIns="0" tIns="0" rIns="0" bIns="0" rtlCol="0" anchor="ctr">
-            <a:normAutofit/>
-          </a:bodyPr>
-          <a:lstStyle/>
-          <a:p>
-            <a:pPr algn="ctr" indent="0" marL="0">
-              <a:lnSpc>
-                <a:spcPct val="125000"/>
-              </a:lnSpc>
-              <a:buNone/>
-            </a:pPr>
-            <a:r>
-              <a:rPr lang="en-US" sz="1370" dirty="0">
+              <a:t>Baseline S1</a:t>
+            </a:r>
+            <a:endParaRPr lang="en-US" sz="1320" dirty="0"/>
+          </a:p>
+        </p:txBody>
+      </p:sp>
+      <p:sp>
+        <p:nvSpPr>
+          <p:cNvPr id="18" name="Text 16"/>
+          <p:cNvSpPr/>
+          <p:nvPr/>
+        </p:nvSpPr>
+        <p:spPr>
+          <a:xfrm>
+            <a:off x="2578608" y="2615184"/>
+            <a:ext cx="1417320" cy="621792"/>
+          </a:xfrm>
+          <a:prstGeom prst="rect">
+            <a:avLst/>
+          </a:prstGeom>
+          <a:noFill/>
+          <a:ln/>
+        </p:spPr>
+        <p:txBody>
+          <a:bodyPr wrap="square" lIns="0" tIns="0" rIns="0" bIns="0" rtlCol="0" anchor="ctr">
+            <a:normAutofit/>
+          </a:bodyPr>
+          <a:lstStyle/>
+          <a:p>
+            <a:pPr algn="ctr" indent="0" marL="0">
+              <a:lnSpc>
+                <a:spcPct val="125000"/>
+              </a:lnSpc>
+              <a:buNone/>
+            </a:pPr>
+            <a:r>
+              <a:rPr lang="en-US" sz="1320" dirty="0">
                 <a:solidFill>
                   <a:srgbClr val="1A1A1A"/>
                 </a:solidFill>
@@ -14186,22 +14318,154 @@
                 <a:ea typeface="Cambria" pitchFamily="34" charset="-122"/>
                 <a:cs typeface="Cambria" pitchFamily="34" charset="-120"/>
               </a:rPr>
-              <a:t>[+0,82; +2,30]</a:t>
-            </a:r>
-            <a:endParaRPr lang="en-US" sz="1370" dirty="0"/>
-          </a:p>
-        </p:txBody>
-      </p:sp>
-      <p:sp>
-        <p:nvSpPr>
-          <p:cNvPr id="16" name="Shape 14"/>
-          <p:cNvSpPr/>
-          <p:nvPr/>
-        </p:nvSpPr>
-        <p:spPr>
-          <a:xfrm>
-            <a:off x="1051560" y="3319272"/>
-            <a:ext cx="7040880" cy="0"/>
+              <a:t>59,11</a:t>
+            </a:r>
+            <a:endParaRPr lang="en-US" sz="1320" dirty="0"/>
+          </a:p>
+        </p:txBody>
+      </p:sp>
+      <p:sp>
+        <p:nvSpPr>
+          <p:cNvPr id="19" name="Text 17"/>
+          <p:cNvSpPr/>
+          <p:nvPr/>
+        </p:nvSpPr>
+        <p:spPr>
+          <a:xfrm>
+            <a:off x="3995928" y="2615184"/>
+            <a:ext cx="1417320" cy="621792"/>
+          </a:xfrm>
+          <a:prstGeom prst="rect">
+            <a:avLst/>
+          </a:prstGeom>
+          <a:noFill/>
+          <a:ln/>
+        </p:spPr>
+        <p:txBody>
+          <a:bodyPr wrap="square" lIns="0" tIns="0" rIns="0" bIns="0" rtlCol="0" anchor="ctr">
+            <a:normAutofit/>
+          </a:bodyPr>
+          <a:lstStyle/>
+          <a:p>
+            <a:pPr algn="ctr" indent="0" marL="0">
+              <a:lnSpc>
+                <a:spcPct val="125000"/>
+              </a:lnSpc>
+              <a:buNone/>
+            </a:pPr>
+            <a:r>
+              <a:rPr lang="en-US" sz="1320" dirty="0">
+                <a:solidFill>
+                  <a:srgbClr val="1A1A1A"/>
+                </a:solidFill>
+                <a:latin typeface="Cambria" pitchFamily="34" charset="0"/>
+                <a:ea typeface="Cambria" pitchFamily="34" charset="-122"/>
+                <a:cs typeface="Cambria" pitchFamily="34" charset="-120"/>
+              </a:rPr>
+              <a:t>54,51</a:t>
+            </a:r>
+            <a:endParaRPr lang="en-US" sz="1320" dirty="0"/>
+          </a:p>
+        </p:txBody>
+      </p:sp>
+      <p:sp>
+        <p:nvSpPr>
+          <p:cNvPr id="20" name="Text 18"/>
+          <p:cNvSpPr/>
+          <p:nvPr/>
+        </p:nvSpPr>
+        <p:spPr>
+          <a:xfrm>
+            <a:off x="5413248" y="2615184"/>
+            <a:ext cx="1417320" cy="621792"/>
+          </a:xfrm>
+          <a:prstGeom prst="rect">
+            <a:avLst/>
+          </a:prstGeom>
+          <a:noFill/>
+          <a:ln/>
+        </p:spPr>
+        <p:txBody>
+          <a:bodyPr wrap="square" lIns="0" tIns="0" rIns="0" bIns="0" rtlCol="0" anchor="ctr">
+            <a:normAutofit/>
+          </a:bodyPr>
+          <a:lstStyle/>
+          <a:p>
+            <a:pPr algn="ctr" indent="0" marL="0">
+              <a:lnSpc>
+                <a:spcPct val="125000"/>
+              </a:lnSpc>
+              <a:buNone/>
+            </a:pPr>
+            <a:r>
+              <a:rPr lang="en-US" sz="1320" dirty="0">
+                <a:solidFill>
+                  <a:srgbClr val="1A1A1A"/>
+                </a:solidFill>
+                <a:latin typeface="Cambria" pitchFamily="34" charset="0"/>
+                <a:ea typeface="Cambria" pitchFamily="34" charset="-122"/>
+                <a:cs typeface="Cambria" pitchFamily="34" charset="-120"/>
+              </a:rPr>
+              <a:t>46,96</a:t>
+            </a:r>
+            <a:endParaRPr lang="en-US" sz="1320" dirty="0"/>
+          </a:p>
+        </p:txBody>
+      </p:sp>
+      <p:sp>
+        <p:nvSpPr>
+          <p:cNvPr id="21" name="Text 19"/>
+          <p:cNvSpPr/>
+          <p:nvPr/>
+        </p:nvSpPr>
+        <p:spPr>
+          <a:xfrm>
+            <a:off x="6830568" y="2615184"/>
+            <a:ext cx="1417320" cy="621792"/>
+          </a:xfrm>
+          <a:prstGeom prst="rect">
+            <a:avLst/>
+          </a:prstGeom>
+          <a:noFill/>
+          <a:ln/>
+        </p:spPr>
+        <p:txBody>
+          <a:bodyPr wrap="square" lIns="0" tIns="0" rIns="0" bIns="0" rtlCol="0" anchor="ctr">
+            <a:normAutofit/>
+          </a:bodyPr>
+          <a:lstStyle/>
+          <a:p>
+            <a:pPr algn="ctr" indent="0" marL="0">
+              <a:lnSpc>
+                <a:spcPct val="125000"/>
+              </a:lnSpc>
+              <a:buNone/>
+            </a:pPr>
+            <a:r>
+              <a:rPr lang="en-US" sz="1320" dirty="0">
+                <a:solidFill>
+                  <a:srgbClr val="1A1A1A"/>
+                </a:solidFill>
+                <a:latin typeface="Cambria" pitchFamily="34" charset="0"/>
+                <a:ea typeface="Cambria" pitchFamily="34" charset="-122"/>
+                <a:cs typeface="Cambria" pitchFamily="34" charset="-120"/>
+              </a:rPr>
+              <a:t>44,63</a:t>
+            </a:r>
+            <a:endParaRPr lang="en-US" sz="1320" dirty="0"/>
+          </a:p>
+        </p:txBody>
+      </p:sp>
+      <p:sp>
+        <p:nvSpPr>
+          <p:cNvPr id="22" name="Shape 20"/>
+          <p:cNvSpPr/>
+          <p:nvPr/>
+        </p:nvSpPr>
+        <p:spPr>
+          <a:xfrm>
+            <a:off x="566928" y="3236976"/>
+            <a:ext cx="7680960" cy="0"/>
           </a:xfrm>
           <a:prstGeom prst="line">
             <a:avLst/>
@@ -14218,14 +14482,14 @@
       </p:sp>
       <p:sp>
         <p:nvSpPr>
-          <p:cNvPr id="17" name="Text 15"/>
-          <p:cNvSpPr/>
-          <p:nvPr/>
-        </p:nvSpPr>
-        <p:spPr>
-          <a:xfrm>
-            <a:off x="1051560" y="3319272"/>
-            <a:ext cx="2834640" cy="621792"/>
+          <p:cNvPr id="23" name="Text 21"/>
+          <p:cNvSpPr/>
+          <p:nvPr/>
+        </p:nvSpPr>
+        <p:spPr>
+          <a:xfrm>
+            <a:off x="566928" y="3236976"/>
+            <a:ext cx="2011680" cy="658368"/>
           </a:xfrm>
           <a:prstGeom prst="rect">
             <a:avLst/>
@@ -14246,51 +14510,7 @@
               <a:buNone/>
             </a:pPr>
             <a:r>
-              <a:rPr lang="en-US" sz="1370" dirty="0">
-                <a:solidFill>
-                  <a:srgbClr val="1A1A1A"/>
-                </a:solidFill>
-                <a:latin typeface="Cambria" pitchFamily="34" charset="0"/>
-                <a:ea typeface="Cambria" pitchFamily="34" charset="-122"/>
-                <a:cs typeface="Cambria" pitchFamily="34" charset="-120"/>
-              </a:rPr>
-              <a:t>Phi-Ground</a:t>
-            </a:r>
-            <a:endParaRPr lang="en-US" sz="1370" dirty="0"/>
-          </a:p>
-        </p:txBody>
-      </p:sp>
-      <p:sp>
-        <p:nvSpPr>
-          <p:cNvPr id="18" name="Text 16"/>
-          <p:cNvSpPr/>
-          <p:nvPr/>
-        </p:nvSpPr>
-        <p:spPr>
-          <a:xfrm>
-            <a:off x="3886200" y="3319272"/>
-            <a:ext cx="1828800" cy="621792"/>
-          </a:xfrm>
-          <a:prstGeom prst="rect">
-            <a:avLst/>
-          </a:prstGeom>
-          <a:noFill/>
-          <a:ln/>
-        </p:spPr>
-        <p:txBody>
-          <a:bodyPr wrap="square" lIns="0" tIns="0" rIns="0" bIns="0" rtlCol="0" anchor="ctr">
-            <a:normAutofit/>
-          </a:bodyPr>
-          <a:lstStyle/>
-          <a:p>
-            <a:pPr algn="ctr" indent="0" marL="0">
-              <a:lnSpc>
-                <a:spcPct val="125000"/>
-              </a:lnSpc>
-              <a:buNone/>
-            </a:pPr>
-            <a:r>
-              <a:rPr lang="en-US" sz="1370" b="1" dirty="0">
+              <a:rPr lang="en-US" sz="1320" b="1" dirty="0">
                 <a:solidFill>
                   <a:srgbClr val="4F417A"/>
                 </a:solidFill>
@@ -14298,66 +14518,198 @@
                 <a:ea typeface="Cambria" pitchFamily="34" charset="-122"/>
                 <a:cs typeface="Cambria" pitchFamily="34" charset="-120"/>
               </a:rPr>
-              <a:t>+0,78</a:t>
-            </a:r>
-            <a:endParaRPr lang="en-US" sz="1370" dirty="0"/>
-          </a:p>
-        </p:txBody>
-      </p:sp>
-      <p:sp>
-        <p:nvSpPr>
-          <p:cNvPr id="19" name="Text 17"/>
-          <p:cNvSpPr/>
-          <p:nvPr/>
-        </p:nvSpPr>
-        <p:spPr>
-          <a:xfrm>
-            <a:off x="5715000" y="3319272"/>
-            <a:ext cx="2377440" cy="621792"/>
-          </a:xfrm>
-          <a:prstGeom prst="rect">
-            <a:avLst/>
-          </a:prstGeom>
-          <a:noFill/>
-          <a:ln/>
-        </p:spPr>
-        <p:txBody>
-          <a:bodyPr wrap="square" lIns="0" tIns="0" rIns="0" bIns="0" rtlCol="0" anchor="ctr">
-            <a:normAutofit/>
-          </a:bodyPr>
-          <a:lstStyle/>
-          <a:p>
-            <a:pPr algn="ctr" indent="0" marL="0">
-              <a:lnSpc>
-                <a:spcPct val="125000"/>
-              </a:lnSpc>
-              <a:buNone/>
-            </a:pPr>
-            <a:r>
-              <a:rPr lang="en-US" sz="1370" dirty="0">
-                <a:solidFill>
-                  <a:srgbClr val="1A1A1A"/>
-                </a:solidFill>
-                <a:latin typeface="Cambria" pitchFamily="34" charset="0"/>
-                <a:ea typeface="Cambria" pitchFamily="34" charset="-122"/>
-                <a:cs typeface="Cambria" pitchFamily="34" charset="-120"/>
-              </a:rPr>
-              <a:t>[+0,05; +1,51]</a:t>
-            </a:r>
-            <a:endParaRPr lang="en-US" sz="1370" dirty="0"/>
-          </a:p>
-        </p:txBody>
-      </p:sp>
-      <p:sp>
-        <p:nvSpPr>
-          <p:cNvPr id="20" name="Shape 18"/>
-          <p:cNvSpPr/>
-          <p:nvPr/>
-        </p:nvSpPr>
-        <p:spPr>
-          <a:xfrm>
-            <a:off x="1051560" y="3941064"/>
-            <a:ext cx="7040880" cy="0"/>
+              <a:t>GRPO-SPICE</a:t>
+            </a:r>
+            <a:endParaRPr lang="en-US" sz="1320" dirty="0"/>
+          </a:p>
+        </p:txBody>
+      </p:sp>
+      <p:sp>
+        <p:nvSpPr>
+          <p:cNvPr id="24" name="Text 22"/>
+          <p:cNvSpPr/>
+          <p:nvPr/>
+        </p:nvSpPr>
+        <p:spPr>
+          <a:xfrm>
+            <a:off x="2578608" y="3236976"/>
+            <a:ext cx="1417320" cy="658368"/>
+          </a:xfrm>
+          <a:prstGeom prst="rect">
+            <a:avLst/>
+          </a:prstGeom>
+          <a:noFill/>
+          <a:ln/>
+        </p:spPr>
+        <p:txBody>
+          <a:bodyPr wrap="square" lIns="0" tIns="0" rIns="0" bIns="0" rtlCol="0" anchor="ctr">
+            <a:normAutofit/>
+          </a:bodyPr>
+          <a:lstStyle/>
+          <a:p>
+            <a:pPr algn="ctr" indent="0" marL="0">
+              <a:lnSpc>
+                <a:spcPct val="125000"/>
+              </a:lnSpc>
+              <a:buNone/>
+            </a:pPr>
+            <a:r>
+              <a:rPr lang="en-US" sz="1320" b="1" dirty="0">
+                <a:solidFill>
+                  <a:srgbClr val="4F417A"/>
+                </a:solidFill>
+                <a:latin typeface="Cambria" pitchFamily="34" charset="0"/>
+                <a:ea typeface="Cambria" pitchFamily="34" charset="-122"/>
+                <a:cs typeface="Cambria" pitchFamily="34" charset="-120"/>
+              </a:rPr>
+              <a:t>60,65</a:t>
+            </a:r>
+            <a:endParaRPr lang="en-US" sz="1320" dirty="0"/>
+          </a:p>
+        </p:txBody>
+      </p:sp>
+      <p:sp>
+        <p:nvSpPr>
+          <p:cNvPr id="25" name="Text 23"/>
+          <p:cNvSpPr/>
+          <p:nvPr/>
+        </p:nvSpPr>
+        <p:spPr>
+          <a:xfrm>
+            <a:off x="3995928" y="3236976"/>
+            <a:ext cx="1417320" cy="658368"/>
+          </a:xfrm>
+          <a:prstGeom prst="rect">
+            <a:avLst/>
+          </a:prstGeom>
+          <a:noFill/>
+          <a:ln/>
+        </p:spPr>
+        <p:txBody>
+          <a:bodyPr wrap="square" lIns="0" tIns="0" rIns="0" bIns="0" rtlCol="0" anchor="ctr">
+            <a:normAutofit/>
+          </a:bodyPr>
+          <a:lstStyle/>
+          <a:p>
+            <a:pPr algn="ctr" indent="0" marL="0">
+              <a:lnSpc>
+                <a:spcPct val="125000"/>
+              </a:lnSpc>
+              <a:buNone/>
+            </a:pPr>
+            <a:r>
+              <a:rPr lang="en-US" sz="1320" b="1" dirty="0">
+                <a:solidFill>
+                  <a:srgbClr val="4F417A"/>
+                </a:solidFill>
+                <a:latin typeface="Cambria" pitchFamily="34" charset="0"/>
+                <a:ea typeface="Cambria" pitchFamily="34" charset="-122"/>
+                <a:cs typeface="Cambria" pitchFamily="34" charset="-120"/>
+              </a:rPr>
+              <a:t>56,06</a:t>
+            </a:r>
+            <a:endParaRPr lang="en-US" sz="1320" dirty="0"/>
+          </a:p>
+        </p:txBody>
+      </p:sp>
+      <p:sp>
+        <p:nvSpPr>
+          <p:cNvPr id="26" name="Text 24"/>
+          <p:cNvSpPr/>
+          <p:nvPr/>
+        </p:nvSpPr>
+        <p:spPr>
+          <a:xfrm>
+            <a:off x="5413248" y="3236976"/>
+            <a:ext cx="1417320" cy="658368"/>
+          </a:xfrm>
+          <a:prstGeom prst="rect">
+            <a:avLst/>
+          </a:prstGeom>
+          <a:noFill/>
+          <a:ln/>
+        </p:spPr>
+        <p:txBody>
+          <a:bodyPr wrap="square" lIns="0" tIns="0" rIns="0" bIns="0" rtlCol="0" anchor="ctr">
+            <a:normAutofit/>
+          </a:bodyPr>
+          <a:lstStyle/>
+          <a:p>
+            <a:pPr algn="ctr" indent="0" marL="0">
+              <a:lnSpc>
+                <a:spcPct val="125000"/>
+              </a:lnSpc>
+              <a:buNone/>
+            </a:pPr>
+            <a:r>
+              <a:rPr lang="en-US" sz="1320" b="1" dirty="0">
+                <a:solidFill>
+                  <a:srgbClr val="4F417A"/>
+                </a:solidFill>
+                <a:latin typeface="Cambria" pitchFamily="34" charset="0"/>
+                <a:ea typeface="Cambria" pitchFamily="34" charset="-122"/>
+                <a:cs typeface="Cambria" pitchFamily="34" charset="-120"/>
+              </a:rPr>
+              <a:t>47,75</a:t>
+            </a:r>
+            <a:endParaRPr lang="en-US" sz="1320" dirty="0"/>
+          </a:p>
+        </p:txBody>
+      </p:sp>
+      <p:sp>
+        <p:nvSpPr>
+          <p:cNvPr id="27" name="Text 25"/>
+          <p:cNvSpPr/>
+          <p:nvPr/>
+        </p:nvSpPr>
+        <p:spPr>
+          <a:xfrm>
+            <a:off x="6830568" y="3236976"/>
+            <a:ext cx="1417320" cy="658368"/>
+          </a:xfrm>
+          <a:prstGeom prst="rect">
+            <a:avLst/>
+          </a:prstGeom>
+          <a:noFill/>
+          <a:ln/>
+        </p:spPr>
+        <p:txBody>
+          <a:bodyPr wrap="square" lIns="0" tIns="0" rIns="0" bIns="0" rtlCol="0" anchor="ctr">
+            <a:normAutofit/>
+          </a:bodyPr>
+          <a:lstStyle/>
+          <a:p>
+            <a:pPr algn="ctr" indent="0" marL="0">
+              <a:lnSpc>
+                <a:spcPct val="125000"/>
+              </a:lnSpc>
+              <a:buNone/>
+            </a:pPr>
+            <a:r>
+              <a:rPr lang="en-US" sz="1320" b="1" dirty="0">
+                <a:solidFill>
+                  <a:srgbClr val="4F417A"/>
+                </a:solidFill>
+                <a:latin typeface="Cambria" pitchFamily="34" charset="0"/>
+                <a:ea typeface="Cambria" pitchFamily="34" charset="-122"/>
+                <a:cs typeface="Cambria" pitchFamily="34" charset="-120"/>
+              </a:rPr>
+              <a:t>45,33</a:t>
+            </a:r>
+            <a:endParaRPr lang="en-US" sz="1320" dirty="0"/>
+          </a:p>
+        </p:txBody>
+      </p:sp>
+      <p:sp>
+        <p:nvSpPr>
+          <p:cNvPr id="28" name="Shape 26"/>
+          <p:cNvSpPr/>
+          <p:nvPr/>
+        </p:nvSpPr>
+        <p:spPr>
+          <a:xfrm>
+            <a:off x="566928" y="3895344"/>
+            <a:ext cx="7680960" cy="0"/>
           </a:xfrm>
           <a:prstGeom prst="line">
             <a:avLst/>
@@ -14374,14 +14726,14 @@
       </p:sp>
       <p:sp>
         <p:nvSpPr>
-          <p:cNvPr id="21" name="Text 19"/>
-          <p:cNvSpPr/>
-          <p:nvPr/>
-        </p:nvSpPr>
-        <p:spPr>
-          <a:xfrm>
-            <a:off x="1051560" y="3941064"/>
-            <a:ext cx="2834640" cy="621792"/>
+          <p:cNvPr id="29" name="Text 27"/>
+          <p:cNvSpPr/>
+          <p:nvPr/>
+        </p:nvSpPr>
+        <p:spPr>
+          <a:xfrm>
+            <a:off x="566928" y="3895344"/>
+            <a:ext cx="2011680" cy="658368"/>
           </a:xfrm>
           <a:prstGeom prst="rect">
             <a:avLst/>
@@ -14402,7 +14754,7 @@
               <a:buNone/>
             </a:pPr>
             <a:r>
-              <a:rPr lang="en-US" sz="1370" dirty="0">
+              <a:rPr lang="en-US" sz="1320" b="1" dirty="0">
                 <a:solidFill>
                   <a:srgbClr val="1A1A1A"/>
                 </a:solidFill>
@@ -14410,43 +14762,43 @@
                 <a:ea typeface="Cambria" pitchFamily="34" charset="-122"/>
                 <a:cs typeface="Cambria" pitchFamily="34" charset="-120"/>
               </a:rPr>
-              <a:t>Phi-4</a:t>
-            </a:r>
-            <a:endParaRPr lang="en-US" sz="1370" dirty="0"/>
-          </a:p>
-        </p:txBody>
-      </p:sp>
-      <p:sp>
-        <p:nvSpPr>
-          <p:cNvPr id="22" name="Text 20"/>
-          <p:cNvSpPr/>
-          <p:nvPr/>
-        </p:nvSpPr>
-        <p:spPr>
-          <a:xfrm>
-            <a:off x="3886200" y="3941064"/>
-            <a:ext cx="1828800" cy="621792"/>
-          </a:xfrm>
-          <a:prstGeom prst="rect">
-            <a:avLst/>
-          </a:prstGeom>
-          <a:noFill/>
-          <a:ln/>
-        </p:spPr>
-        <p:txBody>
-          <a:bodyPr wrap="square" lIns="0" tIns="0" rIns="0" bIns="0" rtlCol="0" anchor="ctr">
-            <a:normAutofit/>
-          </a:bodyPr>
-          <a:lstStyle/>
-          <a:p>
-            <a:pPr algn="ctr" indent="0" marL="0">
-              <a:lnSpc>
-                <a:spcPct val="125000"/>
-              </a:lnSpc>
-              <a:buNone/>
-            </a:pPr>
-            <a:r>
-              <a:rPr lang="en-US" sz="1370" b="1" dirty="0">
+              <a:t>Δ so với S1</a:t>
+            </a:r>
+            <a:endParaRPr lang="en-US" sz="1320" dirty="0"/>
+          </a:p>
+        </p:txBody>
+      </p:sp>
+      <p:sp>
+        <p:nvSpPr>
+          <p:cNvPr id="30" name="Text 28"/>
+          <p:cNvSpPr/>
+          <p:nvPr/>
+        </p:nvSpPr>
+        <p:spPr>
+          <a:xfrm>
+            <a:off x="2578608" y="3895344"/>
+            <a:ext cx="1417320" cy="658368"/>
+          </a:xfrm>
+          <a:prstGeom prst="rect">
+            <a:avLst/>
+          </a:prstGeom>
+          <a:noFill/>
+          <a:ln/>
+        </p:spPr>
+        <p:txBody>
+          <a:bodyPr wrap="square" lIns="0" tIns="0" rIns="0" bIns="0" rtlCol="0" anchor="ctr">
+            <a:normAutofit/>
+          </a:bodyPr>
+          <a:lstStyle/>
+          <a:p>
+            <a:pPr algn="ctr" indent="0" marL="0">
+              <a:lnSpc>
+                <a:spcPct val="125000"/>
+              </a:lnSpc>
+              <a:buNone/>
+            </a:pPr>
+            <a:r>
+              <a:rPr lang="en-US" sz="1320" b="1" dirty="0">
                 <a:solidFill>
                   <a:srgbClr val="4F417A"/>
                 </a:solidFill>
@@ -14454,112 +14806,175 @@
                 <a:ea typeface="Cambria" pitchFamily="34" charset="-122"/>
                 <a:cs typeface="Cambria" pitchFamily="34" charset="-120"/>
               </a:rPr>
+              <a:t>+1,55</a:t>
+            </a:r>
+            <a:endParaRPr lang="en-US" sz="1320" dirty="0"/>
+          </a:p>
+        </p:txBody>
+      </p:sp>
+      <p:sp>
+        <p:nvSpPr>
+          <p:cNvPr id="31" name="Text 29"/>
+          <p:cNvSpPr/>
+          <p:nvPr/>
+        </p:nvSpPr>
+        <p:spPr>
+          <a:xfrm>
+            <a:off x="3995928" y="3895344"/>
+            <a:ext cx="1417320" cy="658368"/>
+          </a:xfrm>
+          <a:prstGeom prst="rect">
+            <a:avLst/>
+          </a:prstGeom>
+          <a:noFill/>
+          <a:ln/>
+        </p:spPr>
+        <p:txBody>
+          <a:bodyPr wrap="square" lIns="0" tIns="0" rIns="0" bIns="0" rtlCol="0" anchor="ctr">
+            <a:normAutofit/>
+          </a:bodyPr>
+          <a:lstStyle/>
+          <a:p>
+            <a:pPr algn="ctr" indent="0" marL="0">
+              <a:lnSpc>
+                <a:spcPct val="125000"/>
+              </a:lnSpc>
+              <a:buNone/>
+            </a:pPr>
+            <a:r>
+              <a:rPr lang="en-US" sz="1320" b="1" dirty="0">
+                <a:solidFill>
+                  <a:srgbClr val="4F417A"/>
+                </a:solidFill>
+                <a:latin typeface="Cambria" pitchFamily="34" charset="0"/>
+                <a:ea typeface="Cambria" pitchFamily="34" charset="-122"/>
+                <a:cs typeface="Cambria" pitchFamily="34" charset="-120"/>
+              </a:rPr>
+              <a:t>+1,55</a:t>
+            </a:r>
+            <a:endParaRPr lang="en-US" sz="1320" dirty="0"/>
+          </a:p>
+        </p:txBody>
+      </p:sp>
+      <p:sp>
+        <p:nvSpPr>
+          <p:cNvPr id="32" name="Text 30"/>
+          <p:cNvSpPr/>
+          <p:nvPr/>
+        </p:nvSpPr>
+        <p:spPr>
+          <a:xfrm>
+            <a:off x="5413248" y="3895344"/>
+            <a:ext cx="1417320" cy="658368"/>
+          </a:xfrm>
+          <a:prstGeom prst="rect">
+            <a:avLst/>
+          </a:prstGeom>
+          <a:noFill/>
+          <a:ln/>
+        </p:spPr>
+        <p:txBody>
+          <a:bodyPr wrap="square" lIns="0" tIns="0" rIns="0" bIns="0" rtlCol="0" anchor="ctr">
+            <a:normAutofit/>
+          </a:bodyPr>
+          <a:lstStyle/>
+          <a:p>
+            <a:pPr algn="ctr" indent="0" marL="0">
+              <a:lnSpc>
+                <a:spcPct val="125000"/>
+              </a:lnSpc>
+              <a:buNone/>
+            </a:pPr>
+            <a:r>
+              <a:rPr lang="en-US" sz="1320" b="1" dirty="0">
+                <a:solidFill>
+                  <a:srgbClr val="4F417A"/>
+                </a:solidFill>
+                <a:latin typeface="Cambria" pitchFamily="34" charset="0"/>
+                <a:ea typeface="Cambria" pitchFamily="34" charset="-122"/>
+                <a:cs typeface="Cambria" pitchFamily="34" charset="-120"/>
+              </a:rPr>
+              <a:t>+0,78</a:t>
+            </a:r>
+            <a:endParaRPr lang="en-US" sz="1320" dirty="0"/>
+          </a:p>
+        </p:txBody>
+      </p:sp>
+      <p:sp>
+        <p:nvSpPr>
+          <p:cNvPr id="33" name="Text 31"/>
+          <p:cNvSpPr/>
+          <p:nvPr/>
+        </p:nvSpPr>
+        <p:spPr>
+          <a:xfrm>
+            <a:off x="6830568" y="3895344"/>
+            <a:ext cx="1417320" cy="658368"/>
+          </a:xfrm>
+          <a:prstGeom prst="rect">
+            <a:avLst/>
+          </a:prstGeom>
+          <a:noFill/>
+          <a:ln/>
+        </p:spPr>
+        <p:txBody>
+          <a:bodyPr wrap="square" lIns="0" tIns="0" rIns="0" bIns="0" rtlCol="0" anchor="ctr">
+            <a:normAutofit/>
+          </a:bodyPr>
+          <a:lstStyle/>
+          <a:p>
+            <a:pPr algn="ctr" indent="0" marL="0">
+              <a:lnSpc>
+                <a:spcPct val="125000"/>
+              </a:lnSpc>
+              <a:buNone/>
+            </a:pPr>
+            <a:r>
+              <a:rPr lang="en-US" sz="1320" b="1" dirty="0">
+                <a:solidFill>
+                  <a:srgbClr val="4F417A"/>
+                </a:solidFill>
+                <a:latin typeface="Cambria" pitchFamily="34" charset="0"/>
+                <a:ea typeface="Cambria" pitchFamily="34" charset="-122"/>
+                <a:cs typeface="Cambria" pitchFamily="34" charset="-120"/>
+              </a:rPr>
               <a:t>+0,69</a:t>
             </a:r>
-            <a:endParaRPr lang="en-US" sz="1370" dirty="0"/>
-          </a:p>
-        </p:txBody>
-      </p:sp>
-      <p:sp>
-        <p:nvSpPr>
-          <p:cNvPr id="23" name="Text 21"/>
-          <p:cNvSpPr/>
-          <p:nvPr/>
-        </p:nvSpPr>
-        <p:spPr>
-          <a:xfrm>
-            <a:off x="5715000" y="3941064"/>
-            <a:ext cx="2377440" cy="621792"/>
-          </a:xfrm>
-          <a:prstGeom prst="rect">
-            <a:avLst/>
-          </a:prstGeom>
-          <a:noFill/>
-          <a:ln/>
-        </p:spPr>
-        <p:txBody>
-          <a:bodyPr wrap="square" lIns="0" tIns="0" rIns="0" bIns="0" rtlCol="0" anchor="ctr">
-            <a:normAutofit/>
-          </a:bodyPr>
-          <a:lstStyle/>
-          <a:p>
-            <a:pPr algn="ctr" indent="0" marL="0">
-              <a:lnSpc>
-                <a:spcPct val="125000"/>
-              </a:lnSpc>
-              <a:buNone/>
-            </a:pPr>
-            <a:r>
-              <a:rPr lang="en-US" sz="1370" dirty="0">
-                <a:solidFill>
-                  <a:srgbClr val="1A1A1A"/>
-                </a:solidFill>
-                <a:latin typeface="Cambria" pitchFamily="34" charset="0"/>
-                <a:ea typeface="Cambria" pitchFamily="34" charset="-122"/>
-                <a:cs typeface="Cambria" pitchFamily="34" charset="-120"/>
-              </a:rPr>
-              <a:t>[+0,02; +1,40]</a:t>
-            </a:r>
-            <a:endParaRPr lang="en-US" sz="1370" dirty="0"/>
-          </a:p>
-        </p:txBody>
-      </p:sp>
-      <p:sp>
-        <p:nvSpPr>
-          <p:cNvPr id="24" name="Shape 22"/>
-          <p:cNvSpPr/>
-          <p:nvPr/>
-        </p:nvSpPr>
-        <p:spPr>
-          <a:xfrm>
-            <a:off x="1005840" y="4663440"/>
-            <a:ext cx="7132320" cy="768096"/>
-          </a:xfrm>
-          <a:prstGeom prst="roundRect">
-            <a:avLst/>
-          </a:prstGeom>
-          <a:solidFill>
-            <a:srgbClr val="F3F2F5"/>
-          </a:solidFill>
-          <a:ln w="12700">
-            <a:solidFill>
-              <a:srgbClr val="4F417A"/>
-            </a:solidFill>
-            <a:prstDash val="solid"/>
-          </a:ln>
-        </p:spPr>
-      </p:sp>
-      <p:sp>
-        <p:nvSpPr>
-          <p:cNvPr id="25" name="Text 23"/>
-          <p:cNvSpPr/>
-          <p:nvPr/>
-        </p:nvSpPr>
-        <p:spPr>
-          <a:xfrm>
-            <a:off x="1207008" y="4663440"/>
-            <a:ext cx="6729984" cy="768096"/>
-          </a:xfrm>
-          <a:prstGeom prst="rect">
-            <a:avLst/>
-          </a:prstGeom>
-          <a:noFill/>
-          <a:ln/>
-        </p:spPr>
-        <p:txBody>
-          <a:bodyPr wrap="square" lIns="0" tIns="0" rIns="0" bIns="0" rtlCol="0" anchor="ctr">
-            <a:normAutofit/>
-          </a:bodyPr>
-          <a:lstStyle/>
-          <a:p>
-            <a:pPr algn="ctr" indent="0" marL="0">
-              <a:lnSpc>
-                <a:spcPct val="125000"/>
-              </a:lnSpc>
-              <a:buNone/>
-            </a:pPr>
-            <a:r>
-              <a:rPr lang="en-US" sz="1550" b="1" dirty="0">
+            <a:endParaRPr lang="en-US" sz="1320" dirty="0"/>
+          </a:p>
+        </p:txBody>
+      </p:sp>
+      <p:sp>
+        <p:nvSpPr>
+          <p:cNvPr id="34" name="Text 32"/>
+          <p:cNvSpPr/>
+          <p:nvPr/>
+        </p:nvSpPr>
+        <p:spPr>
+          <a:xfrm>
+            <a:off x="502920" y="4846320"/>
+            <a:ext cx="8138160" cy="457200"/>
+          </a:xfrm>
+          <a:prstGeom prst="rect">
+            <a:avLst/>
+          </a:prstGeom>
+          <a:noFill/>
+          <a:ln/>
+        </p:spPr>
+        <p:txBody>
+          <a:bodyPr wrap="square" lIns="0" tIns="0" rIns="0" bIns="0" rtlCol="0" anchor="ctr">
+            <a:normAutofit/>
+          </a:bodyPr>
+          <a:lstStyle/>
+          <a:p>
+            <a:pPr algn="ctr" indent="0" marL="0">
+              <a:lnSpc>
+                <a:spcPct val="125000"/>
+              </a:lnSpc>
+              <a:buNone/>
+            </a:pPr>
+            <a:r>
+              <a:rPr lang="en-US" sz="1320" dirty="0">
                 <a:solidFill>
                   <a:srgbClr val="25194B"/>
                 </a:solidFill>
@@ -14567,15 +14982,15 @@
                 <a:ea typeface="Cambria" pitchFamily="34" charset="-122"/>
                 <a:cs typeface="Cambria" pitchFamily="34" charset="-120"/>
               </a:rPr>
-              <a:t>Cả 4 khoảng tin cậy đều nằm trên 0 → mức tăng không chỉ xuất hiện với một mô hình định vị.</a:t>
-            </a:r>
-            <a:endParaRPr lang="en-US" sz="1550" dirty="0"/>
-          </a:p>
-        </p:txBody>
-      </p:sp>
-      <p:sp>
-        <p:nvSpPr>
-          <p:cNvPr id="26" name="Shape 24"/>
+              <a:t>KTC 95% của bốn mức tăng đều nằm trên 0. Dấu —: chưa có kết quả Base đầy đủ.</a:t>
+            </a:r>
+            <a:endParaRPr lang="en-US" sz="1320" dirty="0"/>
+          </a:p>
+        </p:txBody>
+      </p:sp>
+      <p:sp>
+        <p:nvSpPr>
+          <p:cNvPr id="35" name="Shape 33"/>
           <p:cNvSpPr/>
           <p:nvPr/>
         </p:nvSpPr>
@@ -14602,7 +15017,7 @@
       </p:sp>
       <p:sp>
         <p:nvSpPr>
-          <p:cNvPr id="27" name="Shape 25"/>
+          <p:cNvPr id="36" name="Shape 34"/>
           <p:cNvSpPr/>
           <p:nvPr/>
         </p:nvSpPr>
@@ -14629,7 +15044,7 @@
       </p:sp>
       <p:sp>
         <p:nvSpPr>
-          <p:cNvPr id="28" name="Shape 26"/>
+          <p:cNvPr id="37" name="Shape 35"/>
           <p:cNvSpPr/>
           <p:nvPr/>
         </p:nvSpPr>
@@ -14656,7 +15071,7 @@
       </p:sp>
       <p:sp>
         <p:nvSpPr>
-          <p:cNvPr id="29" name="Shape 27"/>
+          <p:cNvPr id="38" name="Shape 36"/>
           <p:cNvSpPr/>
           <p:nvPr/>
         </p:nvSpPr>
@@ -14683,7 +15098,7 @@
       </p:sp>
       <p:sp>
         <p:nvSpPr>
-          <p:cNvPr id="30" name="Text 28"/>
+          <p:cNvPr id="39" name="Text 37"/>
           <p:cNvSpPr/>
           <p:nvPr/>
         </p:nvSpPr>
@@ -14725,7 +15140,7 @@
       </p:sp>
       <p:sp>
         <p:nvSpPr>
-          <p:cNvPr id="31" name="Text 29"/>
+          <p:cNvPr id="40" name="Text 38"/>
           <p:cNvSpPr/>
           <p:nvPr/>
         </p:nvSpPr>
@@ -14767,7 +15182,7 @@
       </p:sp>
       <p:sp>
         <p:nvSpPr>
-          <p:cNvPr id="32" name="Text 30"/>
+          <p:cNvPr id="41" name="Text 39"/>
           <p:cNvSpPr/>
           <p:nvPr/>
         </p:nvSpPr>
@@ -14809,7 +15224,7 @@
       </p:sp>
       <p:sp>
         <p:nvSpPr>
-          <p:cNvPr id="33" name="Text 31"/>
+          <p:cNvPr id="42" name="Text 40"/>
           <p:cNvSpPr/>
           <p:nvPr/>
         </p:nvSpPr>
@@ -14980,7 +15395,7 @@
               <a:buNone/>
             </a:pPr>
             <a:r>
-              <a:rPr lang="en-US" sz="1630" b="1" dirty="0">
+              <a:rPr lang="en-US" sz="1630" dirty="0">
                 <a:solidFill>
                   <a:srgbClr val="25194B"/>
                 </a:solidFill>
@@ -15265,7 +15680,7 @@
               <a:buNone/>
             </a:pPr>
             <a:r>
-              <a:rPr lang="en-US" sz="1800" b="1" dirty="0">
+              <a:rPr lang="en-US" sz="1800" dirty="0">
                 <a:solidFill>
                   <a:srgbClr val="25194B"/>
                 </a:solidFill>
@@ -15273,7 +15688,7 @@
                 <a:ea typeface="Cambria" pitchFamily="34" charset="-122"/>
                 <a:cs typeface="Cambria" pitchFamily="34" charset="-120"/>
               </a:rPr>
-              <a:t>+1,48 điểm   ·   KTC 95% [+0,54; +2,43]</a:t>
+              <a:t>+1,48 điểm · KTC 95% từ +0,54 đến +2,43</a:t>
             </a:r>
             <a:endParaRPr lang="en-US" sz="1800" dirty="0"/>
           </a:p>
@@ -15309,7 +15724,7 @@
               <a:buNone/>
             </a:pPr>
             <a:r>
-              <a:rPr lang="en-US" sz="1380" b="1" dirty="0">
+              <a:rPr lang="en-US" sz="1380" dirty="0">
                 <a:solidFill>
                   <a:srgbClr val="25194B"/>
                 </a:solidFill>
@@ -15732,7 +16147,7 @@
               <a:buNone/>
             </a:pPr>
             <a:r>
-              <a:rPr lang="en-US" sz="1600" b="1" dirty="0">
+              <a:rPr lang="en-US" sz="1600" dirty="0">
                 <a:solidFill>
                   <a:srgbClr val="25194B"/>
                 </a:solidFill>
@@ -15874,7 +16289,7 @@
               <a:buNone/>
             </a:pPr>
             <a:r>
-              <a:rPr lang="en-US" sz="1420" b="1" dirty="0">
+              <a:rPr lang="en-US" sz="1420" dirty="0">
                 <a:solidFill>
                   <a:srgbClr val="7A7099"/>
                 </a:solidFill>
@@ -16158,7 +16573,7 @@
               <a:buNone/>
             </a:pPr>
             <a:r>
-              <a:rPr lang="en-US" sz="1420" b="1" dirty="0">
+              <a:rPr lang="en-US" sz="1420" dirty="0">
                 <a:solidFill>
                   <a:srgbClr val="4F417A"/>
                 </a:solidFill>
@@ -16457,7 +16872,7 @@
                 <a:ea typeface="Cambria" pitchFamily="34" charset="-122"/>
                 <a:cs typeface="Cambria" pitchFamily="34" charset="-120"/>
               </a:rPr>
-              <a:t>[+1,51; +5,03]</a:t>
+              <a:t>KTC +1,51 đến +5,03</a:t>
             </a:r>
             <a:endParaRPr lang="en-US" sz="1260" dirty="0"/>
           </a:p>
@@ -16613,7 +17028,7 @@
                 <a:ea typeface="Cambria" pitchFamily="34" charset="-122"/>
                 <a:cs typeface="Cambria" pitchFamily="34" charset="-120"/>
               </a:rPr>
-              <a:t>[−1,39; +0,36]</a:t>
+              <a:t>KTC −1,39 đến +0,36</a:t>
             </a:r>
             <a:endParaRPr lang="en-US" sz="1260" dirty="0"/>
           </a:p>
@@ -16649,7 +17064,7 @@
               <a:buNone/>
             </a:pPr>
             <a:r>
-              <a:rPr lang="en-US" sz="1350" b="1" dirty="0">
+              <a:rPr lang="en-US" sz="1350" dirty="0">
                 <a:solidFill>
                   <a:srgbClr val="25194B"/>
                 </a:solidFill>
@@ -16657,7 +17072,7 @@
                 <a:ea typeface="Cambria" pitchFamily="34" charset="-122"/>
                 <a:cs typeface="Cambria" pitchFamily="34" charset="-120"/>
               </a:rPr>
-              <a:t>S1 vẫn cao hơn Base; GRPO-SPICE không khác rõ S1 về executability.</a:t>
+              <a:t>S1 vẫn cao hơn Base. GRPO-SPICE không khác rõ S1 về executability.</a:t>
             </a:r>
             <a:endParaRPr lang="en-US" sz="1350" dirty="0"/>
           </a:p>
@@ -17826,7 +18241,7 @@
               <a:buNone/>
             </a:pPr>
             <a:r>
-              <a:rPr lang="en-US" sz="1450" b="1" dirty="0">
+              <a:rPr lang="en-US" sz="1450" dirty="0">
                 <a:solidFill>
                   <a:srgbClr val="25194B"/>
                 </a:solidFill>
@@ -18646,7 +19061,7 @@
               <a:buNone/>
             </a:pPr>
             <a:r>
-              <a:rPr lang="en-US" sz="1380" b="1" dirty="0">
+              <a:rPr lang="en-US" sz="1380" dirty="0">
                 <a:solidFill>
                   <a:srgbClr val="25194B"/>
                 </a:solidFill>
@@ -19069,7 +19484,7 @@
               <a:buNone/>
             </a:pPr>
             <a:r>
-              <a:rPr lang="en-US" sz="1600" b="1" dirty="0">
+              <a:rPr lang="en-US" sz="1600" dirty="0">
                 <a:solidFill>
                   <a:srgbClr val="25194B"/>
                 </a:solidFill>
@@ -19077,7 +19492,7 @@
                 <a:ea typeface="Cambria" pitchFamily="34" charset="-122"/>
                 <a:cs typeface="Cambria" pitchFamily="34" charset="-120"/>
               </a:rPr>
-              <a:t>GRPO-SPICE cao hơn baseline S1 ở cả hai seed, nhưng độ lớn mức tăng thay đổi theo seed.</a:t>
+              <a:t>GRPO-SPICE cao hơn baseline S1 ở cả hai seed. Độ lớn mức tăng thay đổi theo seed.</a:t>
             </a:r>
             <a:endParaRPr lang="en-US" sz="1600" dirty="0"/>
           </a:p>
@@ -19516,9 +19931,9 @@
               <a:buNone/>
             </a:pPr>
             <a:r>
-              <a:rPr lang="en-US" sz="1400" b="1" dirty="0">
-                <a:solidFill>
-                  <a:srgbClr val="4F417A"/>
+              <a:rPr lang="en-US" sz="1400" dirty="0">
+                <a:solidFill>
+                  <a:srgbClr val="1A1A1A"/>
                 </a:solidFill>
                 <a:latin typeface="Cambria" pitchFamily="34" charset="0"/>
                 <a:ea typeface="Cambria" pitchFamily="34" charset="-122"/>
@@ -19648,9 +20063,9 @@
               <a:buNone/>
             </a:pPr>
             <a:r>
-              <a:rPr lang="en-US" sz="1400" b="1" dirty="0">
-                <a:solidFill>
-                  <a:srgbClr val="4F417A"/>
+              <a:rPr lang="en-US" sz="1400" dirty="0">
+                <a:solidFill>
+                  <a:srgbClr val="1A1A1A"/>
                 </a:solidFill>
                 <a:latin typeface="Cambria" pitchFamily="34" charset="0"/>
                 <a:ea typeface="Cambria" pitchFamily="34" charset="-122"/>
@@ -19716,7 +20131,7 @@
               <a:buNone/>
             </a:pPr>
             <a:r>
-              <a:rPr lang="en-US" sz="1420" b="1" dirty="0">
+              <a:rPr lang="en-US" sz="1420" dirty="0">
                 <a:solidFill>
                   <a:srgbClr val="1A1A1A"/>
                 </a:solidFill>
@@ -19917,7 +20332,7 @@
               <a:buNone/>
             </a:pPr>
             <a:r>
-              <a:rPr lang="en-US" sz="1530" b="1" dirty="0">
+              <a:rPr lang="en-US" sz="1530" dirty="0">
                 <a:solidFill>
                   <a:srgbClr val="25194B"/>
                 </a:solidFill>
@@ -19925,7 +20340,7 @@
                 <a:ea typeface="Cambria" pitchFamily="34" charset="-122"/>
                 <a:cs typeface="Cambria" pitchFamily="34" charset="-120"/>
               </a:rPr>
-              <a:t>Cả hai seed đều cùng hướng so với baseline S1; seed thứ hai cho mức tăng nhỏ hơn.</a:t>
+              <a:t>Cả hai seed đều cùng hướng so với baseline S1. Seed thứ hai cho mức tăng nhỏ hơn.</a:t>
             </a:r>
             <a:endParaRPr lang="en-US" sz="1530" dirty="0"/>
           </a:p>
@@ -21493,7 +21908,7 @@
               <a:buNone/>
             </a:pPr>
             <a:r>
-              <a:rPr lang="en-US" sz="1550" b="1" dirty="0">
+              <a:rPr lang="en-US" sz="1550" dirty="0">
                 <a:solidFill>
                   <a:srgbClr val="25194B"/>
                 </a:solidFill>
@@ -21958,7 +22373,7 @@
               <a:buNone/>
             </a:pPr>
             <a:r>
-              <a:rPr lang="en-US" sz="1250" b="1" dirty="0">
+              <a:rPr lang="en-US" sz="1250" dirty="0">
                 <a:solidFill>
                   <a:srgbClr val="1A1A1A"/>
                 </a:solidFill>
@@ -22044,7 +22459,7 @@
               <a:buNone/>
             </a:pPr>
             <a:r>
-              <a:rPr lang="en-US" sz="1250" b="1" dirty="0">
+              <a:rPr lang="en-US" sz="1250" dirty="0">
                 <a:solidFill>
                   <a:srgbClr val="1A1A1A"/>
                 </a:solidFill>
@@ -22130,7 +22545,7 @@
               <a:buNone/>
             </a:pPr>
             <a:r>
-              <a:rPr lang="en-US" sz="1250" b="1" dirty="0">
+              <a:rPr lang="en-US" sz="1250" dirty="0">
                 <a:solidFill>
                   <a:srgbClr val="1A1A1A"/>
                 </a:solidFill>
@@ -23154,7 +23569,7 @@
                 <a:ea typeface="Cambria" pitchFamily="34" charset="-122"/>
                 <a:cs typeface="Cambria" pitchFamily="34" charset="-120"/>
               </a:rPr>
-              <a:t>|px−gx| ≤ 0,14W; |py−gy| ≤ 0,14H.</a:t>
+              <a:t>|px−gx| ≤ 0,14W và |py−gy| ≤ 0,14H.</a:t>
             </a:r>
             <a:endParaRPr lang="en-US" sz="1550" dirty="0"/>
           </a:p>
@@ -27483,7 +27898,7 @@
                 <a:ea typeface="Cambria" pitchFamily="34" charset="-122"/>
                 <a:cs typeface="Cambria" pitchFamily="34" charset="-120"/>
               </a:rPr>
-              <a:t>[+0,80; +2,33]</a:t>
+              <a:t>+0,80 đến +2,33</a:t>
             </a:r>
             <a:endParaRPr lang="en-US" sz="1300" dirty="0"/>
           </a:p>
@@ -27639,7 +28054,7 @@
                 <a:ea typeface="Cambria" pitchFamily="34" charset="-122"/>
                 <a:cs typeface="Cambria" pitchFamily="34" charset="-120"/>
               </a:rPr>
-              <a:t>[+0,82; +2,30]</a:t>
+              <a:t>+0,82 đến +2,30</a:t>
             </a:r>
             <a:endParaRPr lang="en-US" sz="1300" dirty="0"/>
           </a:p>
@@ -27795,7 +28210,7 @@
                 <a:ea typeface="Cambria" pitchFamily="34" charset="-122"/>
                 <a:cs typeface="Cambria" pitchFamily="34" charset="-120"/>
               </a:rPr>
-              <a:t>[+0,05; +1,51]</a:t>
+              <a:t>+0,05 đến +1,51</a:t>
             </a:r>
             <a:endParaRPr lang="en-US" sz="1300" dirty="0"/>
           </a:p>
@@ -27951,7 +28366,7 @@
                 <a:ea typeface="Cambria" pitchFamily="34" charset="-122"/>
                 <a:cs typeface="Cambria" pitchFamily="34" charset="-120"/>
               </a:rPr>
-              <a:t>[+0,02; +1,40]</a:t>
+              <a:t>+0,02 đến +1,40</a:t>
             </a:r>
             <a:endParaRPr lang="en-US" sz="1300" dirty="0"/>
           </a:p>
@@ -29766,7 +30181,7 @@
               <a:buNone/>
             </a:pPr>
             <a:r>
-              <a:rPr lang="en-US" sz="1550" b="1" dirty="0">
+              <a:rPr lang="en-US" sz="1550" dirty="0">
                 <a:solidFill>
                   <a:srgbClr val="25194B"/>
                 </a:solidFill>
@@ -30912,7 +31327,7 @@
                 <a:ea typeface="Cambria" pitchFamily="34" charset="-122"/>
                 <a:cs typeface="Cambria" pitchFamily="34" charset="-120"/>
               </a:rPr>
-              <a:t>Khi thực sự chọn, chất lượng khá tốt; vấn đề nằm ở quyết định từ chối chọn.</a:t>
+              <a:t>Khi thực sự chọn, chất lượng khá tốt. Vấn đề nằm ở quyết định từ chối chọn.</a:t>
             </a:r>
             <a:endParaRPr lang="en-US" sz="1210" dirty="0"/>
           </a:p>
@@ -31068,7 +31483,7 @@
                 <a:ea typeface="Cambria" pitchFamily="34" charset="-122"/>
                 <a:cs typeface="Cambria" pitchFamily="34" charset="-120"/>
               </a:rPr>
-              <a:t>Bộ biên tập có ích khi vùng cắt đúng; khâu chọn vùng còn là điểm cần cải thiện.</a:t>
+              <a:t>Bộ biên tập có ích khi vùng cắt đúng. Khâu chọn vùng còn là điểm cần cải thiện.</a:t>
             </a:r>
             <a:endParaRPr lang="en-US" sz="1210" dirty="0"/>
           </a:p>
@@ -31870,7 +32285,7 @@
               <a:buNone/>
             </a:pPr>
             <a:r>
-              <a:rPr lang="en-US" sz="1600" b="1" dirty="0">
+              <a:rPr lang="en-US" sz="1600" dirty="0">
                 <a:solidFill>
                   <a:srgbClr val="25194B"/>
                 </a:solidFill>
@@ -32670,7 +33085,7 @@
               <a:buNone/>
             </a:pPr>
             <a:r>
-              <a:rPr lang="en-US" sz="1250" b="1" dirty="0">
+              <a:rPr lang="en-US" sz="1250" dirty="0">
                 <a:solidFill>
                   <a:srgbClr val="1A1A1A"/>
                 </a:solidFill>
@@ -32756,7 +33171,7 @@
               <a:buNone/>
             </a:pPr>
             <a:r>
-              <a:rPr lang="en-US" sz="1250" b="1" dirty="0">
+              <a:rPr lang="en-US" sz="1250" dirty="0">
                 <a:solidFill>
                   <a:srgbClr val="1A1A1A"/>
                 </a:solidFill>
@@ -32842,7 +33257,7 @@
               <a:buNone/>
             </a:pPr>
             <a:r>
-              <a:rPr lang="en-US" sz="1250" b="1" dirty="0">
+              <a:rPr lang="en-US" sz="1250" dirty="0">
                 <a:solidFill>
                   <a:srgbClr val="1A1A1A"/>
                 </a:solidFill>
@@ -33273,7 +33688,7 @@
                 <a:ea typeface="Cambria" pitchFamily="34" charset="-122"/>
                 <a:cs typeface="Cambria" pitchFamily="34" charset="-120"/>
               </a:rPr>
-              <a:t>Tập huấn luyện và tập kiểm tra chính được tách theo tác vụ; không có tác vụ xuất hiện ở cả hai phía.</a:t>
+              <a:t>Tập huấn luyện và tập kiểm tra chính được tách theo tác vụ. Không có tác vụ xuất hiện ở cả hai phía.</a:t>
             </a:r>
             <a:endParaRPr lang="en-US" sz="1650" dirty="0"/>
           </a:p>
@@ -35790,7 +36205,7 @@
               <a:buNone/>
             </a:pPr>
             <a:r>
-              <a:rPr lang="en-US" sz="1600" b="1" dirty="0">
+              <a:rPr lang="en-US" sz="1600" dirty="0">
                 <a:solidFill>
                   <a:srgbClr val="25194B"/>
                 </a:solidFill>
@@ -36074,7 +36489,7 @@
               <a:buNone/>
             </a:pPr>
             <a:r>
-              <a:rPr lang="en-US" sz="1420" b="1" dirty="0">
+              <a:rPr lang="en-US" sz="1420" dirty="0">
                 <a:solidFill>
                   <a:srgbClr val="4F417A"/>
                 </a:solidFill>
@@ -36216,7 +36631,7 @@
               <a:buNone/>
             </a:pPr>
             <a:r>
-              <a:rPr lang="en-US" sz="1420" b="1" dirty="0">
+              <a:rPr lang="en-US" sz="1420" dirty="0">
                 <a:solidFill>
                   <a:srgbClr val="7A7099"/>
                 </a:solidFill>
@@ -37504,7 +37919,7 @@
               <a:buNone/>
             </a:pPr>
             <a:r>
-              <a:rPr lang="en-US" sz="1420" b="1" dirty="0">
+              <a:rPr lang="en-US" sz="1420" dirty="0">
                 <a:solidFill>
                   <a:srgbClr val="25194B"/>
                 </a:solidFill>
@@ -37512,7 +37927,7 @@
                 <a:ea typeface="Cambria" pitchFamily="34" charset="-122"/>
                 <a:cs typeface="Cambria" pitchFamily="34" charset="-120"/>
               </a:rPr>
-              <a:t>Mô hình định vị chỉ được dùng để đánh giá câu hướng dẫn; không tham gia sinh câu hay cập nhật mô hình.</a:t>
+              <a:t>Mô hình định vị chỉ được dùng để đánh giá câu hướng dẫn. Mô hình này không tham gia sinh câu hay cập nhật mô hình.</a:t>
             </a:r>
             <a:endParaRPr lang="en-US" sz="1420" dirty="0"/>
           </a:p>

</xml_diff>